<commit_message>
Update research-revolution transition language
</commit_message>
<xml_diff>
--- a/reference/archie/presentations/NPQG Fundamentals - Action.pptx
+++ b/reference/archie/presentations/NPQG Fundamentals - Action.pptx
@@ -3,28 +3,26 @@
 <p:presentation xmlns:a="http://schemas.openxmlformats.org/drawingml/2006/main" xmlns:r="http://schemas.openxmlformats.org/officeDocument/2006/relationships" xmlns:p="http://schemas.openxmlformats.org/presentationml/2006/main" saveSubsetFonts="1" autoCompressPictures="0">
   <p:sldMasterIdLst>
     <p:sldMasterId id="2147483648" r:id="rId1"/>
-    <p:sldMasterId id="2147483664" r:id="rId2"/>
   </p:sldMasterIdLst>
   <p:notesMasterIdLst>
-    <p:notesMasterId r:id="rId19"/>
+    <p:notesMasterId r:id="rId17"/>
   </p:notesMasterIdLst>
   <p:sldIdLst>
-    <p:sldId id="884" r:id="rId3"/>
-    <p:sldId id="808" r:id="rId4"/>
-    <p:sldId id="382" r:id="rId5"/>
-    <p:sldId id="842" r:id="rId6"/>
-    <p:sldId id="819" r:id="rId7"/>
-    <p:sldId id="844" r:id="rId8"/>
-    <p:sldId id="757" r:id="rId9"/>
-    <p:sldId id="820" r:id="rId10"/>
-    <p:sldId id="821" r:id="rId11"/>
-    <p:sldId id="809" r:id="rId12"/>
-    <p:sldId id="839" r:id="rId13"/>
-    <p:sldId id="840" r:id="rId14"/>
-    <p:sldId id="817" r:id="rId15"/>
-    <p:sldId id="816" r:id="rId16"/>
-    <p:sldId id="815" r:id="rId17"/>
-    <p:sldId id="843" r:id="rId18"/>
+    <p:sldId id="884" r:id="rId2"/>
+    <p:sldId id="808" r:id="rId3"/>
+    <p:sldId id="842" r:id="rId4"/>
+    <p:sldId id="819" r:id="rId5"/>
+    <p:sldId id="844" r:id="rId6"/>
+    <p:sldId id="757" r:id="rId7"/>
+    <p:sldId id="820" r:id="rId8"/>
+    <p:sldId id="821" r:id="rId9"/>
+    <p:sldId id="809" r:id="rId10"/>
+    <p:sldId id="839" r:id="rId11"/>
+    <p:sldId id="840" r:id="rId12"/>
+    <p:sldId id="817" r:id="rId13"/>
+    <p:sldId id="816" r:id="rId14"/>
+    <p:sldId id="815" r:id="rId15"/>
+    <p:sldId id="843" r:id="rId16"/>
   </p:sldIdLst>
   <p:sldSz cx="12192000" cy="6858000"/>
   <p:notesSz cx="6858000" cy="9144000"/>
@@ -3027,7 +3025,7 @@
           <a:p>
             <a:fld id="{BBBDA440-6FDE-5E41-BA40-A3C0E02BAB9F}" type="datetimeFigureOut">
               <a:rPr lang="en-US" smtClean="0"/>
-              <a:t>3/14/26</a:t>
+              <a:t>7/3/26</a:t>
             </a:fld>
             <a:endParaRPr lang="en-US"/>
           </a:p>
@@ -3982,7 +3980,7 @@
                 <a:tabLst/>
                 <a:defRPr/>
               </a:pPr>
-              <a:t>4</a:t>
+              <a:t>3</a:t>
             </a:fld>
             <a:endParaRPr kumimoji="0" lang="en-US" sz="1200" b="0" i="0" u="none" strike="noStrike" kern="1200" cap="none" spc="0" normalizeH="0" baseline="0" noProof="0">
               <a:ln>
@@ -4126,7 +4124,7 @@
                 <a:tabLst/>
                 <a:defRPr/>
               </a:pPr>
-              <a:t>10</a:t>
+              <a:t>9</a:t>
             </a:fld>
             <a:endParaRPr kumimoji="0" lang="en-US" sz="1200" b="0" i="0" u="none" strike="noStrike" kern="1200" cap="none" spc="0" normalizeH="0" baseline="0" noProof="0">
               <a:ln>
@@ -4330,7 +4328,7 @@
                 <a:tabLst/>
                 <a:defRPr/>
               </a:pPr>
-              <a:t>13</a:t>
+              <a:t>12</a:t>
             </a:fld>
             <a:endParaRPr kumimoji="0" lang="en-US" sz="1200" b="0" i="0" u="none" strike="noStrike" kern="1200" cap="none" spc="0" normalizeH="0" baseline="0" noProof="0">
               <a:ln>
@@ -4474,7 +4472,7 @@
                 <a:tabLst/>
                 <a:defRPr/>
               </a:pPr>
-              <a:t>14</a:t>
+              <a:t>13</a:t>
             </a:fld>
             <a:endParaRPr kumimoji="0" lang="en-US" sz="1200" b="0" i="0" u="none" strike="noStrike" kern="1200" cap="none" spc="0" normalizeH="0" baseline="0" noProof="0">
               <a:ln>
@@ -4618,7 +4616,7 @@
                 <a:tabLst/>
                 <a:defRPr/>
               </a:pPr>
-              <a:t>15</a:t>
+              <a:t>14</a:t>
             </a:fld>
             <a:endParaRPr kumimoji="0" lang="en-US" sz="1200" b="0" i="0" u="none" strike="noStrike" kern="1200" cap="none" spc="0" normalizeH="0" baseline="0" noProof="0">
               <a:ln>
@@ -4797,7 +4795,7 @@
           <a:p>
             <a:fld id="{CB70D3E6-D921-5B44-AC8D-B7FDAFC8A532}" type="datetimeFigureOut">
               <a:rPr lang="en-US" smtClean="0"/>
-              <a:t>3/14/26</a:t>
+              <a:t>7/3/26</a:t>
             </a:fld>
             <a:endParaRPr lang="en-US"/>
           </a:p>
@@ -4995,7 +4993,7 @@
           <a:p>
             <a:fld id="{CB70D3E6-D921-5B44-AC8D-B7FDAFC8A532}" type="datetimeFigureOut">
               <a:rPr lang="en-US" smtClean="0"/>
-              <a:t>3/14/26</a:t>
+              <a:t>7/3/26</a:t>
             </a:fld>
             <a:endParaRPr lang="en-US"/>
           </a:p>
@@ -5203,7 +5201,7 @@
           <a:p>
             <a:fld id="{CB70D3E6-D921-5B44-AC8D-B7FDAFC8A532}" type="datetimeFigureOut">
               <a:rPr lang="en-US" smtClean="0"/>
-              <a:t>3/14/26</a:t>
+              <a:t>7/3/26</a:t>
             </a:fld>
             <a:endParaRPr lang="en-US"/>
           </a:p>
@@ -5276,597 +5274,6 @@
 </p:sldLayout>
 </file>
 
-<file path=ppt/slideLayouts/slideLayout12.xml><?xml version="1.0" encoding="utf-8"?>
-<p:sldLayout xmlns:a="http://schemas.openxmlformats.org/drawingml/2006/main" xmlns:r="http://schemas.openxmlformats.org/officeDocument/2006/relationships" xmlns:p="http://schemas.openxmlformats.org/presentationml/2006/main" type="title" preserve="1">
-  <p:cSld name="Title Slide">
-    <p:spTree>
-      <p:nvGrpSpPr>
-        <p:cNvPr id="1" name=""/>
-        <p:cNvGrpSpPr/>
-        <p:nvPr/>
-      </p:nvGrpSpPr>
-      <p:grpSpPr>
-        <a:xfrm>
-          <a:off x="0" y="0"/>
-          <a:ext cx="0" cy="0"/>
-          <a:chOff x="0" y="0"/>
-          <a:chExt cx="0" cy="0"/>
-        </a:xfrm>
-      </p:grpSpPr>
-      <p:sp>
-        <p:nvSpPr>
-          <p:cNvPr id="2" name="Title 1">
-            <a:extLst>
-              <a:ext uri="{FF2B5EF4-FFF2-40B4-BE49-F238E27FC236}">
-                <a16:creationId xmlns:a16="http://schemas.microsoft.com/office/drawing/2014/main" id="{08FC2668-EBEB-AE41-BF76-89062B014B13}"/>
-              </a:ext>
-            </a:extLst>
-          </p:cNvPr>
-          <p:cNvSpPr>
-            <a:spLocks noGrp="1"/>
-          </p:cNvSpPr>
-          <p:nvPr>
-            <p:ph type="ctrTitle"/>
-          </p:nvPr>
-        </p:nvSpPr>
-        <p:spPr>
-          <a:xfrm>
-            <a:off x="1524000" y="1122363"/>
-            <a:ext cx="9144000" cy="2387600"/>
-          </a:xfrm>
-        </p:spPr>
-        <p:txBody>
-          <a:bodyPr anchor="b"/>
-          <a:lstStyle>
-            <a:lvl1pPr algn="ctr">
-              <a:defRPr sz="6000"/>
-            </a:lvl1pPr>
-          </a:lstStyle>
-          <a:p>
-            <a:r>
-              <a:rPr lang="en-US" dirty="0"/>
-              <a:t>Click to edit Master title style</a:t>
-            </a:r>
-          </a:p>
-        </p:txBody>
-      </p:sp>
-      <p:sp>
-        <p:nvSpPr>
-          <p:cNvPr id="3" name="Subtitle 2">
-            <a:extLst>
-              <a:ext uri="{FF2B5EF4-FFF2-40B4-BE49-F238E27FC236}">
-                <a16:creationId xmlns:a16="http://schemas.microsoft.com/office/drawing/2014/main" id="{C8C28A4C-0805-8E44-B54E-3B6F671F8D01}"/>
-              </a:ext>
-            </a:extLst>
-          </p:cNvPr>
-          <p:cNvSpPr>
-            <a:spLocks noGrp="1"/>
-          </p:cNvSpPr>
-          <p:nvPr>
-            <p:ph type="subTitle" idx="1"/>
-          </p:nvPr>
-        </p:nvSpPr>
-        <p:spPr>
-          <a:xfrm>
-            <a:off x="1524000" y="3602038"/>
-            <a:ext cx="9144000" cy="1655762"/>
-          </a:xfrm>
-        </p:spPr>
-        <p:txBody>
-          <a:bodyPr/>
-          <a:lstStyle>
-            <a:lvl1pPr marL="0" indent="0" algn="ctr">
-              <a:buNone/>
-              <a:defRPr sz="2400"/>
-            </a:lvl1pPr>
-            <a:lvl2pPr marL="457200" indent="0" algn="ctr">
-              <a:buNone/>
-              <a:defRPr sz="2000"/>
-            </a:lvl2pPr>
-            <a:lvl3pPr marL="914400" indent="0" algn="ctr">
-              <a:buNone/>
-              <a:defRPr sz="1800"/>
-            </a:lvl3pPr>
-            <a:lvl4pPr marL="1371600" indent="0" algn="ctr">
-              <a:buNone/>
-              <a:defRPr sz="1600"/>
-            </a:lvl4pPr>
-            <a:lvl5pPr marL="1828800" indent="0" algn="ctr">
-              <a:buNone/>
-              <a:defRPr sz="1600"/>
-            </a:lvl5pPr>
-            <a:lvl6pPr marL="2286000" indent="0" algn="ctr">
-              <a:buNone/>
-              <a:defRPr sz="1600"/>
-            </a:lvl6pPr>
-            <a:lvl7pPr marL="2743200" indent="0" algn="ctr">
-              <a:buNone/>
-              <a:defRPr sz="1600"/>
-            </a:lvl7pPr>
-            <a:lvl8pPr marL="3200400" indent="0" algn="ctr">
-              <a:buNone/>
-              <a:defRPr sz="1600"/>
-            </a:lvl8pPr>
-            <a:lvl9pPr marL="3657600" indent="0" algn="ctr">
-              <a:buNone/>
-              <a:defRPr sz="1600"/>
-            </a:lvl9pPr>
-          </a:lstStyle>
-          <a:p>
-            <a:r>
-              <a:rPr lang="en-US"/>
-              <a:t>Click to edit Master subtitle style</a:t>
-            </a:r>
-          </a:p>
-        </p:txBody>
-      </p:sp>
-      <p:sp>
-        <p:nvSpPr>
-          <p:cNvPr id="4" name="Date Placeholder 3">
-            <a:extLst>
-              <a:ext uri="{FF2B5EF4-FFF2-40B4-BE49-F238E27FC236}">
-                <a16:creationId xmlns:a16="http://schemas.microsoft.com/office/drawing/2014/main" id="{293B74C2-6265-7F41-BB8F-D8A0A0C89A63}"/>
-              </a:ext>
-            </a:extLst>
-          </p:cNvPr>
-          <p:cNvSpPr>
-            <a:spLocks noGrp="1"/>
-          </p:cNvSpPr>
-          <p:nvPr>
-            <p:ph type="dt" sz="half" idx="10"/>
-          </p:nvPr>
-        </p:nvSpPr>
-        <p:spPr/>
-        <p:txBody>
-          <a:bodyPr/>
-          <a:lstStyle/>
-          <a:p>
-            <a:fld id="{B1CFC895-F8E0-4049-8BEE-E5499394E46C}" type="datetime1">
-              <a:rPr lang="en-US" smtClean="0"/>
-              <a:t>3/14/26</a:t>
-            </a:fld>
-            <a:endParaRPr lang="en-US"/>
-          </a:p>
-        </p:txBody>
-      </p:sp>
-      <p:sp>
-        <p:nvSpPr>
-          <p:cNvPr id="5" name="Footer Placeholder 4">
-            <a:extLst>
-              <a:ext uri="{FF2B5EF4-FFF2-40B4-BE49-F238E27FC236}">
-                <a16:creationId xmlns:a16="http://schemas.microsoft.com/office/drawing/2014/main" id="{74C53590-4180-6C42-A6BF-707655C15A1D}"/>
-              </a:ext>
-            </a:extLst>
-          </p:cNvPr>
-          <p:cNvSpPr>
-            <a:spLocks noGrp="1"/>
-          </p:cNvSpPr>
-          <p:nvPr>
-            <p:ph type="ftr" sz="quarter" idx="11"/>
-          </p:nvPr>
-        </p:nvSpPr>
-        <p:spPr/>
-        <p:txBody>
-          <a:bodyPr/>
-          <a:lstStyle>
-            <a:lvl1pPr>
-              <a:defRPr/>
-            </a:lvl1pPr>
-          </a:lstStyle>
-          <a:p>
-            <a:r>
-              <a:rPr lang="en-US"/>
-              <a:t>J Mark Morris - Model of Nature - April 2019</a:t>
-            </a:r>
-          </a:p>
-        </p:txBody>
-      </p:sp>
-      <p:sp>
-        <p:nvSpPr>
-          <p:cNvPr id="6" name="Slide Number Placeholder 5">
-            <a:extLst>
-              <a:ext uri="{FF2B5EF4-FFF2-40B4-BE49-F238E27FC236}">
-                <a16:creationId xmlns:a16="http://schemas.microsoft.com/office/drawing/2014/main" id="{93A81401-8545-2D4E-A7FB-31AFC7A8DB71}"/>
-              </a:ext>
-            </a:extLst>
-          </p:cNvPr>
-          <p:cNvSpPr>
-            <a:spLocks noGrp="1"/>
-          </p:cNvSpPr>
-          <p:nvPr>
-            <p:ph type="sldNum" sz="quarter" idx="12"/>
-          </p:nvPr>
-        </p:nvSpPr>
-        <p:spPr/>
-        <p:txBody>
-          <a:bodyPr/>
-          <a:lstStyle/>
-          <a:p>
-            <a:fld id="{D73D4D4B-2FF7-BE46-958C-B004BD45EF6F}" type="slidenum">
-              <a:rPr lang="en-US" smtClean="0"/>
-              <a:t>‹#›</a:t>
-            </a:fld>
-            <a:endParaRPr lang="en-US"/>
-          </a:p>
-        </p:txBody>
-      </p:sp>
-    </p:spTree>
-    <p:extLst>
-      <p:ext uri="{BB962C8B-B14F-4D97-AF65-F5344CB8AC3E}">
-        <p14:creationId xmlns:p14="http://schemas.microsoft.com/office/powerpoint/2010/main" val="3372916978"/>
-      </p:ext>
-    </p:extLst>
-  </p:cSld>
-  <p:clrMapOvr>
-    <a:masterClrMapping/>
-  </p:clrMapOvr>
-</p:sldLayout>
-</file>
-
-<file path=ppt/slideLayouts/slideLayout13.xml><?xml version="1.0" encoding="utf-8"?>
-<p:sldLayout xmlns:a="http://schemas.openxmlformats.org/drawingml/2006/main" xmlns:r="http://schemas.openxmlformats.org/officeDocument/2006/relationships" xmlns:p="http://schemas.openxmlformats.org/presentationml/2006/main" type="obj" preserve="1">
-  <p:cSld name="Title and Content">
-    <p:spTree>
-      <p:nvGrpSpPr>
-        <p:cNvPr id="1" name=""/>
-        <p:cNvGrpSpPr/>
-        <p:nvPr/>
-      </p:nvGrpSpPr>
-      <p:grpSpPr>
-        <a:xfrm>
-          <a:off x="0" y="0"/>
-          <a:ext cx="0" cy="0"/>
-          <a:chOff x="0" y="0"/>
-          <a:chExt cx="0" cy="0"/>
-        </a:xfrm>
-      </p:grpSpPr>
-      <p:sp>
-        <p:nvSpPr>
-          <p:cNvPr id="2" name="Title 1">
-            <a:extLst>
-              <a:ext uri="{FF2B5EF4-FFF2-40B4-BE49-F238E27FC236}">
-                <a16:creationId xmlns:a16="http://schemas.microsoft.com/office/drawing/2014/main" id="{EDF560F9-C770-5C4C-9C93-102EC332DBA4}"/>
-              </a:ext>
-            </a:extLst>
-          </p:cNvPr>
-          <p:cNvSpPr>
-            <a:spLocks noGrp="1"/>
-          </p:cNvSpPr>
-          <p:nvPr>
-            <p:ph type="title"/>
-          </p:nvPr>
-        </p:nvSpPr>
-        <p:spPr>
-          <a:xfrm>
-            <a:off x="838200" y="365125"/>
-            <a:ext cx="10515600" cy="777875"/>
-          </a:xfrm>
-        </p:spPr>
-        <p:txBody>
-          <a:bodyPr/>
-          <a:lstStyle/>
-          <a:p>
-            <a:r>
-              <a:rPr lang="en-US" dirty="0"/>
-              <a:t>Click to edit Master title style</a:t>
-            </a:r>
-          </a:p>
-        </p:txBody>
-      </p:sp>
-      <p:sp>
-        <p:nvSpPr>
-          <p:cNvPr id="3" name="Content Placeholder 2">
-            <a:extLst>
-              <a:ext uri="{FF2B5EF4-FFF2-40B4-BE49-F238E27FC236}">
-                <a16:creationId xmlns:a16="http://schemas.microsoft.com/office/drawing/2014/main" id="{80D38EDA-56F1-1C40-B81E-28B921C4E99F}"/>
-              </a:ext>
-            </a:extLst>
-          </p:cNvPr>
-          <p:cNvSpPr>
-            <a:spLocks noGrp="1"/>
-          </p:cNvSpPr>
-          <p:nvPr>
-            <p:ph idx="1"/>
-          </p:nvPr>
-        </p:nvSpPr>
-        <p:spPr>
-          <a:xfrm>
-            <a:off x="838200" y="1295400"/>
-            <a:ext cx="10515600" cy="4881563"/>
-          </a:xfrm>
-        </p:spPr>
-        <p:txBody>
-          <a:bodyPr/>
-          <a:lstStyle/>
-          <a:p>
-            <a:pPr lvl="0"/>
-            <a:r>
-              <a:rPr lang="en-US" dirty="0"/>
-              <a:t>Edit Master text styles</a:t>
-            </a:r>
-          </a:p>
-          <a:p>
-            <a:pPr lvl="1"/>
-            <a:r>
-              <a:rPr lang="en-US" dirty="0"/>
-              <a:t>Second level</a:t>
-            </a:r>
-          </a:p>
-          <a:p>
-            <a:pPr lvl="2"/>
-            <a:r>
-              <a:rPr lang="en-US" dirty="0"/>
-              <a:t>Third level</a:t>
-            </a:r>
-          </a:p>
-          <a:p>
-            <a:pPr lvl="3"/>
-            <a:r>
-              <a:rPr lang="en-US" dirty="0"/>
-              <a:t>Fourth level</a:t>
-            </a:r>
-          </a:p>
-          <a:p>
-            <a:pPr lvl="4"/>
-            <a:r>
-              <a:rPr lang="en-US" dirty="0"/>
-              <a:t>Fifth level</a:t>
-            </a:r>
-          </a:p>
-        </p:txBody>
-      </p:sp>
-      <p:sp>
-        <p:nvSpPr>
-          <p:cNvPr id="4" name="Date Placeholder 3">
-            <a:extLst>
-              <a:ext uri="{FF2B5EF4-FFF2-40B4-BE49-F238E27FC236}">
-                <a16:creationId xmlns:a16="http://schemas.microsoft.com/office/drawing/2014/main" id="{0AD42772-5D80-F641-A1BB-6048573C4E88}"/>
-              </a:ext>
-            </a:extLst>
-          </p:cNvPr>
-          <p:cNvSpPr>
-            <a:spLocks noGrp="1"/>
-          </p:cNvSpPr>
-          <p:nvPr>
-            <p:ph type="dt" sz="half" idx="10"/>
-          </p:nvPr>
-        </p:nvSpPr>
-        <p:spPr/>
-        <p:txBody>
-          <a:bodyPr/>
-          <a:lstStyle/>
-          <a:p>
-            <a:fld id="{A91F55E2-A889-F24B-B1FE-1E878178F308}" type="datetime1">
-              <a:rPr lang="en-US" smtClean="0"/>
-              <a:t>3/14/26</a:t>
-            </a:fld>
-            <a:endParaRPr lang="en-US"/>
-          </a:p>
-        </p:txBody>
-      </p:sp>
-      <p:sp>
-        <p:nvSpPr>
-          <p:cNvPr id="5" name="Footer Placeholder 4">
-            <a:extLst>
-              <a:ext uri="{FF2B5EF4-FFF2-40B4-BE49-F238E27FC236}">
-                <a16:creationId xmlns:a16="http://schemas.microsoft.com/office/drawing/2014/main" id="{C68FC4AF-90CF-484C-B6C7-5CE1A016FB49}"/>
-              </a:ext>
-            </a:extLst>
-          </p:cNvPr>
-          <p:cNvSpPr>
-            <a:spLocks noGrp="1"/>
-          </p:cNvSpPr>
-          <p:nvPr>
-            <p:ph type="ftr" sz="quarter" idx="11"/>
-          </p:nvPr>
-        </p:nvSpPr>
-        <p:spPr/>
-        <p:txBody>
-          <a:bodyPr/>
-          <a:lstStyle/>
-          <a:p>
-            <a:r>
-              <a:rPr lang="en-US"/>
-              <a:t>J Mark Morris - Model of Nature - April 2019</a:t>
-            </a:r>
-          </a:p>
-        </p:txBody>
-      </p:sp>
-      <p:sp>
-        <p:nvSpPr>
-          <p:cNvPr id="6" name="Slide Number Placeholder 5">
-            <a:extLst>
-              <a:ext uri="{FF2B5EF4-FFF2-40B4-BE49-F238E27FC236}">
-                <a16:creationId xmlns:a16="http://schemas.microsoft.com/office/drawing/2014/main" id="{8169AF1E-33D8-3041-A601-1384C718A8B5}"/>
-              </a:ext>
-            </a:extLst>
-          </p:cNvPr>
-          <p:cNvSpPr>
-            <a:spLocks noGrp="1"/>
-          </p:cNvSpPr>
-          <p:nvPr>
-            <p:ph type="sldNum" sz="quarter" idx="12"/>
-          </p:nvPr>
-        </p:nvSpPr>
-        <p:spPr/>
-        <p:txBody>
-          <a:bodyPr/>
-          <a:lstStyle/>
-          <a:p>
-            <a:fld id="{D73D4D4B-2FF7-BE46-958C-B004BD45EF6F}" type="slidenum">
-              <a:rPr lang="en-US" smtClean="0"/>
-              <a:t>‹#›</a:t>
-            </a:fld>
-            <a:endParaRPr lang="en-US"/>
-          </a:p>
-        </p:txBody>
-      </p:sp>
-    </p:spTree>
-    <p:extLst>
-      <p:ext uri="{BB962C8B-B14F-4D97-AF65-F5344CB8AC3E}">
-        <p14:creationId xmlns:p14="http://schemas.microsoft.com/office/powerpoint/2010/main" val="497139919"/>
-      </p:ext>
-    </p:extLst>
-  </p:cSld>
-  <p:clrMapOvr>
-    <a:masterClrMapping/>
-  </p:clrMapOvr>
-</p:sldLayout>
-</file>
-
-<file path=ppt/slideLayouts/slideLayout14.xml><?xml version="1.0" encoding="utf-8"?>
-<p:sldLayout xmlns:a="http://schemas.openxmlformats.org/drawingml/2006/main" xmlns:r="http://schemas.openxmlformats.org/officeDocument/2006/relationships" xmlns:p="http://schemas.openxmlformats.org/presentationml/2006/main" type="titleOnly" preserve="1">
-  <p:cSld name="Title Only">
-    <p:spTree>
-      <p:nvGrpSpPr>
-        <p:cNvPr id="1" name=""/>
-        <p:cNvGrpSpPr/>
-        <p:nvPr/>
-      </p:nvGrpSpPr>
-      <p:grpSpPr>
-        <a:xfrm>
-          <a:off x="0" y="0"/>
-          <a:ext cx="0" cy="0"/>
-          <a:chOff x="0" y="0"/>
-          <a:chExt cx="0" cy="0"/>
-        </a:xfrm>
-      </p:grpSpPr>
-      <p:sp>
-        <p:nvSpPr>
-          <p:cNvPr id="2" name="Title 1">
-            <a:extLst>
-              <a:ext uri="{FF2B5EF4-FFF2-40B4-BE49-F238E27FC236}">
-                <a16:creationId xmlns:a16="http://schemas.microsoft.com/office/drawing/2014/main" id="{5821822D-6D7A-1342-98EF-890C6F2DA174}"/>
-              </a:ext>
-            </a:extLst>
-          </p:cNvPr>
-          <p:cNvSpPr>
-            <a:spLocks noGrp="1"/>
-          </p:cNvSpPr>
-          <p:nvPr>
-            <p:ph type="title"/>
-          </p:nvPr>
-        </p:nvSpPr>
-        <p:spPr>
-          <a:xfrm>
-            <a:off x="838200" y="365125"/>
-            <a:ext cx="10515600" cy="777875"/>
-          </a:xfrm>
-        </p:spPr>
-        <p:txBody>
-          <a:bodyPr/>
-          <a:lstStyle/>
-          <a:p>
-            <a:r>
-              <a:rPr lang="en-US"/>
-              <a:t>Click to edit Master title style</a:t>
-            </a:r>
-          </a:p>
-        </p:txBody>
-      </p:sp>
-      <p:sp>
-        <p:nvSpPr>
-          <p:cNvPr id="3" name="Date Placeholder 2">
-            <a:extLst>
-              <a:ext uri="{FF2B5EF4-FFF2-40B4-BE49-F238E27FC236}">
-                <a16:creationId xmlns:a16="http://schemas.microsoft.com/office/drawing/2014/main" id="{74CF19EA-9170-5B4B-814F-7425C8E22823}"/>
-              </a:ext>
-            </a:extLst>
-          </p:cNvPr>
-          <p:cNvSpPr>
-            <a:spLocks noGrp="1"/>
-          </p:cNvSpPr>
-          <p:nvPr>
-            <p:ph type="dt" sz="half" idx="10"/>
-          </p:nvPr>
-        </p:nvSpPr>
-        <p:spPr/>
-        <p:txBody>
-          <a:bodyPr/>
-          <a:lstStyle/>
-          <a:p>
-            <a:fld id="{C6E8461C-3391-334C-9885-001B32D724C4}" type="datetime1">
-              <a:rPr lang="en-US" smtClean="0"/>
-              <a:t>3/14/26</a:t>
-            </a:fld>
-            <a:endParaRPr lang="en-US"/>
-          </a:p>
-        </p:txBody>
-      </p:sp>
-      <p:sp>
-        <p:nvSpPr>
-          <p:cNvPr id="4" name="Footer Placeholder 3">
-            <a:extLst>
-              <a:ext uri="{FF2B5EF4-FFF2-40B4-BE49-F238E27FC236}">
-                <a16:creationId xmlns:a16="http://schemas.microsoft.com/office/drawing/2014/main" id="{5882B1FB-ECDF-AD43-9020-0267ED91C04E}"/>
-              </a:ext>
-            </a:extLst>
-          </p:cNvPr>
-          <p:cNvSpPr>
-            <a:spLocks noGrp="1"/>
-          </p:cNvSpPr>
-          <p:nvPr>
-            <p:ph type="ftr" sz="quarter" idx="11"/>
-          </p:nvPr>
-        </p:nvSpPr>
-        <p:spPr/>
-        <p:txBody>
-          <a:bodyPr/>
-          <a:lstStyle>
-            <a:lvl1pPr>
-              <a:defRPr/>
-            </a:lvl1pPr>
-          </a:lstStyle>
-          <a:p>
-            <a:r>
-              <a:rPr lang="en-US"/>
-              <a:t>J Mark Morris - Model of Nature - April 2019</a:t>
-            </a:r>
-          </a:p>
-        </p:txBody>
-      </p:sp>
-      <p:sp>
-        <p:nvSpPr>
-          <p:cNvPr id="5" name="Slide Number Placeholder 4">
-            <a:extLst>
-              <a:ext uri="{FF2B5EF4-FFF2-40B4-BE49-F238E27FC236}">
-                <a16:creationId xmlns:a16="http://schemas.microsoft.com/office/drawing/2014/main" id="{D949C470-5AF0-5246-81E7-95EAEE5639EF}"/>
-              </a:ext>
-            </a:extLst>
-          </p:cNvPr>
-          <p:cNvSpPr>
-            <a:spLocks noGrp="1"/>
-          </p:cNvSpPr>
-          <p:nvPr>
-            <p:ph type="sldNum" sz="quarter" idx="12"/>
-          </p:nvPr>
-        </p:nvSpPr>
-        <p:spPr/>
-        <p:txBody>
-          <a:bodyPr/>
-          <a:lstStyle/>
-          <a:p>
-            <a:fld id="{D73D4D4B-2FF7-BE46-958C-B004BD45EF6F}" type="slidenum">
-              <a:rPr lang="en-US" smtClean="0"/>
-              <a:t>‹#›</a:t>
-            </a:fld>
-            <a:endParaRPr lang="en-US"/>
-          </a:p>
-        </p:txBody>
-      </p:sp>
-    </p:spTree>
-    <p:extLst>
-      <p:ext uri="{BB962C8B-B14F-4D97-AF65-F5344CB8AC3E}">
-        <p14:creationId xmlns:p14="http://schemas.microsoft.com/office/powerpoint/2010/main" val="1963469369"/>
-      </p:ext>
-    </p:extLst>
-  </p:cSld>
-  <p:clrMapOvr>
-    <a:masterClrMapping/>
-  </p:clrMapOvr>
-</p:sldLayout>
-</file>
-
 <file path=ppt/slideLayouts/slideLayout2.xml><?xml version="1.0" encoding="utf-8"?>
 <p:sldLayout xmlns:a="http://schemas.openxmlformats.org/drawingml/2006/main" xmlns:r="http://schemas.openxmlformats.org/officeDocument/2006/relationships" xmlns:p="http://schemas.openxmlformats.org/presentationml/2006/main" type="obj" preserve="1">
   <p:cSld name="Title and Content">
@@ -5992,7 +5399,7 @@
           <a:p>
             <a:fld id="{CB70D3E6-D921-5B44-AC8D-B7FDAFC8A532}" type="datetimeFigureOut">
               <a:rPr lang="en-US" smtClean="0"/>
-              <a:t>3/14/26</a:t>
+              <a:t>7/3/26</a:t>
             </a:fld>
             <a:endParaRPr lang="en-US"/>
           </a:p>
@@ -6267,7 +5674,7 @@
           <a:p>
             <a:fld id="{CB70D3E6-D921-5B44-AC8D-B7FDAFC8A532}" type="datetimeFigureOut">
               <a:rPr lang="en-US" smtClean="0"/>
-              <a:t>3/14/26</a:t>
+              <a:t>7/3/26</a:t>
             </a:fld>
             <a:endParaRPr lang="en-US"/>
           </a:p>
@@ -6532,7 +5939,7 @@
           <a:p>
             <a:fld id="{CB70D3E6-D921-5B44-AC8D-B7FDAFC8A532}" type="datetimeFigureOut">
               <a:rPr lang="en-US" smtClean="0"/>
-              <a:t>3/14/26</a:t>
+              <a:t>7/3/26</a:t>
             </a:fld>
             <a:endParaRPr lang="en-US"/>
           </a:p>
@@ -6944,7 +6351,7 @@
           <a:p>
             <a:fld id="{CB70D3E6-D921-5B44-AC8D-B7FDAFC8A532}" type="datetimeFigureOut">
               <a:rPr lang="en-US" smtClean="0"/>
-              <a:t>3/14/26</a:t>
+              <a:t>7/3/26</a:t>
             </a:fld>
             <a:endParaRPr lang="en-US"/>
           </a:p>
@@ -7085,7 +6492,7 @@
           <a:p>
             <a:fld id="{CB70D3E6-D921-5B44-AC8D-B7FDAFC8A532}" type="datetimeFigureOut">
               <a:rPr lang="en-US" smtClean="0"/>
-              <a:t>3/14/26</a:t>
+              <a:t>7/3/26</a:t>
             </a:fld>
             <a:endParaRPr lang="en-US"/>
           </a:p>
@@ -7198,7 +6605,7 @@
           <a:p>
             <a:fld id="{CB70D3E6-D921-5B44-AC8D-B7FDAFC8A532}" type="datetimeFigureOut">
               <a:rPr lang="en-US" smtClean="0"/>
-              <a:t>3/14/26</a:t>
+              <a:t>7/3/26</a:t>
             </a:fld>
             <a:endParaRPr lang="en-US"/>
           </a:p>
@@ -7509,7 +6916,7 @@
           <a:p>
             <a:fld id="{CB70D3E6-D921-5B44-AC8D-B7FDAFC8A532}" type="datetimeFigureOut">
               <a:rPr lang="en-US" smtClean="0"/>
-              <a:t>3/14/26</a:t>
+              <a:t>7/3/26</a:t>
             </a:fld>
             <a:endParaRPr lang="en-US"/>
           </a:p>
@@ -7797,7 +7204,7 @@
           <a:p>
             <a:fld id="{CB70D3E6-D921-5B44-AC8D-B7FDAFC8A532}" type="datetimeFigureOut">
               <a:rPr lang="en-US" smtClean="0"/>
-              <a:t>3/14/26</a:t>
+              <a:t>7/3/26</a:t>
             </a:fld>
             <a:endParaRPr lang="en-US"/>
           </a:p>
@@ -8038,7 +7445,7 @@
           <a:p>
             <a:fld id="{CB70D3E6-D921-5B44-AC8D-B7FDAFC8A532}" type="datetimeFigureOut">
               <a:rPr lang="en-US" smtClean="0"/>
-              <a:t>3/14/26</a:t>
+              <a:t>7/3/26</a:t>
             </a:fld>
             <a:endParaRPr lang="en-US"/>
           </a:p>
@@ -8438,580 +7845,6 @@
 </p:sldMaster>
 </file>
 
-<file path=ppt/slideMasters/slideMaster2.xml><?xml version="1.0" encoding="utf-8"?>
-<p:sldMaster xmlns:a="http://schemas.openxmlformats.org/drawingml/2006/main" xmlns:r="http://schemas.openxmlformats.org/officeDocument/2006/relationships" xmlns:p="http://schemas.openxmlformats.org/presentationml/2006/main">
-  <p:cSld>
-    <p:bg>
-      <p:bgRef idx="1001">
-        <a:schemeClr val="bg1"/>
-      </p:bgRef>
-    </p:bg>
-    <p:spTree>
-      <p:nvGrpSpPr>
-        <p:cNvPr id="1" name=""/>
-        <p:cNvGrpSpPr/>
-        <p:nvPr/>
-      </p:nvGrpSpPr>
-      <p:grpSpPr>
-        <a:xfrm>
-          <a:off x="0" y="0"/>
-          <a:ext cx="0" cy="0"/>
-          <a:chOff x="0" y="0"/>
-          <a:chExt cx="0" cy="0"/>
-        </a:xfrm>
-      </p:grpSpPr>
-      <p:sp>
-        <p:nvSpPr>
-          <p:cNvPr id="2" name="Title Placeholder 1">
-            <a:extLst>
-              <a:ext uri="{FF2B5EF4-FFF2-40B4-BE49-F238E27FC236}">
-                <a16:creationId xmlns:a16="http://schemas.microsoft.com/office/drawing/2014/main" id="{4C79A1DB-155B-0846-9CED-8B75F56E0E58}"/>
-              </a:ext>
-            </a:extLst>
-          </p:cNvPr>
-          <p:cNvSpPr>
-            <a:spLocks noGrp="1"/>
-          </p:cNvSpPr>
-          <p:nvPr>
-            <p:ph type="title"/>
-          </p:nvPr>
-        </p:nvSpPr>
-        <p:spPr>
-          <a:xfrm>
-            <a:off x="838200" y="365125"/>
-            <a:ext cx="10515600" cy="1325563"/>
-          </a:xfrm>
-          <a:prstGeom prst="rect">
-            <a:avLst/>
-          </a:prstGeom>
-        </p:spPr>
-        <p:txBody>
-          <a:bodyPr vert="horz" lIns="91440" tIns="45720" rIns="91440" bIns="45720" rtlCol="0" anchor="ctr">
-            <a:normAutofit/>
-          </a:bodyPr>
-          <a:lstStyle/>
-          <a:p>
-            <a:r>
-              <a:rPr lang="en-US" dirty="0"/>
-              <a:t>Click to edit Master title style</a:t>
-            </a:r>
-          </a:p>
-        </p:txBody>
-      </p:sp>
-      <p:sp>
-        <p:nvSpPr>
-          <p:cNvPr id="3" name="Text Placeholder 2">
-            <a:extLst>
-              <a:ext uri="{FF2B5EF4-FFF2-40B4-BE49-F238E27FC236}">
-                <a16:creationId xmlns:a16="http://schemas.microsoft.com/office/drawing/2014/main" id="{FD69736F-08D5-7643-A656-ABAEB9457A7A}"/>
-              </a:ext>
-            </a:extLst>
-          </p:cNvPr>
-          <p:cNvSpPr>
-            <a:spLocks noGrp="1"/>
-          </p:cNvSpPr>
-          <p:nvPr>
-            <p:ph type="body" idx="1"/>
-          </p:nvPr>
-        </p:nvSpPr>
-        <p:spPr>
-          <a:xfrm>
-            <a:off x="838200" y="1825625"/>
-            <a:ext cx="10515600" cy="4351338"/>
-          </a:xfrm>
-          <a:prstGeom prst="rect">
-            <a:avLst/>
-          </a:prstGeom>
-        </p:spPr>
-        <p:txBody>
-          <a:bodyPr vert="horz" lIns="91440" tIns="45720" rIns="91440" bIns="45720" rtlCol="0">
-            <a:normAutofit/>
-          </a:bodyPr>
-          <a:lstStyle/>
-          <a:p>
-            <a:pPr lvl="0"/>
-            <a:r>
-              <a:rPr lang="en-US"/>
-              <a:t>Edit Master text styles</a:t>
-            </a:r>
-          </a:p>
-          <a:p>
-            <a:pPr lvl="1"/>
-            <a:r>
-              <a:rPr lang="en-US"/>
-              <a:t>Second level</a:t>
-            </a:r>
-          </a:p>
-          <a:p>
-            <a:pPr lvl="2"/>
-            <a:r>
-              <a:rPr lang="en-US"/>
-              <a:t>Third level</a:t>
-            </a:r>
-          </a:p>
-          <a:p>
-            <a:pPr lvl="3"/>
-            <a:r>
-              <a:rPr lang="en-US"/>
-              <a:t>Fourth level</a:t>
-            </a:r>
-          </a:p>
-          <a:p>
-            <a:pPr lvl="4"/>
-            <a:r>
-              <a:rPr lang="en-US"/>
-              <a:t>Fifth level</a:t>
-            </a:r>
-          </a:p>
-        </p:txBody>
-      </p:sp>
-      <p:sp>
-        <p:nvSpPr>
-          <p:cNvPr id="4" name="Date Placeholder 3">
-            <a:extLst>
-              <a:ext uri="{FF2B5EF4-FFF2-40B4-BE49-F238E27FC236}">
-                <a16:creationId xmlns:a16="http://schemas.microsoft.com/office/drawing/2014/main" id="{C0433D04-66F5-D74B-8EEA-459FDC00D1E4}"/>
-              </a:ext>
-            </a:extLst>
-          </p:cNvPr>
-          <p:cNvSpPr>
-            <a:spLocks noGrp="1"/>
-          </p:cNvSpPr>
-          <p:nvPr>
-            <p:ph type="dt" sz="half" idx="2"/>
-          </p:nvPr>
-        </p:nvSpPr>
-        <p:spPr>
-          <a:xfrm>
-            <a:off x="838200" y="6356350"/>
-            <a:ext cx="2743200" cy="365125"/>
-          </a:xfrm>
-          <a:prstGeom prst="rect">
-            <a:avLst/>
-          </a:prstGeom>
-        </p:spPr>
-        <p:txBody>
-          <a:bodyPr vert="horz" lIns="91440" tIns="45720" rIns="91440" bIns="45720" rtlCol="0" anchor="ctr"/>
-          <a:lstStyle>
-            <a:lvl1pPr algn="l">
-              <a:defRPr sz="1200">
-                <a:solidFill>
-                  <a:schemeClr val="tx1">
-                    <a:tint val="75000"/>
-                  </a:schemeClr>
-                </a:solidFill>
-                <a:latin typeface="Helvetica Neue" panose="02000503000000020004" pitchFamily="2" charset="0"/>
-                <a:ea typeface="Helvetica Neue" panose="02000503000000020004" pitchFamily="2" charset="0"/>
-                <a:cs typeface="Helvetica Neue" panose="02000503000000020004" pitchFamily="2" charset="0"/>
-              </a:defRPr>
-            </a:lvl1pPr>
-          </a:lstStyle>
-          <a:p>
-            <a:fld id="{2005EE61-3907-C44D-8624-D47E09E871DB}" type="datetime1">
-              <a:rPr lang="en-US" smtClean="0"/>
-              <a:t>3/14/26</a:t>
-            </a:fld>
-            <a:endParaRPr lang="en-US"/>
-          </a:p>
-        </p:txBody>
-      </p:sp>
-      <p:sp>
-        <p:nvSpPr>
-          <p:cNvPr id="5" name="Footer Placeholder 4">
-            <a:extLst>
-              <a:ext uri="{FF2B5EF4-FFF2-40B4-BE49-F238E27FC236}">
-                <a16:creationId xmlns:a16="http://schemas.microsoft.com/office/drawing/2014/main" id="{9FDE6E67-6F97-E149-8437-635D11E7ED43}"/>
-              </a:ext>
-            </a:extLst>
-          </p:cNvPr>
-          <p:cNvSpPr>
-            <a:spLocks noGrp="1"/>
-          </p:cNvSpPr>
-          <p:nvPr>
-            <p:ph type="ftr" sz="quarter" idx="3"/>
-          </p:nvPr>
-        </p:nvSpPr>
-        <p:spPr>
-          <a:xfrm>
-            <a:off x="4038600" y="6356350"/>
-            <a:ext cx="4114800" cy="365125"/>
-          </a:xfrm>
-          <a:prstGeom prst="rect">
-            <a:avLst/>
-          </a:prstGeom>
-        </p:spPr>
-        <p:txBody>
-          <a:bodyPr vert="horz" lIns="91440" tIns="45720" rIns="91440" bIns="45720" rtlCol="0" anchor="ctr"/>
-          <a:lstStyle>
-            <a:lvl1pPr algn="ctr">
-              <a:defRPr sz="1200">
-                <a:solidFill>
-                  <a:schemeClr val="tx1">
-                    <a:tint val="75000"/>
-                  </a:schemeClr>
-                </a:solidFill>
-                <a:latin typeface="Helvetica Neue" panose="02000503000000020004" pitchFamily="2" charset="0"/>
-                <a:ea typeface="Helvetica Neue" panose="02000503000000020004" pitchFamily="2" charset="0"/>
-                <a:cs typeface="Helvetica Neue" panose="02000503000000020004" pitchFamily="2" charset="0"/>
-              </a:defRPr>
-            </a:lvl1pPr>
-          </a:lstStyle>
-          <a:p>
-            <a:r>
-              <a:rPr lang="en-US"/>
-              <a:t>J Mark Morris - Model of Nature - April 2019</a:t>
-            </a:r>
-          </a:p>
-        </p:txBody>
-      </p:sp>
-      <p:sp>
-        <p:nvSpPr>
-          <p:cNvPr id="6" name="Slide Number Placeholder 5">
-            <a:extLst>
-              <a:ext uri="{FF2B5EF4-FFF2-40B4-BE49-F238E27FC236}">
-                <a16:creationId xmlns:a16="http://schemas.microsoft.com/office/drawing/2014/main" id="{D585CC1E-0AB1-F34A-83C6-0956BF9B4AF3}"/>
-              </a:ext>
-            </a:extLst>
-          </p:cNvPr>
-          <p:cNvSpPr>
-            <a:spLocks noGrp="1"/>
-          </p:cNvSpPr>
-          <p:nvPr>
-            <p:ph type="sldNum" sz="quarter" idx="4"/>
-          </p:nvPr>
-        </p:nvSpPr>
-        <p:spPr>
-          <a:xfrm>
-            <a:off x="8610600" y="6356350"/>
-            <a:ext cx="2743200" cy="365125"/>
-          </a:xfrm>
-          <a:prstGeom prst="rect">
-            <a:avLst/>
-          </a:prstGeom>
-        </p:spPr>
-        <p:txBody>
-          <a:bodyPr vert="horz" lIns="91440" tIns="45720" rIns="91440" bIns="45720" rtlCol="0" anchor="ctr"/>
-          <a:lstStyle>
-            <a:lvl1pPr algn="r">
-              <a:defRPr sz="1200">
-                <a:solidFill>
-                  <a:schemeClr val="tx1">
-                    <a:tint val="75000"/>
-                  </a:schemeClr>
-                </a:solidFill>
-                <a:latin typeface="Helvetica Neue" panose="02000503000000020004" pitchFamily="2" charset="0"/>
-                <a:ea typeface="Helvetica Neue" panose="02000503000000020004" pitchFamily="2" charset="0"/>
-                <a:cs typeface="Helvetica Neue" panose="02000503000000020004" pitchFamily="2" charset="0"/>
-              </a:defRPr>
-            </a:lvl1pPr>
-          </a:lstStyle>
-          <a:p>
-            <a:fld id="{D73D4D4B-2FF7-BE46-958C-B004BD45EF6F}" type="slidenum">
-              <a:rPr lang="en-US" smtClean="0"/>
-              <a:pPr/>
-              <a:t>‹#›</a:t>
-            </a:fld>
-            <a:endParaRPr lang="en-US"/>
-          </a:p>
-        </p:txBody>
-      </p:sp>
-    </p:spTree>
-    <p:extLst>
-      <p:ext uri="{BB962C8B-B14F-4D97-AF65-F5344CB8AC3E}">
-        <p14:creationId xmlns:p14="http://schemas.microsoft.com/office/powerpoint/2010/main" val="4188259015"/>
-      </p:ext>
-    </p:extLst>
-  </p:cSld>
-  <p:clrMap bg1="lt1" tx1="dk1" bg2="lt2" tx2="dk2" accent1="accent1" accent2="accent2" accent3="accent3" accent4="accent4" accent5="accent5" accent6="accent6" hlink="hlink" folHlink="folHlink"/>
-  <p:sldLayoutIdLst>
-    <p:sldLayoutId id="2147483665" r:id="rId1"/>
-    <p:sldLayoutId id="2147483666" r:id="rId2"/>
-    <p:sldLayoutId id="2147483667" r:id="rId3"/>
-  </p:sldLayoutIdLst>
-  <p:hf sldNum="0" hdr="0" dt="0"/>
-  <p:txStyles>
-    <p:titleStyle>
-      <a:lvl1pPr algn="l" defTabSz="914400" rtl="0" eaLnBrk="1" latinLnBrk="0" hangingPunct="1">
-        <a:lnSpc>
-          <a:spcPct val="90000"/>
-        </a:lnSpc>
-        <a:spcBef>
-          <a:spcPct val="0"/>
-        </a:spcBef>
-        <a:buNone/>
-        <a:defRPr sz="4400" kern="1200">
-          <a:solidFill>
-            <a:schemeClr val="tx1"/>
-          </a:solidFill>
-          <a:latin typeface="Helvetica Neue" panose="02000503000000020004" pitchFamily="2" charset="0"/>
-          <a:ea typeface="Helvetica Neue" panose="02000503000000020004" pitchFamily="2" charset="0"/>
-          <a:cs typeface="Helvetica Neue" panose="02000503000000020004" pitchFamily="2" charset="0"/>
-        </a:defRPr>
-      </a:lvl1pPr>
-    </p:titleStyle>
-    <p:bodyStyle>
-      <a:lvl1pPr marL="228600" indent="-228600" algn="l" defTabSz="914400" rtl="0" eaLnBrk="1" latinLnBrk="0" hangingPunct="1">
-        <a:lnSpc>
-          <a:spcPct val="90000"/>
-        </a:lnSpc>
-        <a:spcBef>
-          <a:spcPts val="1000"/>
-        </a:spcBef>
-        <a:buFont typeface="Arial" panose="020B0604020202020204" pitchFamily="34" charset="0"/>
-        <a:buChar char="•"/>
-        <a:defRPr sz="2800" kern="1200">
-          <a:solidFill>
-            <a:schemeClr val="tx1"/>
-          </a:solidFill>
-          <a:latin typeface="Helvetica Neue" panose="02000503000000020004" pitchFamily="2" charset="0"/>
-          <a:ea typeface="Helvetica Neue" panose="02000503000000020004" pitchFamily="2" charset="0"/>
-          <a:cs typeface="Helvetica Neue" panose="02000503000000020004" pitchFamily="2" charset="0"/>
-        </a:defRPr>
-      </a:lvl1pPr>
-      <a:lvl2pPr marL="685800" indent="-228600" algn="l" defTabSz="914400" rtl="0" eaLnBrk="1" latinLnBrk="0" hangingPunct="1">
-        <a:lnSpc>
-          <a:spcPct val="90000"/>
-        </a:lnSpc>
-        <a:spcBef>
-          <a:spcPts val="500"/>
-        </a:spcBef>
-        <a:buFont typeface="Arial" panose="020B0604020202020204" pitchFamily="34" charset="0"/>
-        <a:buChar char="•"/>
-        <a:defRPr sz="2400" kern="1200">
-          <a:solidFill>
-            <a:schemeClr val="tx1"/>
-          </a:solidFill>
-          <a:latin typeface="Helvetica Neue" panose="02000503000000020004" pitchFamily="2" charset="0"/>
-          <a:ea typeface="Helvetica Neue" panose="02000503000000020004" pitchFamily="2" charset="0"/>
-          <a:cs typeface="Helvetica Neue" panose="02000503000000020004" pitchFamily="2" charset="0"/>
-        </a:defRPr>
-      </a:lvl2pPr>
-      <a:lvl3pPr marL="1143000" indent="-228600" algn="l" defTabSz="914400" rtl="0" eaLnBrk="1" latinLnBrk="0" hangingPunct="1">
-        <a:lnSpc>
-          <a:spcPct val="90000"/>
-        </a:lnSpc>
-        <a:spcBef>
-          <a:spcPts val="500"/>
-        </a:spcBef>
-        <a:buFont typeface="Arial" panose="020B0604020202020204" pitchFamily="34" charset="0"/>
-        <a:buChar char="•"/>
-        <a:defRPr sz="2000" kern="1200">
-          <a:solidFill>
-            <a:schemeClr val="tx1"/>
-          </a:solidFill>
-          <a:latin typeface="Helvetica Neue" panose="02000503000000020004" pitchFamily="2" charset="0"/>
-          <a:ea typeface="Helvetica Neue" panose="02000503000000020004" pitchFamily="2" charset="0"/>
-          <a:cs typeface="Helvetica Neue" panose="02000503000000020004" pitchFamily="2" charset="0"/>
-        </a:defRPr>
-      </a:lvl3pPr>
-      <a:lvl4pPr marL="1600200" indent="-228600" algn="l" defTabSz="914400" rtl="0" eaLnBrk="1" latinLnBrk="0" hangingPunct="1">
-        <a:lnSpc>
-          <a:spcPct val="90000"/>
-        </a:lnSpc>
-        <a:spcBef>
-          <a:spcPts val="500"/>
-        </a:spcBef>
-        <a:buFont typeface="Arial" panose="020B0604020202020204" pitchFamily="34" charset="0"/>
-        <a:buChar char="•"/>
-        <a:defRPr sz="1800" kern="1200">
-          <a:solidFill>
-            <a:schemeClr val="tx1"/>
-          </a:solidFill>
-          <a:latin typeface="Helvetica Neue" panose="02000503000000020004" pitchFamily="2" charset="0"/>
-          <a:ea typeface="Helvetica Neue" panose="02000503000000020004" pitchFamily="2" charset="0"/>
-          <a:cs typeface="Helvetica Neue" panose="02000503000000020004" pitchFamily="2" charset="0"/>
-        </a:defRPr>
-      </a:lvl4pPr>
-      <a:lvl5pPr marL="2057400" indent="-228600" algn="l" defTabSz="914400" rtl="0" eaLnBrk="1" latinLnBrk="0" hangingPunct="1">
-        <a:lnSpc>
-          <a:spcPct val="90000"/>
-        </a:lnSpc>
-        <a:spcBef>
-          <a:spcPts val="500"/>
-        </a:spcBef>
-        <a:buFont typeface="Arial" panose="020B0604020202020204" pitchFamily="34" charset="0"/>
-        <a:buChar char="•"/>
-        <a:defRPr sz="1800" kern="1200">
-          <a:solidFill>
-            <a:schemeClr val="tx1"/>
-          </a:solidFill>
-          <a:latin typeface="Helvetica Neue" panose="02000503000000020004" pitchFamily="2" charset="0"/>
-          <a:ea typeface="Helvetica Neue" panose="02000503000000020004" pitchFamily="2" charset="0"/>
-          <a:cs typeface="Helvetica Neue" panose="02000503000000020004" pitchFamily="2" charset="0"/>
-        </a:defRPr>
-      </a:lvl5pPr>
-      <a:lvl6pPr marL="2514600" indent="-228600" algn="l" defTabSz="914400" rtl="0" eaLnBrk="1" latinLnBrk="0" hangingPunct="1">
-        <a:lnSpc>
-          <a:spcPct val="90000"/>
-        </a:lnSpc>
-        <a:spcBef>
-          <a:spcPts val="500"/>
-        </a:spcBef>
-        <a:buFont typeface="Arial" panose="020B0604020202020204" pitchFamily="34" charset="0"/>
-        <a:buChar char="•"/>
-        <a:defRPr sz="1800" kern="1200">
-          <a:solidFill>
-            <a:schemeClr val="tx1"/>
-          </a:solidFill>
-          <a:latin typeface="+mn-lt"/>
-          <a:ea typeface="+mn-ea"/>
-          <a:cs typeface="+mn-cs"/>
-        </a:defRPr>
-      </a:lvl6pPr>
-      <a:lvl7pPr marL="2971800" indent="-228600" algn="l" defTabSz="914400" rtl="0" eaLnBrk="1" latinLnBrk="0" hangingPunct="1">
-        <a:lnSpc>
-          <a:spcPct val="90000"/>
-        </a:lnSpc>
-        <a:spcBef>
-          <a:spcPts val="500"/>
-        </a:spcBef>
-        <a:buFont typeface="Arial" panose="020B0604020202020204" pitchFamily="34" charset="0"/>
-        <a:buChar char="•"/>
-        <a:defRPr sz="1800" kern="1200">
-          <a:solidFill>
-            <a:schemeClr val="tx1"/>
-          </a:solidFill>
-          <a:latin typeface="+mn-lt"/>
-          <a:ea typeface="+mn-ea"/>
-          <a:cs typeface="+mn-cs"/>
-        </a:defRPr>
-      </a:lvl7pPr>
-      <a:lvl8pPr marL="3429000" indent="-228600" algn="l" defTabSz="914400" rtl="0" eaLnBrk="1" latinLnBrk="0" hangingPunct="1">
-        <a:lnSpc>
-          <a:spcPct val="90000"/>
-        </a:lnSpc>
-        <a:spcBef>
-          <a:spcPts val="500"/>
-        </a:spcBef>
-        <a:buFont typeface="Arial" panose="020B0604020202020204" pitchFamily="34" charset="0"/>
-        <a:buChar char="•"/>
-        <a:defRPr sz="1800" kern="1200">
-          <a:solidFill>
-            <a:schemeClr val="tx1"/>
-          </a:solidFill>
-          <a:latin typeface="+mn-lt"/>
-          <a:ea typeface="+mn-ea"/>
-          <a:cs typeface="+mn-cs"/>
-        </a:defRPr>
-      </a:lvl8pPr>
-      <a:lvl9pPr marL="3886200" indent="-228600" algn="l" defTabSz="914400" rtl="0" eaLnBrk="1" latinLnBrk="0" hangingPunct="1">
-        <a:lnSpc>
-          <a:spcPct val="90000"/>
-        </a:lnSpc>
-        <a:spcBef>
-          <a:spcPts val="500"/>
-        </a:spcBef>
-        <a:buFont typeface="Arial" panose="020B0604020202020204" pitchFamily="34" charset="0"/>
-        <a:buChar char="•"/>
-        <a:defRPr sz="1800" kern="1200">
-          <a:solidFill>
-            <a:schemeClr val="tx1"/>
-          </a:solidFill>
-          <a:latin typeface="+mn-lt"/>
-          <a:ea typeface="+mn-ea"/>
-          <a:cs typeface="+mn-cs"/>
-        </a:defRPr>
-      </a:lvl9pPr>
-    </p:bodyStyle>
-    <p:otherStyle>
-      <a:defPPr>
-        <a:defRPr lang="en-US"/>
-      </a:defPPr>
-      <a:lvl1pPr marL="0" algn="l" defTabSz="914400" rtl="0" eaLnBrk="1" latinLnBrk="0" hangingPunct="1">
-        <a:defRPr sz="1800" kern="1200">
-          <a:solidFill>
-            <a:schemeClr val="tx1"/>
-          </a:solidFill>
-          <a:latin typeface="+mn-lt"/>
-          <a:ea typeface="+mn-ea"/>
-          <a:cs typeface="+mn-cs"/>
-        </a:defRPr>
-      </a:lvl1pPr>
-      <a:lvl2pPr marL="457200" algn="l" defTabSz="914400" rtl="0" eaLnBrk="1" latinLnBrk="0" hangingPunct="1">
-        <a:defRPr sz="1800" kern="1200">
-          <a:solidFill>
-            <a:schemeClr val="tx1"/>
-          </a:solidFill>
-          <a:latin typeface="+mn-lt"/>
-          <a:ea typeface="+mn-ea"/>
-          <a:cs typeface="+mn-cs"/>
-        </a:defRPr>
-      </a:lvl2pPr>
-      <a:lvl3pPr marL="914400" algn="l" defTabSz="914400" rtl="0" eaLnBrk="1" latinLnBrk="0" hangingPunct="1">
-        <a:defRPr sz="1800" kern="1200">
-          <a:solidFill>
-            <a:schemeClr val="tx1"/>
-          </a:solidFill>
-          <a:latin typeface="+mn-lt"/>
-          <a:ea typeface="+mn-ea"/>
-          <a:cs typeface="+mn-cs"/>
-        </a:defRPr>
-      </a:lvl3pPr>
-      <a:lvl4pPr marL="1371600" algn="l" defTabSz="914400" rtl="0" eaLnBrk="1" latinLnBrk="0" hangingPunct="1">
-        <a:defRPr sz="1800" kern="1200">
-          <a:solidFill>
-            <a:schemeClr val="tx1"/>
-          </a:solidFill>
-          <a:latin typeface="+mn-lt"/>
-          <a:ea typeface="+mn-ea"/>
-          <a:cs typeface="+mn-cs"/>
-        </a:defRPr>
-      </a:lvl4pPr>
-      <a:lvl5pPr marL="1828800" algn="l" defTabSz="914400" rtl="0" eaLnBrk="1" latinLnBrk="0" hangingPunct="1">
-        <a:defRPr sz="1800" kern="1200">
-          <a:solidFill>
-            <a:schemeClr val="tx1"/>
-          </a:solidFill>
-          <a:latin typeface="+mn-lt"/>
-          <a:ea typeface="+mn-ea"/>
-          <a:cs typeface="+mn-cs"/>
-        </a:defRPr>
-      </a:lvl5pPr>
-      <a:lvl6pPr marL="2286000" algn="l" defTabSz="914400" rtl="0" eaLnBrk="1" latinLnBrk="0" hangingPunct="1">
-        <a:defRPr sz="1800" kern="1200">
-          <a:solidFill>
-            <a:schemeClr val="tx1"/>
-          </a:solidFill>
-          <a:latin typeface="+mn-lt"/>
-          <a:ea typeface="+mn-ea"/>
-          <a:cs typeface="+mn-cs"/>
-        </a:defRPr>
-      </a:lvl6pPr>
-      <a:lvl7pPr marL="2743200" algn="l" defTabSz="914400" rtl="0" eaLnBrk="1" latinLnBrk="0" hangingPunct="1">
-        <a:defRPr sz="1800" kern="1200">
-          <a:solidFill>
-            <a:schemeClr val="tx1"/>
-          </a:solidFill>
-          <a:latin typeface="+mn-lt"/>
-          <a:ea typeface="+mn-ea"/>
-          <a:cs typeface="+mn-cs"/>
-        </a:defRPr>
-      </a:lvl7pPr>
-      <a:lvl8pPr marL="3200400" algn="l" defTabSz="914400" rtl="0" eaLnBrk="1" latinLnBrk="0" hangingPunct="1">
-        <a:defRPr sz="1800" kern="1200">
-          <a:solidFill>
-            <a:schemeClr val="tx1"/>
-          </a:solidFill>
-          <a:latin typeface="+mn-lt"/>
-          <a:ea typeface="+mn-ea"/>
-          <a:cs typeface="+mn-cs"/>
-        </a:defRPr>
-      </a:lvl8pPr>
-      <a:lvl9pPr marL="3657600" algn="l" defTabSz="914400" rtl="0" eaLnBrk="1" latinLnBrk="0" hangingPunct="1">
-        <a:defRPr sz="1800" kern="1200">
-          <a:solidFill>
-            <a:schemeClr val="tx1"/>
-          </a:solidFill>
-          <a:latin typeface="+mn-lt"/>
-          <a:ea typeface="+mn-ea"/>
-          <a:cs typeface="+mn-cs"/>
-        </a:defRPr>
-      </a:lvl9pPr>
-    </p:otherStyle>
-  </p:txStyles>
-</p:sldMaster>
-</file>
-
 <file path=ppt/slides/slide1.xml><?xml version="1.0" encoding="utf-8"?>
 <p:sld xmlns:a="http://schemas.openxmlformats.org/drawingml/2006/main" xmlns:r="http://schemas.openxmlformats.org/officeDocument/2006/relationships" xmlns:p="http://schemas.openxmlformats.org/presentationml/2006/main">
   <p:cSld>
@@ -9136,638 +7969,6 @@
 </file>
 
 <file path=ppt/slides/slide10.xml><?xml version="1.0" encoding="utf-8"?>
-<p:sld xmlns:a="http://schemas.openxmlformats.org/drawingml/2006/main" xmlns:r="http://schemas.openxmlformats.org/officeDocument/2006/relationships" xmlns:p="http://schemas.openxmlformats.org/presentationml/2006/main">
-  <p:cSld>
-    <p:bg>
-      <p:bgPr>
-        <a:solidFill>
-          <a:srgbClr val="7030A0"/>
-        </a:solidFill>
-        <a:effectLst/>
-      </p:bgPr>
-    </p:bg>
-    <p:spTree>
-      <p:nvGrpSpPr>
-        <p:cNvPr id="1" name=""/>
-        <p:cNvGrpSpPr/>
-        <p:nvPr/>
-      </p:nvGrpSpPr>
-      <p:grpSpPr>
-        <a:xfrm>
-          <a:off x="0" y="0"/>
-          <a:ext cx="0" cy="0"/>
-          <a:chOff x="0" y="0"/>
-          <a:chExt cx="0" cy="0"/>
-        </a:xfrm>
-      </p:grpSpPr>
-      <p:sp>
-        <p:nvSpPr>
-          <p:cNvPr id="2" name="TextBox 1">
-            <a:extLst>
-              <a:ext uri="{FF2B5EF4-FFF2-40B4-BE49-F238E27FC236}">
-                <a16:creationId xmlns:a16="http://schemas.microsoft.com/office/drawing/2014/main" id="{018A63B5-40EC-8B9D-0CE4-CED6A7D3C146}"/>
-              </a:ext>
-            </a:extLst>
-          </p:cNvPr>
-          <p:cNvSpPr txBox="1"/>
-          <p:nvPr/>
-        </p:nvSpPr>
-        <p:spPr>
-          <a:xfrm>
-            <a:off x="-70338" y="0"/>
-            <a:ext cx="12262338" cy="6740307"/>
-          </a:xfrm>
-          <a:prstGeom prst="rect">
-            <a:avLst/>
-          </a:prstGeom>
-          <a:noFill/>
-        </p:spPr>
-        <p:txBody>
-          <a:bodyPr wrap="square" rtlCol="0">
-            <a:spAutoFit/>
-          </a:bodyPr>
-          <a:lstStyle/>
-          <a:p>
-            <a:pPr marL="0" marR="0" lvl="0" indent="0" algn="l" defTabSz="914400" rtl="0" eaLnBrk="1" fontAlgn="auto" latinLnBrk="0" hangingPunct="1">
-              <a:lnSpc>
-                <a:spcPct val="100000"/>
-              </a:lnSpc>
-              <a:spcBef>
-                <a:spcPts val="0"/>
-              </a:spcBef>
-              <a:spcAft>
-                <a:spcPts val="0"/>
-              </a:spcAft>
-              <a:buClrTx/>
-              <a:buSzTx/>
-              <a:buFontTx/>
-              <a:buNone/>
-              <a:tabLst/>
-              <a:defRPr/>
-            </a:pPr>
-            <a:r>
-              <a:rPr kumimoji="0" lang="en-US" sz="1600" b="0" i="0" u="none" strike="noStrike" kern="1200" cap="none" spc="0" normalizeH="0" baseline="0" noProof="0" dirty="0">
-                <a:ln>
-                  <a:noFill/>
-                </a:ln>
-                <a:solidFill>
-                  <a:prstClr val="white"/>
-                </a:solidFill>
-                <a:effectLst/>
-                <a:uLnTx/>
-                <a:uFillTx/>
-                <a:latin typeface="Calibri" panose="020F0502020204030204"/>
-                <a:ea typeface="+mn-ea"/>
-                <a:cs typeface="+mn-cs"/>
-              </a:rPr>
-              <a:t>It's like the classic history potential figure. However, if we really contemplated what is happening in this dynamical geometry between any two point potentials is this:</a:t>
-            </a:r>
-          </a:p>
-          <a:p>
-            <a:pPr marL="0" marR="0" lvl="0" indent="0" algn="l" defTabSz="914400" rtl="0" eaLnBrk="1" fontAlgn="auto" latinLnBrk="0" hangingPunct="1">
-              <a:lnSpc>
-                <a:spcPct val="100000"/>
-              </a:lnSpc>
-              <a:spcBef>
-                <a:spcPts val="0"/>
-              </a:spcBef>
-              <a:spcAft>
-                <a:spcPts val="0"/>
-              </a:spcAft>
-              <a:buClrTx/>
-              <a:buSzTx/>
-              <a:buFontTx/>
-              <a:buNone/>
-              <a:tabLst/>
-              <a:defRPr/>
-            </a:pPr>
-            <a:r>
-              <a:rPr kumimoji="0" lang="en-US" sz="1600" b="0" i="0" u="none" strike="noStrike" kern="1200" cap="none" spc="0" normalizeH="0" baseline="0" noProof="0" dirty="0">
-                <a:ln>
-                  <a:noFill/>
-                </a:ln>
-                <a:solidFill>
-                  <a:prstClr val="white"/>
-                </a:solidFill>
-                <a:effectLst/>
-                <a:uLnTx/>
-                <a:uFillTx/>
-                <a:latin typeface="Calibri" panose="020F0502020204030204"/>
-                <a:ea typeface="+mn-ea"/>
-                <a:cs typeface="+mn-cs"/>
-              </a:rPr>
-              <a:t>1. Point potentials follow continuous paths through R4 (t, </a:t>
-            </a:r>
-            <a:r>
-              <a:rPr kumimoji="0" lang="en-US" sz="1600" b="0" i="0" u="none" strike="noStrike" kern="1200" cap="none" spc="0" normalizeH="0" baseline="0" noProof="0" dirty="0" err="1">
-                <a:ln>
-                  <a:noFill/>
-                </a:ln>
-                <a:solidFill>
-                  <a:prstClr val="white"/>
-                </a:solidFill>
-                <a:effectLst/>
-                <a:uLnTx/>
-                <a:uFillTx/>
-                <a:latin typeface="Calibri" panose="020F0502020204030204"/>
-                <a:ea typeface="+mn-ea"/>
-                <a:cs typeface="+mn-cs"/>
-              </a:rPr>
-              <a:t>x,y,z</a:t>
-            </a:r>
-            <a:r>
-              <a:rPr kumimoji="0" lang="en-US" sz="1600" b="0" i="0" u="none" strike="noStrike" kern="1200" cap="none" spc="0" normalizeH="0" baseline="0" noProof="0" dirty="0">
-                <a:ln>
-                  <a:noFill/>
-                </a:ln>
-                <a:solidFill>
-                  <a:prstClr val="white"/>
-                </a:solidFill>
-                <a:effectLst/>
-                <a:uLnTx/>
-                <a:uFillTx/>
-                <a:latin typeface="Calibri" panose="020F0502020204030204"/>
-                <a:ea typeface="+mn-ea"/>
-                <a:cs typeface="+mn-cs"/>
-              </a:rPr>
-              <a:t>, x', y', z'). That is to say at any absolute time each point potential has a position in space and a velocity.</a:t>
-            </a:r>
-          </a:p>
-          <a:p>
-            <a:pPr marL="0" marR="0" lvl="0" indent="0" algn="l" defTabSz="914400" rtl="0" eaLnBrk="1" fontAlgn="auto" latinLnBrk="0" hangingPunct="1">
-              <a:lnSpc>
-                <a:spcPct val="100000"/>
-              </a:lnSpc>
-              <a:spcBef>
-                <a:spcPts val="0"/>
-              </a:spcBef>
-              <a:spcAft>
-                <a:spcPts val="0"/>
-              </a:spcAft>
-              <a:buClrTx/>
-              <a:buSzTx/>
-              <a:buFontTx/>
-              <a:buNone/>
-              <a:tabLst/>
-              <a:defRPr/>
-            </a:pPr>
-            <a:r>
-              <a:rPr kumimoji="0" lang="en-US" sz="1600" b="0" i="0" u="none" strike="noStrike" kern="1200" cap="none" spc="0" normalizeH="0" baseline="0" noProof="0" dirty="0">
-                <a:ln>
-                  <a:noFill/>
-                </a:ln>
-                <a:solidFill>
-                  <a:prstClr val="white"/>
-                </a:solidFill>
-                <a:effectLst/>
-                <a:uLnTx/>
-                <a:uFillTx/>
-                <a:latin typeface="Calibri" panose="020F0502020204030204"/>
-                <a:ea typeface="+mn-ea"/>
-                <a:cs typeface="+mn-cs"/>
-              </a:rPr>
-              <a:t>2. Now consider two point potentials each following their path under the influence of the arriving potential field. Let's limit ourselves to point potential velocities less than field speed, because it is a simpler case. </a:t>
-            </a:r>
-          </a:p>
-          <a:p>
-            <a:pPr marL="0" marR="0" lvl="0" indent="0" algn="l" defTabSz="914400" rtl="0" eaLnBrk="1" fontAlgn="auto" latinLnBrk="0" hangingPunct="1">
-              <a:lnSpc>
-                <a:spcPct val="100000"/>
-              </a:lnSpc>
-              <a:spcBef>
-                <a:spcPts val="0"/>
-              </a:spcBef>
-              <a:spcAft>
-                <a:spcPts val="0"/>
-              </a:spcAft>
-              <a:buClrTx/>
-              <a:buSzTx/>
-              <a:buFontTx/>
-              <a:buNone/>
-              <a:tabLst/>
-              <a:defRPr/>
-            </a:pPr>
-            <a:r>
-              <a:rPr kumimoji="0" lang="en-US" sz="1600" b="0" i="0" u="none" strike="noStrike" kern="1200" cap="none" spc="0" normalizeH="0" baseline="0" noProof="0" dirty="0">
-                <a:ln>
-                  <a:noFill/>
-                </a:ln>
-                <a:solidFill>
-                  <a:prstClr val="white"/>
-                </a:solidFill>
-                <a:effectLst/>
-                <a:uLnTx/>
-                <a:uFillTx/>
-                <a:latin typeface="Calibri" panose="020F0502020204030204"/>
-                <a:ea typeface="+mn-ea"/>
-                <a:cs typeface="+mn-cs"/>
-              </a:rPr>
-              <a:t>3. Each point potential is continuously emitting a spherical potential that starts at it's current location with radius 0 and expands such that radius is field speed multiplied by elapsed time since emission. We are using all Euclidean coordinates here in time and space, so everything is absolute. </a:t>
-            </a:r>
-          </a:p>
-          <a:p>
-            <a:pPr marL="0" marR="0" lvl="0" indent="0" algn="l" defTabSz="914400" rtl="0" eaLnBrk="1" fontAlgn="auto" latinLnBrk="0" hangingPunct="1">
-              <a:lnSpc>
-                <a:spcPct val="100000"/>
-              </a:lnSpc>
-              <a:spcBef>
-                <a:spcPts val="0"/>
-              </a:spcBef>
-              <a:spcAft>
-                <a:spcPts val="0"/>
-              </a:spcAft>
-              <a:buClrTx/>
-              <a:buSzTx/>
-              <a:buFontTx/>
-              <a:buNone/>
-              <a:tabLst/>
-              <a:defRPr/>
-            </a:pPr>
-            <a:r>
-              <a:rPr kumimoji="0" lang="en-US" sz="1600" b="0" i="0" u="none" strike="noStrike" kern="1200" cap="none" spc="0" normalizeH="0" baseline="0" noProof="0" dirty="0">
-                <a:ln>
-                  <a:noFill/>
-                </a:ln>
-                <a:solidFill>
-                  <a:prstClr val="white"/>
-                </a:solidFill>
-                <a:effectLst/>
-                <a:uLnTx/>
-                <a:uFillTx/>
-                <a:latin typeface="Calibri" panose="020F0502020204030204"/>
-                <a:ea typeface="+mn-ea"/>
-                <a:cs typeface="+mn-cs"/>
-              </a:rPr>
-              <a:t>4. So there is a pretty cool thing that once a spherical potential is emitted, the origin of that sphere never changes.  Only the radius increases. Meanwhile the point potential has moved on continuously emitting new potential spheres.  So the potential wake is kind of like a boat in a lake, except we are in 3D space not flatland. </a:t>
-            </a:r>
-          </a:p>
-          <a:p>
-            <a:pPr marL="0" marR="0" lvl="0" indent="0" algn="l" defTabSz="914400" rtl="0" eaLnBrk="1" fontAlgn="auto" latinLnBrk="0" hangingPunct="1">
-              <a:lnSpc>
-                <a:spcPct val="100000"/>
-              </a:lnSpc>
-              <a:spcBef>
-                <a:spcPts val="0"/>
-              </a:spcBef>
-              <a:spcAft>
-                <a:spcPts val="0"/>
-              </a:spcAft>
-              <a:buClrTx/>
-              <a:buSzTx/>
-              <a:buFontTx/>
-              <a:buNone/>
-              <a:tabLst/>
-              <a:defRPr/>
-            </a:pPr>
-            <a:r>
-              <a:rPr kumimoji="0" lang="en-US" sz="1600" b="0" i="0" u="none" strike="noStrike" kern="1200" cap="none" spc="0" normalizeH="0" baseline="0" noProof="0" dirty="0">
-                <a:ln>
-                  <a:noFill/>
-                </a:ln>
-                <a:solidFill>
-                  <a:prstClr val="white"/>
-                </a:solidFill>
-                <a:effectLst/>
-                <a:uLnTx/>
-                <a:uFillTx/>
-                <a:latin typeface="Calibri" panose="020F0502020204030204"/>
-                <a:ea typeface="+mn-ea"/>
-                <a:cs typeface="+mn-cs"/>
-              </a:rPr>
-              <a:t>5. Now it gets kind of cool to start thinking about the relationship between the point potentials. Let's examine the sphere A emits at T0. It takes some time to reach B. When the sphere intersects B, we still know the origin of the sphere and can do math. But also we have to consider the velocity of A when that potential sphere was emitted, because it affects the gradient of potential that B experiences. We also have to consider B's velocity. There is a general formula in here which needs to be developed. It might look like </a:t>
-            </a:r>
-            <a:r>
-              <a:rPr kumimoji="0" lang="en-US" sz="1600" b="0" i="0" u="none" strike="noStrike" kern="1200" cap="none" spc="0" normalizeH="0" baseline="0" noProof="0" dirty="0" err="1">
-                <a:ln>
-                  <a:noFill/>
-                </a:ln>
-                <a:solidFill>
-                  <a:prstClr val="white"/>
-                </a:solidFill>
-                <a:effectLst/>
-                <a:uLnTx/>
-                <a:uFillTx/>
-                <a:latin typeface="Calibri" panose="020F0502020204030204"/>
-                <a:ea typeface="+mn-ea"/>
-                <a:cs typeface="+mn-cs"/>
-              </a:rPr>
-              <a:t>Lienard</a:t>
-            </a:r>
-            <a:r>
-              <a:rPr kumimoji="0" lang="en-US" sz="1600" b="0" i="0" u="none" strike="noStrike" kern="1200" cap="none" spc="0" normalizeH="0" baseline="0" noProof="0" dirty="0">
-                <a:ln>
-                  <a:noFill/>
-                </a:ln>
-                <a:solidFill>
-                  <a:prstClr val="white"/>
-                </a:solidFill>
-                <a:effectLst/>
-                <a:uLnTx/>
-                <a:uFillTx/>
-                <a:latin typeface="Calibri" panose="020F0502020204030204"/>
-                <a:ea typeface="+mn-ea"/>
-                <a:cs typeface="+mn-cs"/>
-              </a:rPr>
-              <a:t>/</a:t>
-            </a:r>
-            <a:r>
-              <a:rPr kumimoji="0" lang="en-US" sz="1600" b="0" i="0" u="none" strike="noStrike" kern="1200" cap="none" spc="0" normalizeH="0" baseline="0" noProof="0" dirty="0" err="1">
-                <a:ln>
-                  <a:noFill/>
-                </a:ln>
-                <a:solidFill>
-                  <a:prstClr val="white"/>
-                </a:solidFill>
-                <a:effectLst/>
-                <a:uLnTx/>
-                <a:uFillTx/>
-                <a:latin typeface="Calibri" panose="020F0502020204030204"/>
-                <a:ea typeface="+mn-ea"/>
-                <a:cs typeface="+mn-cs"/>
-              </a:rPr>
-              <a:t>Wiechert</a:t>
-            </a:r>
-            <a:r>
-              <a:rPr kumimoji="0" lang="en-US" sz="1600" b="0" i="0" u="none" strike="noStrike" kern="1200" cap="none" spc="0" normalizeH="0" baseline="0" noProof="0" dirty="0">
-                <a:ln>
-                  <a:noFill/>
-                </a:ln>
-                <a:solidFill>
-                  <a:prstClr val="white"/>
-                </a:solidFill>
-                <a:effectLst/>
-                <a:uLnTx/>
-                <a:uFillTx/>
-                <a:latin typeface="Calibri" panose="020F0502020204030204"/>
-                <a:ea typeface="+mn-ea"/>
-                <a:cs typeface="+mn-cs"/>
-              </a:rPr>
-              <a:t>/</a:t>
-            </a:r>
-            <a:r>
-              <a:rPr kumimoji="0" lang="en-US" sz="1600" b="0" i="0" u="none" strike="noStrike" kern="1200" cap="none" spc="0" normalizeH="0" baseline="0" noProof="0" dirty="0" err="1">
-                <a:ln>
-                  <a:noFill/>
-                </a:ln>
-                <a:solidFill>
-                  <a:prstClr val="white"/>
-                </a:solidFill>
-                <a:effectLst/>
-                <a:uLnTx/>
-                <a:uFillTx/>
-                <a:latin typeface="Calibri" panose="020F0502020204030204"/>
-                <a:ea typeface="+mn-ea"/>
-                <a:cs typeface="+mn-cs"/>
-              </a:rPr>
-              <a:t>Jeffimenko</a:t>
-            </a:r>
-            <a:r>
-              <a:rPr kumimoji="0" lang="en-US" sz="1600" b="0" i="0" u="none" strike="noStrike" kern="1200" cap="none" spc="0" normalizeH="0" baseline="0" noProof="0" dirty="0">
-                <a:ln>
-                  <a:noFill/>
-                </a:ln>
-                <a:solidFill>
-                  <a:prstClr val="white"/>
-                </a:solidFill>
-                <a:effectLst/>
-                <a:uLnTx/>
-                <a:uFillTx/>
-                <a:latin typeface="Calibri" panose="020F0502020204030204"/>
-                <a:ea typeface="+mn-ea"/>
-                <a:cs typeface="+mn-cs"/>
-              </a:rPr>
-              <a:t> math. Not sure yet. </a:t>
-            </a:r>
-          </a:p>
-          <a:p>
-            <a:pPr marL="0" marR="0" lvl="0" indent="0" algn="l" defTabSz="914400" rtl="0" eaLnBrk="1" fontAlgn="auto" latinLnBrk="0" hangingPunct="1">
-              <a:lnSpc>
-                <a:spcPct val="100000"/>
-              </a:lnSpc>
-              <a:spcBef>
-                <a:spcPts val="0"/>
-              </a:spcBef>
-              <a:spcAft>
-                <a:spcPts val="0"/>
-              </a:spcAft>
-              <a:buClrTx/>
-              <a:buSzTx/>
-              <a:buFontTx/>
-              <a:buNone/>
-              <a:tabLst/>
-              <a:defRPr/>
-            </a:pPr>
-            <a:r>
-              <a:rPr kumimoji="0" lang="en-US" sz="1600" b="0" i="0" u="none" strike="noStrike" kern="1200" cap="none" spc="0" normalizeH="0" baseline="0" noProof="0" dirty="0">
-                <a:ln>
-                  <a:noFill/>
-                </a:ln>
-                <a:solidFill>
-                  <a:prstClr val="white"/>
-                </a:solidFill>
-                <a:effectLst/>
-                <a:uLnTx/>
-                <a:uFillTx/>
-                <a:latin typeface="Calibri" panose="020F0502020204030204"/>
-                <a:ea typeface="+mn-ea"/>
-                <a:cs typeface="+mn-cs"/>
-              </a:rPr>
-              <a:t>6. Let's use the term potential sphere stream to describe each point potential emitting a stream of expanding spherical potentials. The stream also encodes the velocity of the emitting point potential, by nature of the moving origin. </a:t>
-            </a:r>
-          </a:p>
-          <a:p>
-            <a:pPr marL="0" marR="0" lvl="0" indent="0" algn="l" defTabSz="914400" rtl="0" eaLnBrk="1" fontAlgn="auto" latinLnBrk="0" hangingPunct="1">
-              <a:lnSpc>
-                <a:spcPct val="100000"/>
-              </a:lnSpc>
-              <a:spcBef>
-                <a:spcPts val="0"/>
-              </a:spcBef>
-              <a:spcAft>
-                <a:spcPts val="0"/>
-              </a:spcAft>
-              <a:buClrTx/>
-              <a:buSzTx/>
-              <a:buFontTx/>
-              <a:buNone/>
-              <a:tabLst/>
-              <a:defRPr/>
-            </a:pPr>
-            <a:r>
-              <a:rPr kumimoji="0" lang="en-US" sz="1600" b="0" i="0" u="none" strike="noStrike" kern="1200" cap="none" spc="0" normalizeH="0" baseline="0" noProof="0" dirty="0">
-                <a:ln>
-                  <a:noFill/>
-                </a:ln>
-                <a:solidFill>
-                  <a:prstClr val="white"/>
-                </a:solidFill>
-                <a:effectLst/>
-                <a:uLnTx/>
-                <a:uFillTx/>
-                <a:latin typeface="Calibri" panose="020F0502020204030204"/>
-                <a:ea typeface="+mn-ea"/>
-                <a:cs typeface="+mn-cs"/>
-              </a:rPr>
-              <a:t>7. When the potential sphere emitted at T0 arrives, in the potential sphere stream from A, then action will occur and the path of B will be impacted. But B is also emitting a potential sphere stream that impacts A after the travel time delay. So there is a feedback cycle with a variable delay that is dependent on both A and B's path.</a:t>
-            </a:r>
-          </a:p>
-          <a:p>
-            <a:pPr marL="0" marR="0" lvl="0" indent="0" algn="l" defTabSz="914400" rtl="0" eaLnBrk="1" fontAlgn="auto" latinLnBrk="0" hangingPunct="1">
-              <a:lnSpc>
-                <a:spcPct val="100000"/>
-              </a:lnSpc>
-              <a:spcBef>
-                <a:spcPts val="0"/>
-              </a:spcBef>
-              <a:spcAft>
-                <a:spcPts val="0"/>
-              </a:spcAft>
-              <a:buClrTx/>
-              <a:buSzTx/>
-              <a:buFontTx/>
-              <a:buNone/>
-              <a:tabLst/>
-              <a:defRPr/>
-            </a:pPr>
-            <a:r>
-              <a:rPr kumimoji="0" lang="en-US" sz="1600" b="0" i="0" u="none" strike="noStrike" kern="1200" cap="none" spc="0" normalizeH="0" baseline="0" noProof="0" dirty="0">
-                <a:ln>
-                  <a:noFill/>
-                </a:ln>
-                <a:solidFill>
-                  <a:prstClr val="white"/>
-                </a:solidFill>
-                <a:effectLst/>
-                <a:uLnTx/>
-                <a:uFillTx/>
-                <a:latin typeface="Calibri" panose="020F0502020204030204"/>
-                <a:ea typeface="+mn-ea"/>
-                <a:cs typeface="+mn-cs"/>
-              </a:rPr>
-              <a:t>8. I was just thinking the other day how to enhance the picture to show the continuous potential sphere streams from A passing B and causing action, and vice versa. I'd like to somehow capture this dynamic feedback cycle. </a:t>
-            </a:r>
-          </a:p>
-          <a:p>
-            <a:pPr marL="0" marR="0" lvl="0" indent="0" algn="l" defTabSz="914400" rtl="0" eaLnBrk="1" fontAlgn="auto" latinLnBrk="0" hangingPunct="1">
-              <a:lnSpc>
-                <a:spcPct val="100000"/>
-              </a:lnSpc>
-              <a:spcBef>
-                <a:spcPts val="0"/>
-              </a:spcBef>
-              <a:spcAft>
-                <a:spcPts val="0"/>
-              </a:spcAft>
-              <a:buClrTx/>
-              <a:buSzTx/>
-              <a:buFontTx/>
-              <a:buNone/>
-              <a:tabLst/>
-              <a:defRPr/>
-            </a:pPr>
-            <a:r>
-              <a:rPr kumimoji="0" lang="en-US" sz="1600" b="0" i="0" u="none" strike="noStrike" kern="1200" cap="none" spc="0" normalizeH="0" baseline="0" noProof="0" dirty="0">
-                <a:ln>
-                  <a:noFill/>
-                </a:ln>
-                <a:solidFill>
-                  <a:prstClr val="white"/>
-                </a:solidFill>
-                <a:effectLst/>
-                <a:uLnTx/>
-                <a:uFillTx/>
-                <a:latin typeface="Calibri" panose="020F0502020204030204"/>
-                <a:ea typeface="+mn-ea"/>
-                <a:cs typeface="+mn-cs"/>
-              </a:rPr>
-              <a:t>9. I think there is probably some incredible math just in this interaction. I don't know if that math has already been done. Perhaps.  I doubt anyone has considered the case when point potential velocity equals or exceeds field speed. That is an unexplored regime.  </a:t>
-            </a:r>
-          </a:p>
-          <a:p>
-            <a:pPr marL="0" marR="0" lvl="0" indent="0" algn="l" defTabSz="914400" rtl="0" eaLnBrk="1" fontAlgn="auto" latinLnBrk="0" hangingPunct="1">
-              <a:lnSpc>
-                <a:spcPct val="100000"/>
-              </a:lnSpc>
-              <a:spcBef>
-                <a:spcPts val="0"/>
-              </a:spcBef>
-              <a:spcAft>
-                <a:spcPts val="0"/>
-              </a:spcAft>
-              <a:buClrTx/>
-              <a:buSzTx/>
-              <a:buFontTx/>
-              <a:buNone/>
-              <a:tabLst/>
-              <a:defRPr/>
-            </a:pPr>
-            <a:endParaRPr kumimoji="0" lang="en-US" sz="1600" b="0" i="0" u="none" strike="noStrike" kern="1200" cap="none" spc="0" normalizeH="0" baseline="0" noProof="0" dirty="0">
-              <a:ln>
-                <a:noFill/>
-              </a:ln>
-              <a:solidFill>
-                <a:prstClr val="white"/>
-              </a:solidFill>
-              <a:effectLst/>
-              <a:uLnTx/>
-              <a:uFillTx/>
-              <a:latin typeface="Calibri" panose="020F0502020204030204"/>
-              <a:ea typeface="+mn-ea"/>
-              <a:cs typeface="+mn-cs"/>
-            </a:endParaRPr>
-          </a:p>
-          <a:p>
-            <a:pPr marL="0" marR="0" lvl="0" indent="0" algn="l" defTabSz="914400" rtl="0" eaLnBrk="1" fontAlgn="auto" latinLnBrk="0" hangingPunct="1">
-              <a:lnSpc>
-                <a:spcPct val="100000"/>
-              </a:lnSpc>
-              <a:spcBef>
-                <a:spcPts val="0"/>
-              </a:spcBef>
-              <a:spcAft>
-                <a:spcPts val="0"/>
-              </a:spcAft>
-              <a:buClrTx/>
-              <a:buSzTx/>
-              <a:buFontTx/>
-              <a:buNone/>
-              <a:tabLst/>
-              <a:defRPr/>
-            </a:pPr>
-            <a:r>
-              <a:rPr kumimoji="0" lang="en-US" sz="1600" b="0" i="0" u="none" strike="noStrike" kern="1200" cap="none" spc="0" normalizeH="0" baseline="0" noProof="0" dirty="0">
-                <a:ln>
-                  <a:noFill/>
-                </a:ln>
-                <a:solidFill>
-                  <a:prstClr val="white"/>
-                </a:solidFill>
-                <a:effectLst/>
-                <a:uLnTx/>
-                <a:uFillTx/>
-                <a:latin typeface="Calibri" panose="020F0502020204030204"/>
-                <a:ea typeface="+mn-ea"/>
-                <a:cs typeface="+mn-cs"/>
-              </a:rPr>
-              <a:t>My recommendation is to use your imagination to visualize the dynamical geometry and the potential sphere streams and the paths.  For me that leads to a lot of insight.   </a:t>
-            </a:r>
-          </a:p>
-        </p:txBody>
-      </p:sp>
-    </p:spTree>
-    <p:extLst>
-      <p:ext uri="{BB962C8B-B14F-4D97-AF65-F5344CB8AC3E}">
-        <p14:creationId xmlns:p14="http://schemas.microsoft.com/office/powerpoint/2010/main" val="4219678445"/>
-      </p:ext>
-    </p:extLst>
-  </p:cSld>
-  <p:clrMapOvr>
-    <a:masterClrMapping/>
-  </p:clrMapOvr>
-</p:sld>
-</file>
-
-<file path=ppt/slides/slide11.xml><?xml version="1.0" encoding="utf-8"?>
 <p:sld xmlns:a="http://schemas.openxmlformats.org/drawingml/2006/main" xmlns:r="http://schemas.openxmlformats.org/officeDocument/2006/relationships" xmlns:p="http://schemas.openxmlformats.org/presentationml/2006/main">
   <p:cSld>
     <p:bg>
@@ -11870,7 +10071,7 @@
 </p:sld>
 </file>
 
-<file path=ppt/slides/slide12.xml><?xml version="1.0" encoding="utf-8"?>
+<file path=ppt/slides/slide11.xml><?xml version="1.0" encoding="utf-8"?>
 <p:sld xmlns:a="http://schemas.openxmlformats.org/drawingml/2006/main" xmlns:r="http://schemas.openxmlformats.org/officeDocument/2006/relationships" xmlns:p="http://schemas.openxmlformats.org/presentationml/2006/main">
   <p:cSld>
     <p:bg>
@@ -13612,7 +11813,7 @@
 </p:sld>
 </file>
 
-<file path=ppt/slides/slide13.xml><?xml version="1.0" encoding="utf-8"?>
+<file path=ppt/slides/slide12.xml><?xml version="1.0" encoding="utf-8"?>
 <p:sld xmlns:a="http://schemas.openxmlformats.org/drawingml/2006/main" xmlns:r="http://schemas.openxmlformats.org/officeDocument/2006/relationships" xmlns:p="http://schemas.openxmlformats.org/presentationml/2006/main">
   <p:cSld>
     <p:bg>
@@ -20106,7 +18307,7 @@
 </p:sld>
 </file>
 
-<file path=ppt/slides/slide14.xml><?xml version="1.0" encoding="utf-8"?>
+<file path=ppt/slides/slide13.xml><?xml version="1.0" encoding="utf-8"?>
 <p:sld xmlns:a="http://schemas.openxmlformats.org/drawingml/2006/main" xmlns:r="http://schemas.openxmlformats.org/officeDocument/2006/relationships" xmlns:p="http://schemas.openxmlformats.org/presentationml/2006/main">
   <p:cSld>
     <p:bg>
@@ -20731,7 +18932,7 @@
 </p:sld>
 </file>
 
-<file path=ppt/slides/slide15.xml><?xml version="1.0" encoding="utf-8"?>
+<file path=ppt/slides/slide14.xml><?xml version="1.0" encoding="utf-8"?>
 <p:sld xmlns:a="http://schemas.openxmlformats.org/drawingml/2006/main" xmlns:r="http://schemas.openxmlformats.org/officeDocument/2006/relationships" xmlns:p="http://schemas.openxmlformats.org/presentationml/2006/main">
   <p:cSld>
     <p:bg>
@@ -21986,7 +20187,7 @@
 </p:sld>
 </file>
 
-<file path=ppt/slides/slide16.xml><?xml version="1.0" encoding="utf-8"?>
+<file path=ppt/slides/slide15.xml><?xml version="1.0" encoding="utf-8"?>
 <p:sld xmlns:a="http://schemas.openxmlformats.org/drawingml/2006/main" xmlns:r="http://schemas.openxmlformats.org/officeDocument/2006/relationships" xmlns:p="http://schemas.openxmlformats.org/presentationml/2006/main">
   <p:cSld>
     <p:bg>
@@ -24753,427 +22954,6 @@
 </file>
 
 <file path=ppt/slides/slide3.xml><?xml version="1.0" encoding="utf-8"?>
-<p:sld xmlns:a="http://schemas.openxmlformats.org/drawingml/2006/main" xmlns:r="http://schemas.openxmlformats.org/officeDocument/2006/relationships" xmlns:p="http://schemas.openxmlformats.org/presentationml/2006/main">
-  <p:cSld>
-    <p:bg>
-      <p:bgPr>
-        <a:solidFill>
-          <a:schemeClr val="tx1"/>
-        </a:solidFill>
-        <a:effectLst/>
-      </p:bgPr>
-    </p:bg>
-    <p:spTree>
-      <p:nvGrpSpPr>
-        <p:cNvPr id="1" name=""/>
-        <p:cNvGrpSpPr/>
-        <p:nvPr/>
-      </p:nvGrpSpPr>
-      <p:grpSpPr>
-        <a:xfrm>
-          <a:off x="0" y="0"/>
-          <a:ext cx="0" cy="0"/>
-          <a:chOff x="0" y="0"/>
-          <a:chExt cx="0" cy="0"/>
-        </a:xfrm>
-      </p:grpSpPr>
-      <p:sp>
-        <p:nvSpPr>
-          <p:cNvPr id="9" name="Rectangle 8">
-            <a:extLst>
-              <a:ext uri="{FF2B5EF4-FFF2-40B4-BE49-F238E27FC236}">
-                <a16:creationId xmlns:a16="http://schemas.microsoft.com/office/drawing/2014/main" id="{2A8AA5BC-4F7A-4226-8F99-6D824B226A97}"/>
-              </a:ext>
-              <a:ext uri="{C183D7F6-B498-43B3-948B-1728B52AA6E4}">
-                <adec:decorative xmlns:adec="http://schemas.microsoft.com/office/drawing/2017/decorative" val="1"/>
-              </a:ext>
-            </a:extLst>
-          </p:cNvPr>
-          <p:cNvSpPr>
-            <a:spLocks noGrp="1" noRot="1" noChangeAspect="1" noMove="1" noResize="1" noEditPoints="1" noAdjustHandles="1" noChangeArrowheads="1" noChangeShapeType="1" noTextEdit="1"/>
-          </p:cNvSpPr>
-          <p:nvPr>
-            <p:extLst>
-              <p:ext uri="{386F3935-93C4-4BCD-93E2-E3B085C9AB24}">
-                <p16:designElem xmlns:p16="http://schemas.microsoft.com/office/powerpoint/2015/main" val="1"/>
-              </p:ext>
-            </p:extLst>
-          </p:nvPr>
-        </p:nvSpPr>
-        <p:spPr>
-          <a:xfrm>
-            <a:off x="0" y="-3324"/>
-            <a:ext cx="12192000" cy="6861324"/>
-          </a:xfrm>
-          <a:prstGeom prst="rect">
-            <a:avLst/>
-          </a:prstGeom>
-          <a:solidFill>
-            <a:schemeClr val="tx1"/>
-          </a:solidFill>
-          <a:ln>
-            <a:noFill/>
-          </a:ln>
-        </p:spPr>
-        <p:style>
-          <a:lnRef idx="2">
-            <a:schemeClr val="accent1">
-              <a:shade val="50000"/>
-            </a:schemeClr>
-          </a:lnRef>
-          <a:fillRef idx="1">
-            <a:schemeClr val="accent1"/>
-          </a:fillRef>
-          <a:effectRef idx="0">
-            <a:schemeClr val="accent1"/>
-          </a:effectRef>
-          <a:fontRef idx="minor">
-            <a:schemeClr val="lt1"/>
-          </a:fontRef>
-        </p:style>
-        <p:txBody>
-          <a:bodyPr rtlCol="0" anchor="ctr"/>
-          <a:lstStyle/>
-          <a:p>
-            <a:pPr marL="0" marR="0" lvl="0" indent="0" algn="ctr" defTabSz="914400" rtl="0" eaLnBrk="1" fontAlgn="auto" latinLnBrk="0" hangingPunct="1">
-              <a:lnSpc>
-                <a:spcPct val="100000"/>
-              </a:lnSpc>
-              <a:spcBef>
-                <a:spcPts val="0"/>
-              </a:spcBef>
-              <a:spcAft>
-                <a:spcPts val="0"/>
-              </a:spcAft>
-              <a:buClrTx/>
-              <a:buSzTx/>
-              <a:buFontTx/>
-              <a:buNone/>
-              <a:tabLst/>
-              <a:defRPr/>
-            </a:pPr>
-            <a:endParaRPr kumimoji="0" lang="en-US" sz="1800" b="0" i="0" u="none" strike="noStrike" kern="1200" cap="none" spc="0" normalizeH="0" baseline="0" noProof="0">
-              <a:ln>
-                <a:noFill/>
-              </a:ln>
-              <a:solidFill>
-                <a:prstClr val="white"/>
-              </a:solidFill>
-              <a:effectLst/>
-              <a:uLnTx/>
-              <a:uFillTx/>
-              <a:latin typeface="Calibri" panose="020F0502020204030204"/>
-              <a:ea typeface="+mn-ea"/>
-              <a:cs typeface="+mn-cs"/>
-            </a:endParaRPr>
-          </a:p>
-        </p:txBody>
-      </p:sp>
-      <p:sp>
-        <p:nvSpPr>
-          <p:cNvPr id="11" name="Rectangle 10">
-            <a:extLst>
-              <a:ext uri="{FF2B5EF4-FFF2-40B4-BE49-F238E27FC236}">
-                <a16:creationId xmlns:a16="http://schemas.microsoft.com/office/drawing/2014/main" id="{3E5445C6-DD42-4979-86FF-03730E8C6DB0}"/>
-              </a:ext>
-              <a:ext uri="{C183D7F6-B498-43B3-948B-1728B52AA6E4}">
-                <adec:decorative xmlns:adec="http://schemas.microsoft.com/office/drawing/2017/decorative" val="1"/>
-              </a:ext>
-            </a:extLst>
-          </p:cNvPr>
-          <p:cNvSpPr>
-            <a:spLocks noGrp="1" noRot="1" noChangeAspect="1" noMove="1" noResize="1" noEditPoints="1" noAdjustHandles="1" noChangeArrowheads="1" noChangeShapeType="1" noTextEdit="1"/>
-          </p:cNvSpPr>
-          <p:nvPr>
-            <p:extLst>
-              <p:ext uri="{386F3935-93C4-4BCD-93E2-E3B085C9AB24}">
-                <p16:designElem xmlns:p16="http://schemas.microsoft.com/office/powerpoint/2015/main" val="1"/>
-              </p:ext>
-            </p:extLst>
-          </p:nvPr>
-        </p:nvSpPr>
-        <p:spPr bwMode="ltGray">
-          <a:xfrm>
-            <a:off x="321734" y="321733"/>
-            <a:ext cx="11573488" cy="6214534"/>
-          </a:xfrm>
-          <a:prstGeom prst="rect">
-            <a:avLst/>
-          </a:prstGeom>
-          <a:solidFill>
-            <a:schemeClr val="bg1">
-              <a:lumMod val="75000"/>
-              <a:lumOff val="25000"/>
-            </a:schemeClr>
-          </a:solidFill>
-          <a:ln w="127000" cap="sq" cmpd="thinThick">
-            <a:solidFill>
-              <a:schemeClr val="bg1">
-                <a:lumMod val="75000"/>
-                <a:lumOff val="25000"/>
-              </a:schemeClr>
-            </a:solidFill>
-          </a:ln>
-        </p:spPr>
-        <p:style>
-          <a:lnRef idx="2">
-            <a:schemeClr val="accent1">
-              <a:shade val="50000"/>
-            </a:schemeClr>
-          </a:lnRef>
-          <a:fillRef idx="1">
-            <a:schemeClr val="accent1"/>
-          </a:fillRef>
-          <a:effectRef idx="0">
-            <a:schemeClr val="accent1"/>
-          </a:effectRef>
-          <a:fontRef idx="minor">
-            <a:schemeClr val="lt1"/>
-          </a:fontRef>
-        </p:style>
-        <p:txBody>
-          <a:bodyPr rtlCol="0" anchor="ctr"/>
-          <a:lstStyle/>
-          <a:p>
-            <a:pPr marL="0" marR="0" lvl="0" indent="0" algn="ctr" defTabSz="914400" rtl="0" eaLnBrk="1" fontAlgn="auto" latinLnBrk="0" hangingPunct="1">
-              <a:lnSpc>
-                <a:spcPct val="100000"/>
-              </a:lnSpc>
-              <a:spcBef>
-                <a:spcPts val="0"/>
-              </a:spcBef>
-              <a:spcAft>
-                <a:spcPts val="0"/>
-              </a:spcAft>
-              <a:buClrTx/>
-              <a:buSzTx/>
-              <a:buFontTx/>
-              <a:buNone/>
-              <a:tabLst/>
-              <a:defRPr/>
-            </a:pPr>
-            <a:endParaRPr kumimoji="0" lang="en-US" sz="1800" b="0" i="0" u="none" strike="noStrike" kern="1200" cap="none" spc="0" normalizeH="0" baseline="0" noProof="0">
-              <a:ln>
-                <a:noFill/>
-              </a:ln>
-              <a:solidFill>
-                <a:prstClr val="white"/>
-              </a:solidFill>
-              <a:effectLst/>
-              <a:uLnTx/>
-              <a:uFillTx/>
-              <a:latin typeface="Calibri" panose="020F0502020204030204"/>
-              <a:ea typeface="+mn-ea"/>
-              <a:cs typeface="+mn-cs"/>
-            </a:endParaRPr>
-          </a:p>
-        </p:txBody>
-      </p:sp>
-      <p:sp>
-        <p:nvSpPr>
-          <p:cNvPr id="2" name="Title 1">
-            <a:extLst>
-              <a:ext uri="{FF2B5EF4-FFF2-40B4-BE49-F238E27FC236}">
-                <a16:creationId xmlns:a16="http://schemas.microsoft.com/office/drawing/2014/main" id="{7710B119-EC53-BA46-BAA3-CB758CDEDAF5}"/>
-              </a:ext>
-            </a:extLst>
-          </p:cNvPr>
-          <p:cNvSpPr>
-            <a:spLocks noGrp="1"/>
-          </p:cNvSpPr>
-          <p:nvPr>
-            <p:ph type="ctrTitle"/>
-          </p:nvPr>
-        </p:nvSpPr>
-        <p:spPr>
-          <a:xfrm>
-            <a:off x="1524000" y="1122362"/>
-            <a:ext cx="9144000" cy="2840037"/>
-          </a:xfrm>
-        </p:spPr>
-        <p:txBody>
-          <a:bodyPr>
-            <a:normAutofit/>
-          </a:bodyPr>
-          <a:lstStyle/>
-          <a:p>
-            <a:r>
-              <a:rPr lang="en-US" sz="5800" dirty="0"/>
-              <a:t>Thank You</a:t>
-            </a:r>
-          </a:p>
-        </p:txBody>
-      </p:sp>
-      <p:sp>
-        <p:nvSpPr>
-          <p:cNvPr id="3" name="Subtitle 2">
-            <a:extLst>
-              <a:ext uri="{FF2B5EF4-FFF2-40B4-BE49-F238E27FC236}">
-                <a16:creationId xmlns:a16="http://schemas.microsoft.com/office/drawing/2014/main" id="{44E6BC0E-0DB7-C346-A0CC-E3CB36C29A54}"/>
-              </a:ext>
-            </a:extLst>
-          </p:cNvPr>
-          <p:cNvSpPr>
-            <a:spLocks noGrp="1"/>
-          </p:cNvSpPr>
-          <p:nvPr>
-            <p:ph type="subTitle" idx="1"/>
-          </p:nvPr>
-        </p:nvSpPr>
-        <p:spPr>
-          <a:xfrm>
-            <a:off x="1524000" y="4256436"/>
-            <a:ext cx="9144000" cy="1600818"/>
-          </a:xfrm>
-        </p:spPr>
-        <p:txBody>
-          <a:bodyPr>
-            <a:normAutofit/>
-          </a:bodyPr>
-          <a:lstStyle/>
-          <a:p>
-            <a:r>
-              <a:rPr lang="en-US" dirty="0"/>
-              <a:t>Questions?</a:t>
-            </a:r>
-          </a:p>
-        </p:txBody>
-      </p:sp>
-      <p:cxnSp>
-        <p:nvCxnSpPr>
-          <p:cNvPr id="13" name="Straight Connector 12">
-            <a:extLst>
-              <a:ext uri="{FF2B5EF4-FFF2-40B4-BE49-F238E27FC236}">
-                <a16:creationId xmlns:a16="http://schemas.microsoft.com/office/drawing/2014/main" id="{45000665-DFC7-417E-8FD7-516A0F15C975}"/>
-              </a:ext>
-              <a:ext uri="{C183D7F6-B498-43B3-948B-1728B52AA6E4}">
-                <adec:decorative xmlns:adec="http://schemas.microsoft.com/office/drawing/2017/decorative" val="1"/>
-              </a:ext>
-            </a:extLst>
-          </p:cNvPr>
-          <p:cNvCxnSpPr>
-            <a:cxnSpLocks noGrp="1" noRot="1" noChangeAspect="1" noMove="1" noResize="1" noEditPoints="1" noAdjustHandles="1" noChangeArrowheads="1" noChangeShapeType="1"/>
-          </p:cNvCxnSpPr>
-          <p:nvPr>
-            <p:extLst>
-              <p:ext uri="{386F3935-93C4-4BCD-93E2-E3B085C9AB24}">
-                <p16:designElem xmlns:p16="http://schemas.microsoft.com/office/powerpoint/2015/main" val="1"/>
-              </p:ext>
-            </p:extLst>
-          </p:nvPr>
-        </p:nvCxnSpPr>
-        <p:spPr>
-          <a:xfrm>
-            <a:off x="4724400" y="4109417"/>
-            <a:ext cx="2743200" cy="0"/>
-          </a:xfrm>
-          <a:prstGeom prst="line">
-            <a:avLst/>
-          </a:prstGeom>
-          <a:ln w="12700">
-            <a:solidFill>
-              <a:schemeClr val="tx1">
-                <a:lumMod val="85000"/>
-              </a:schemeClr>
-            </a:solidFill>
-          </a:ln>
-        </p:spPr>
-        <p:style>
-          <a:lnRef idx="1">
-            <a:schemeClr val="accent1"/>
-          </a:lnRef>
-          <a:fillRef idx="0">
-            <a:schemeClr val="accent1"/>
-          </a:fillRef>
-          <a:effectRef idx="0">
-            <a:schemeClr val="accent1"/>
-          </a:effectRef>
-          <a:fontRef idx="minor">
-            <a:schemeClr val="tx1"/>
-          </a:fontRef>
-        </p:style>
-      </p:cxnSp>
-      <p:sp>
-        <p:nvSpPr>
-          <p:cNvPr id="4" name="Footer Placeholder 3">
-            <a:extLst>
-              <a:ext uri="{FF2B5EF4-FFF2-40B4-BE49-F238E27FC236}">
-                <a16:creationId xmlns:a16="http://schemas.microsoft.com/office/drawing/2014/main" id="{9E726E67-7B90-B642-8D26-6DDF890C4785}"/>
-              </a:ext>
-            </a:extLst>
-          </p:cNvPr>
-          <p:cNvSpPr>
-            <a:spLocks noGrp="1"/>
-          </p:cNvSpPr>
-          <p:nvPr>
-            <p:ph type="ftr" sz="quarter" idx="11"/>
-          </p:nvPr>
-        </p:nvSpPr>
-        <p:spPr>
-          <a:xfrm>
-            <a:off x="4038600" y="6159710"/>
-            <a:ext cx="4114800" cy="365125"/>
-          </a:xfrm>
-        </p:spPr>
-        <p:txBody>
-          <a:bodyPr>
-            <a:normAutofit/>
-          </a:bodyPr>
-          <a:lstStyle/>
-          <a:p>
-            <a:pPr marL="0" marR="0" lvl="0" indent="0" algn="ctr" defTabSz="914400" rtl="0" eaLnBrk="1" fontAlgn="auto" latinLnBrk="0" hangingPunct="1">
-              <a:lnSpc>
-                <a:spcPct val="100000"/>
-              </a:lnSpc>
-              <a:spcBef>
-                <a:spcPts val="0"/>
-              </a:spcBef>
-              <a:spcAft>
-                <a:spcPts val="600"/>
-              </a:spcAft>
-              <a:buClrTx/>
-              <a:buSzTx/>
-              <a:buFontTx/>
-              <a:buNone/>
-              <a:tabLst/>
-              <a:defRPr/>
-            </a:pPr>
-            <a:r>
-              <a:rPr kumimoji="0" lang="en-US" sz="1200" b="0" i="0" u="none" strike="noStrike" kern="1200" cap="none" spc="0" normalizeH="0" baseline="0" noProof="0" dirty="0">
-                <a:ln>
-                  <a:noFill/>
-                </a:ln>
-                <a:solidFill>
-                  <a:prstClr val="white">
-                    <a:tint val="75000"/>
-                  </a:prstClr>
-                </a:solidFill>
-                <a:effectLst/>
-                <a:uLnTx/>
-                <a:uFillTx/>
-                <a:latin typeface="Helvetica Neue" panose="02000503000000020004" pitchFamily="2" charset="0"/>
-                <a:ea typeface="Helvetica Neue" panose="02000503000000020004" pitchFamily="2" charset="0"/>
-                <a:cs typeface="Helvetica Neue" panose="02000503000000020004" pitchFamily="2" charset="0"/>
-              </a:rPr>
-              <a:t>J Mark Morris - Model of Nature</a:t>
-            </a:r>
-          </a:p>
-        </p:txBody>
-      </p:sp>
-    </p:spTree>
-    <p:extLst>
-      <p:ext uri="{BB962C8B-B14F-4D97-AF65-F5344CB8AC3E}">
-        <p14:creationId xmlns:p14="http://schemas.microsoft.com/office/powerpoint/2010/main" val="3747833275"/>
-      </p:ext>
-    </p:extLst>
-  </p:cSld>
-  <p:clrMapOvr>
-    <a:overrideClrMapping bg1="dk1" tx1="lt1" bg2="dk2" tx2="lt2" accent1="accent1" accent2="accent2" accent3="accent3" accent4="accent4" accent5="accent5" accent6="accent6" hlink="hlink" folHlink="folHlink"/>
-  </p:clrMapOvr>
-</p:sld>
-</file>
-
-<file path=ppt/slides/slide4.xml><?xml version="1.0" encoding="utf-8"?>
 <p:sld xmlns:a="http://schemas.openxmlformats.org/drawingml/2006/main" xmlns:r="http://schemas.openxmlformats.org/officeDocument/2006/relationships" xmlns:p="http://schemas.openxmlformats.org/presentationml/2006/main">
   <p:cSld>
     <p:bg>
@@ -28201,7 +25981,7 @@
 </p:sld>
 </file>
 
-<file path=ppt/slides/slide5.xml><?xml version="1.0" encoding="utf-8"?>
+<file path=ppt/slides/slide4.xml><?xml version="1.0" encoding="utf-8"?>
 <p:sld xmlns:a="http://schemas.openxmlformats.org/drawingml/2006/main" xmlns:r="http://schemas.openxmlformats.org/officeDocument/2006/relationships" xmlns:p="http://schemas.openxmlformats.org/presentationml/2006/main">
   <p:cSld>
     <p:bg>
@@ -30801,7 +28581,7 @@
 </p:sld>
 </file>
 
-<file path=ppt/slides/slide6.xml><?xml version="1.0" encoding="utf-8"?>
+<file path=ppt/slides/slide5.xml><?xml version="1.0" encoding="utf-8"?>
 <p:sld xmlns:a="http://schemas.openxmlformats.org/drawingml/2006/main" xmlns:r="http://schemas.openxmlformats.org/officeDocument/2006/relationships" xmlns:p="http://schemas.openxmlformats.org/presentationml/2006/main">
   <p:cSld>
     <p:bg>
@@ -31661,7 +29441,7 @@
 </p:sld>
 </file>
 
-<file path=ppt/slides/slide7.xml><?xml version="1.0" encoding="utf-8"?>
+<file path=ppt/slides/slide6.xml><?xml version="1.0" encoding="utf-8"?>
 <p:sld xmlns:a="http://schemas.openxmlformats.org/drawingml/2006/main" xmlns:r="http://schemas.openxmlformats.org/officeDocument/2006/relationships" xmlns:p="http://schemas.openxmlformats.org/presentationml/2006/main">
   <p:cSld>
     <p:bg>
@@ -33529,7 +31309,7 @@
 </p:sld>
 </file>
 
-<file path=ppt/slides/slide8.xml><?xml version="1.0" encoding="utf-8"?>
+<file path=ppt/slides/slide7.xml><?xml version="1.0" encoding="utf-8"?>
 <p:sld xmlns:a="http://schemas.openxmlformats.org/drawingml/2006/main" xmlns:r="http://schemas.openxmlformats.org/officeDocument/2006/relationships" xmlns:p="http://schemas.openxmlformats.org/presentationml/2006/main">
   <p:cSld>
     <p:bg>
@@ -35313,7 +33093,7 @@
 </p:sld>
 </file>
 
-<file path=ppt/slides/slide9.xml><?xml version="1.0" encoding="utf-8"?>
+<file path=ppt/slides/slide8.xml><?xml version="1.0" encoding="utf-8"?>
 <p:sld xmlns:a="http://schemas.openxmlformats.org/drawingml/2006/main" xmlns:r="http://schemas.openxmlformats.org/officeDocument/2006/relationships" xmlns:p="http://schemas.openxmlformats.org/presentationml/2006/main">
   <p:cSld>
     <p:bg>
@@ -37278,6 +35058,638 @@
 </p:sld>
 </file>
 
+<file path=ppt/slides/slide9.xml><?xml version="1.0" encoding="utf-8"?>
+<p:sld xmlns:a="http://schemas.openxmlformats.org/drawingml/2006/main" xmlns:r="http://schemas.openxmlformats.org/officeDocument/2006/relationships" xmlns:p="http://schemas.openxmlformats.org/presentationml/2006/main">
+  <p:cSld>
+    <p:bg>
+      <p:bgPr>
+        <a:solidFill>
+          <a:srgbClr val="7030A0"/>
+        </a:solidFill>
+        <a:effectLst/>
+      </p:bgPr>
+    </p:bg>
+    <p:spTree>
+      <p:nvGrpSpPr>
+        <p:cNvPr id="1" name=""/>
+        <p:cNvGrpSpPr/>
+        <p:nvPr/>
+      </p:nvGrpSpPr>
+      <p:grpSpPr>
+        <a:xfrm>
+          <a:off x="0" y="0"/>
+          <a:ext cx="0" cy="0"/>
+          <a:chOff x="0" y="0"/>
+          <a:chExt cx="0" cy="0"/>
+        </a:xfrm>
+      </p:grpSpPr>
+      <p:sp>
+        <p:nvSpPr>
+          <p:cNvPr id="2" name="TextBox 1">
+            <a:extLst>
+              <a:ext uri="{FF2B5EF4-FFF2-40B4-BE49-F238E27FC236}">
+                <a16:creationId xmlns:a16="http://schemas.microsoft.com/office/drawing/2014/main" id="{018A63B5-40EC-8B9D-0CE4-CED6A7D3C146}"/>
+              </a:ext>
+            </a:extLst>
+          </p:cNvPr>
+          <p:cNvSpPr txBox="1"/>
+          <p:nvPr/>
+        </p:nvSpPr>
+        <p:spPr>
+          <a:xfrm>
+            <a:off x="-70338" y="0"/>
+            <a:ext cx="12262338" cy="6740307"/>
+          </a:xfrm>
+          <a:prstGeom prst="rect">
+            <a:avLst/>
+          </a:prstGeom>
+          <a:noFill/>
+        </p:spPr>
+        <p:txBody>
+          <a:bodyPr wrap="square" rtlCol="0">
+            <a:spAutoFit/>
+          </a:bodyPr>
+          <a:lstStyle/>
+          <a:p>
+            <a:pPr marL="0" marR="0" lvl="0" indent="0" algn="l" defTabSz="914400" rtl="0" eaLnBrk="1" fontAlgn="auto" latinLnBrk="0" hangingPunct="1">
+              <a:lnSpc>
+                <a:spcPct val="100000"/>
+              </a:lnSpc>
+              <a:spcBef>
+                <a:spcPts val="0"/>
+              </a:spcBef>
+              <a:spcAft>
+                <a:spcPts val="0"/>
+              </a:spcAft>
+              <a:buClrTx/>
+              <a:buSzTx/>
+              <a:buFontTx/>
+              <a:buNone/>
+              <a:tabLst/>
+              <a:defRPr/>
+            </a:pPr>
+            <a:r>
+              <a:rPr kumimoji="0" lang="en-US" sz="1600" b="0" i="0" u="none" strike="noStrike" kern="1200" cap="none" spc="0" normalizeH="0" baseline="0" noProof="0" dirty="0">
+                <a:ln>
+                  <a:noFill/>
+                </a:ln>
+                <a:solidFill>
+                  <a:prstClr val="white"/>
+                </a:solidFill>
+                <a:effectLst/>
+                <a:uLnTx/>
+                <a:uFillTx/>
+                <a:latin typeface="Calibri" panose="020F0502020204030204"/>
+                <a:ea typeface="+mn-ea"/>
+                <a:cs typeface="+mn-cs"/>
+              </a:rPr>
+              <a:t>It's like the classic history potential figure. However, if we really contemplated what is happening in this dynamical geometry between any two point potentials is this:</a:t>
+            </a:r>
+          </a:p>
+          <a:p>
+            <a:pPr marL="0" marR="0" lvl="0" indent="0" algn="l" defTabSz="914400" rtl="0" eaLnBrk="1" fontAlgn="auto" latinLnBrk="0" hangingPunct="1">
+              <a:lnSpc>
+                <a:spcPct val="100000"/>
+              </a:lnSpc>
+              <a:spcBef>
+                <a:spcPts val="0"/>
+              </a:spcBef>
+              <a:spcAft>
+                <a:spcPts val="0"/>
+              </a:spcAft>
+              <a:buClrTx/>
+              <a:buSzTx/>
+              <a:buFontTx/>
+              <a:buNone/>
+              <a:tabLst/>
+              <a:defRPr/>
+            </a:pPr>
+            <a:r>
+              <a:rPr kumimoji="0" lang="en-US" sz="1600" b="0" i="0" u="none" strike="noStrike" kern="1200" cap="none" spc="0" normalizeH="0" baseline="0" noProof="0" dirty="0">
+                <a:ln>
+                  <a:noFill/>
+                </a:ln>
+                <a:solidFill>
+                  <a:prstClr val="white"/>
+                </a:solidFill>
+                <a:effectLst/>
+                <a:uLnTx/>
+                <a:uFillTx/>
+                <a:latin typeface="Calibri" panose="020F0502020204030204"/>
+                <a:ea typeface="+mn-ea"/>
+                <a:cs typeface="+mn-cs"/>
+              </a:rPr>
+              <a:t>1. Point potentials follow continuous paths through R4 (t, </a:t>
+            </a:r>
+            <a:r>
+              <a:rPr kumimoji="0" lang="en-US" sz="1600" b="0" i="0" u="none" strike="noStrike" kern="1200" cap="none" spc="0" normalizeH="0" baseline="0" noProof="0" dirty="0" err="1">
+                <a:ln>
+                  <a:noFill/>
+                </a:ln>
+                <a:solidFill>
+                  <a:prstClr val="white"/>
+                </a:solidFill>
+                <a:effectLst/>
+                <a:uLnTx/>
+                <a:uFillTx/>
+                <a:latin typeface="Calibri" panose="020F0502020204030204"/>
+                <a:ea typeface="+mn-ea"/>
+                <a:cs typeface="+mn-cs"/>
+              </a:rPr>
+              <a:t>x,y,z</a:t>
+            </a:r>
+            <a:r>
+              <a:rPr kumimoji="0" lang="en-US" sz="1600" b="0" i="0" u="none" strike="noStrike" kern="1200" cap="none" spc="0" normalizeH="0" baseline="0" noProof="0" dirty="0">
+                <a:ln>
+                  <a:noFill/>
+                </a:ln>
+                <a:solidFill>
+                  <a:prstClr val="white"/>
+                </a:solidFill>
+                <a:effectLst/>
+                <a:uLnTx/>
+                <a:uFillTx/>
+                <a:latin typeface="Calibri" panose="020F0502020204030204"/>
+                <a:ea typeface="+mn-ea"/>
+                <a:cs typeface="+mn-cs"/>
+              </a:rPr>
+              <a:t>, x', y', z'). That is to say at any absolute time each point potential has a position in space and a velocity.</a:t>
+            </a:r>
+          </a:p>
+          <a:p>
+            <a:pPr marL="0" marR="0" lvl="0" indent="0" algn="l" defTabSz="914400" rtl="0" eaLnBrk="1" fontAlgn="auto" latinLnBrk="0" hangingPunct="1">
+              <a:lnSpc>
+                <a:spcPct val="100000"/>
+              </a:lnSpc>
+              <a:spcBef>
+                <a:spcPts val="0"/>
+              </a:spcBef>
+              <a:spcAft>
+                <a:spcPts val="0"/>
+              </a:spcAft>
+              <a:buClrTx/>
+              <a:buSzTx/>
+              <a:buFontTx/>
+              <a:buNone/>
+              <a:tabLst/>
+              <a:defRPr/>
+            </a:pPr>
+            <a:r>
+              <a:rPr kumimoji="0" lang="en-US" sz="1600" b="0" i="0" u="none" strike="noStrike" kern="1200" cap="none" spc="0" normalizeH="0" baseline="0" noProof="0" dirty="0">
+                <a:ln>
+                  <a:noFill/>
+                </a:ln>
+                <a:solidFill>
+                  <a:prstClr val="white"/>
+                </a:solidFill>
+                <a:effectLst/>
+                <a:uLnTx/>
+                <a:uFillTx/>
+                <a:latin typeface="Calibri" panose="020F0502020204030204"/>
+                <a:ea typeface="+mn-ea"/>
+                <a:cs typeface="+mn-cs"/>
+              </a:rPr>
+              <a:t>2. Now consider two point potentials each following their path under the influence of the arriving potential field. Let's limit ourselves to point potential velocities less than field speed, because it is a simpler case. </a:t>
+            </a:r>
+          </a:p>
+          <a:p>
+            <a:pPr marL="0" marR="0" lvl="0" indent="0" algn="l" defTabSz="914400" rtl="0" eaLnBrk="1" fontAlgn="auto" latinLnBrk="0" hangingPunct="1">
+              <a:lnSpc>
+                <a:spcPct val="100000"/>
+              </a:lnSpc>
+              <a:spcBef>
+                <a:spcPts val="0"/>
+              </a:spcBef>
+              <a:spcAft>
+                <a:spcPts val="0"/>
+              </a:spcAft>
+              <a:buClrTx/>
+              <a:buSzTx/>
+              <a:buFontTx/>
+              <a:buNone/>
+              <a:tabLst/>
+              <a:defRPr/>
+            </a:pPr>
+            <a:r>
+              <a:rPr kumimoji="0" lang="en-US" sz="1600" b="0" i="0" u="none" strike="noStrike" kern="1200" cap="none" spc="0" normalizeH="0" baseline="0" noProof="0" dirty="0">
+                <a:ln>
+                  <a:noFill/>
+                </a:ln>
+                <a:solidFill>
+                  <a:prstClr val="white"/>
+                </a:solidFill>
+                <a:effectLst/>
+                <a:uLnTx/>
+                <a:uFillTx/>
+                <a:latin typeface="Calibri" panose="020F0502020204030204"/>
+                <a:ea typeface="+mn-ea"/>
+                <a:cs typeface="+mn-cs"/>
+              </a:rPr>
+              <a:t>3. Each point potential is continuously emitting a spherical potential that starts at it's current location with radius 0 and expands such that radius is field speed multiplied by elapsed time since emission. We are using all Euclidean coordinates here in time and space, so everything is absolute. </a:t>
+            </a:r>
+          </a:p>
+          <a:p>
+            <a:pPr marL="0" marR="0" lvl="0" indent="0" algn="l" defTabSz="914400" rtl="0" eaLnBrk="1" fontAlgn="auto" latinLnBrk="0" hangingPunct="1">
+              <a:lnSpc>
+                <a:spcPct val="100000"/>
+              </a:lnSpc>
+              <a:spcBef>
+                <a:spcPts val="0"/>
+              </a:spcBef>
+              <a:spcAft>
+                <a:spcPts val="0"/>
+              </a:spcAft>
+              <a:buClrTx/>
+              <a:buSzTx/>
+              <a:buFontTx/>
+              <a:buNone/>
+              <a:tabLst/>
+              <a:defRPr/>
+            </a:pPr>
+            <a:r>
+              <a:rPr kumimoji="0" lang="en-US" sz="1600" b="0" i="0" u="none" strike="noStrike" kern="1200" cap="none" spc="0" normalizeH="0" baseline="0" noProof="0" dirty="0">
+                <a:ln>
+                  <a:noFill/>
+                </a:ln>
+                <a:solidFill>
+                  <a:prstClr val="white"/>
+                </a:solidFill>
+                <a:effectLst/>
+                <a:uLnTx/>
+                <a:uFillTx/>
+                <a:latin typeface="Calibri" panose="020F0502020204030204"/>
+                <a:ea typeface="+mn-ea"/>
+                <a:cs typeface="+mn-cs"/>
+              </a:rPr>
+              <a:t>4. So there is a pretty cool thing that once a spherical potential is emitted, the origin of that sphere never changes.  Only the radius increases. Meanwhile the point potential has moved on continuously emitting new potential spheres.  So the potential wake is kind of like a boat in a lake, except we are in 3D space not flatland. </a:t>
+            </a:r>
+          </a:p>
+          <a:p>
+            <a:pPr marL="0" marR="0" lvl="0" indent="0" algn="l" defTabSz="914400" rtl="0" eaLnBrk="1" fontAlgn="auto" latinLnBrk="0" hangingPunct="1">
+              <a:lnSpc>
+                <a:spcPct val="100000"/>
+              </a:lnSpc>
+              <a:spcBef>
+                <a:spcPts val="0"/>
+              </a:spcBef>
+              <a:spcAft>
+                <a:spcPts val="0"/>
+              </a:spcAft>
+              <a:buClrTx/>
+              <a:buSzTx/>
+              <a:buFontTx/>
+              <a:buNone/>
+              <a:tabLst/>
+              <a:defRPr/>
+            </a:pPr>
+            <a:r>
+              <a:rPr kumimoji="0" lang="en-US" sz="1600" b="0" i="0" u="none" strike="noStrike" kern="1200" cap="none" spc="0" normalizeH="0" baseline="0" noProof="0" dirty="0">
+                <a:ln>
+                  <a:noFill/>
+                </a:ln>
+                <a:solidFill>
+                  <a:prstClr val="white"/>
+                </a:solidFill>
+                <a:effectLst/>
+                <a:uLnTx/>
+                <a:uFillTx/>
+                <a:latin typeface="Calibri" panose="020F0502020204030204"/>
+                <a:ea typeface="+mn-ea"/>
+                <a:cs typeface="+mn-cs"/>
+              </a:rPr>
+              <a:t>5. Now it gets kind of cool to start thinking about the relationship between the point potentials. Let's examine the sphere A emits at T0. It takes some time to reach B. When the sphere intersects B, we still know the origin of the sphere and can do math. But also we have to consider the velocity of A when that potential sphere was emitted, because it affects the gradient of potential that B experiences. We also have to consider B's velocity. There is a general formula in here which needs to be developed. It might look like </a:t>
+            </a:r>
+            <a:r>
+              <a:rPr kumimoji="0" lang="en-US" sz="1600" b="0" i="0" u="none" strike="noStrike" kern="1200" cap="none" spc="0" normalizeH="0" baseline="0" noProof="0" dirty="0" err="1">
+                <a:ln>
+                  <a:noFill/>
+                </a:ln>
+                <a:solidFill>
+                  <a:prstClr val="white"/>
+                </a:solidFill>
+                <a:effectLst/>
+                <a:uLnTx/>
+                <a:uFillTx/>
+                <a:latin typeface="Calibri" panose="020F0502020204030204"/>
+                <a:ea typeface="+mn-ea"/>
+                <a:cs typeface="+mn-cs"/>
+              </a:rPr>
+              <a:t>Lienard</a:t>
+            </a:r>
+            <a:r>
+              <a:rPr kumimoji="0" lang="en-US" sz="1600" b="0" i="0" u="none" strike="noStrike" kern="1200" cap="none" spc="0" normalizeH="0" baseline="0" noProof="0" dirty="0">
+                <a:ln>
+                  <a:noFill/>
+                </a:ln>
+                <a:solidFill>
+                  <a:prstClr val="white"/>
+                </a:solidFill>
+                <a:effectLst/>
+                <a:uLnTx/>
+                <a:uFillTx/>
+                <a:latin typeface="Calibri" panose="020F0502020204030204"/>
+                <a:ea typeface="+mn-ea"/>
+                <a:cs typeface="+mn-cs"/>
+              </a:rPr>
+              <a:t>/</a:t>
+            </a:r>
+            <a:r>
+              <a:rPr kumimoji="0" lang="en-US" sz="1600" b="0" i="0" u="none" strike="noStrike" kern="1200" cap="none" spc="0" normalizeH="0" baseline="0" noProof="0" dirty="0" err="1">
+                <a:ln>
+                  <a:noFill/>
+                </a:ln>
+                <a:solidFill>
+                  <a:prstClr val="white"/>
+                </a:solidFill>
+                <a:effectLst/>
+                <a:uLnTx/>
+                <a:uFillTx/>
+                <a:latin typeface="Calibri" panose="020F0502020204030204"/>
+                <a:ea typeface="+mn-ea"/>
+                <a:cs typeface="+mn-cs"/>
+              </a:rPr>
+              <a:t>Wiechert</a:t>
+            </a:r>
+            <a:r>
+              <a:rPr kumimoji="0" lang="en-US" sz="1600" b="0" i="0" u="none" strike="noStrike" kern="1200" cap="none" spc="0" normalizeH="0" baseline="0" noProof="0" dirty="0">
+                <a:ln>
+                  <a:noFill/>
+                </a:ln>
+                <a:solidFill>
+                  <a:prstClr val="white"/>
+                </a:solidFill>
+                <a:effectLst/>
+                <a:uLnTx/>
+                <a:uFillTx/>
+                <a:latin typeface="Calibri" panose="020F0502020204030204"/>
+                <a:ea typeface="+mn-ea"/>
+                <a:cs typeface="+mn-cs"/>
+              </a:rPr>
+              <a:t>/</a:t>
+            </a:r>
+            <a:r>
+              <a:rPr kumimoji="0" lang="en-US" sz="1600" b="0" i="0" u="none" strike="noStrike" kern="1200" cap="none" spc="0" normalizeH="0" baseline="0" noProof="0" dirty="0" err="1">
+                <a:ln>
+                  <a:noFill/>
+                </a:ln>
+                <a:solidFill>
+                  <a:prstClr val="white"/>
+                </a:solidFill>
+                <a:effectLst/>
+                <a:uLnTx/>
+                <a:uFillTx/>
+                <a:latin typeface="Calibri" panose="020F0502020204030204"/>
+                <a:ea typeface="+mn-ea"/>
+                <a:cs typeface="+mn-cs"/>
+              </a:rPr>
+              <a:t>Jeffimenko</a:t>
+            </a:r>
+            <a:r>
+              <a:rPr kumimoji="0" lang="en-US" sz="1600" b="0" i="0" u="none" strike="noStrike" kern="1200" cap="none" spc="0" normalizeH="0" baseline="0" noProof="0" dirty="0">
+                <a:ln>
+                  <a:noFill/>
+                </a:ln>
+                <a:solidFill>
+                  <a:prstClr val="white"/>
+                </a:solidFill>
+                <a:effectLst/>
+                <a:uLnTx/>
+                <a:uFillTx/>
+                <a:latin typeface="Calibri" panose="020F0502020204030204"/>
+                <a:ea typeface="+mn-ea"/>
+                <a:cs typeface="+mn-cs"/>
+              </a:rPr>
+              <a:t> math. Not sure yet. </a:t>
+            </a:r>
+          </a:p>
+          <a:p>
+            <a:pPr marL="0" marR="0" lvl="0" indent="0" algn="l" defTabSz="914400" rtl="0" eaLnBrk="1" fontAlgn="auto" latinLnBrk="0" hangingPunct="1">
+              <a:lnSpc>
+                <a:spcPct val="100000"/>
+              </a:lnSpc>
+              <a:spcBef>
+                <a:spcPts val="0"/>
+              </a:spcBef>
+              <a:spcAft>
+                <a:spcPts val="0"/>
+              </a:spcAft>
+              <a:buClrTx/>
+              <a:buSzTx/>
+              <a:buFontTx/>
+              <a:buNone/>
+              <a:tabLst/>
+              <a:defRPr/>
+            </a:pPr>
+            <a:r>
+              <a:rPr kumimoji="0" lang="en-US" sz="1600" b="0" i="0" u="none" strike="noStrike" kern="1200" cap="none" spc="0" normalizeH="0" baseline="0" noProof="0" dirty="0">
+                <a:ln>
+                  <a:noFill/>
+                </a:ln>
+                <a:solidFill>
+                  <a:prstClr val="white"/>
+                </a:solidFill>
+                <a:effectLst/>
+                <a:uLnTx/>
+                <a:uFillTx/>
+                <a:latin typeface="Calibri" panose="020F0502020204030204"/>
+                <a:ea typeface="+mn-ea"/>
+                <a:cs typeface="+mn-cs"/>
+              </a:rPr>
+              <a:t>6. Let's use the term potential sphere stream to describe each point potential emitting a stream of expanding spherical potentials. The stream also encodes the velocity of the emitting point potential, by nature of the moving origin. </a:t>
+            </a:r>
+          </a:p>
+          <a:p>
+            <a:pPr marL="0" marR="0" lvl="0" indent="0" algn="l" defTabSz="914400" rtl="0" eaLnBrk="1" fontAlgn="auto" latinLnBrk="0" hangingPunct="1">
+              <a:lnSpc>
+                <a:spcPct val="100000"/>
+              </a:lnSpc>
+              <a:spcBef>
+                <a:spcPts val="0"/>
+              </a:spcBef>
+              <a:spcAft>
+                <a:spcPts val="0"/>
+              </a:spcAft>
+              <a:buClrTx/>
+              <a:buSzTx/>
+              <a:buFontTx/>
+              <a:buNone/>
+              <a:tabLst/>
+              <a:defRPr/>
+            </a:pPr>
+            <a:r>
+              <a:rPr kumimoji="0" lang="en-US" sz="1600" b="0" i="0" u="none" strike="noStrike" kern="1200" cap="none" spc="0" normalizeH="0" baseline="0" noProof="0" dirty="0">
+                <a:ln>
+                  <a:noFill/>
+                </a:ln>
+                <a:solidFill>
+                  <a:prstClr val="white"/>
+                </a:solidFill>
+                <a:effectLst/>
+                <a:uLnTx/>
+                <a:uFillTx/>
+                <a:latin typeface="Calibri" panose="020F0502020204030204"/>
+                <a:ea typeface="+mn-ea"/>
+                <a:cs typeface="+mn-cs"/>
+              </a:rPr>
+              <a:t>7. When the potential sphere emitted at T0 arrives, in the potential sphere stream from A, then action will occur and the path of B will be impacted. But B is also emitting a potential sphere stream that impacts A after the travel time delay. So there is a feedback cycle with a variable delay that is dependent on both A and B's path.</a:t>
+            </a:r>
+          </a:p>
+          <a:p>
+            <a:pPr marL="0" marR="0" lvl="0" indent="0" algn="l" defTabSz="914400" rtl="0" eaLnBrk="1" fontAlgn="auto" latinLnBrk="0" hangingPunct="1">
+              <a:lnSpc>
+                <a:spcPct val="100000"/>
+              </a:lnSpc>
+              <a:spcBef>
+                <a:spcPts val="0"/>
+              </a:spcBef>
+              <a:spcAft>
+                <a:spcPts val="0"/>
+              </a:spcAft>
+              <a:buClrTx/>
+              <a:buSzTx/>
+              <a:buFontTx/>
+              <a:buNone/>
+              <a:tabLst/>
+              <a:defRPr/>
+            </a:pPr>
+            <a:r>
+              <a:rPr kumimoji="0" lang="en-US" sz="1600" b="0" i="0" u="none" strike="noStrike" kern="1200" cap="none" spc="0" normalizeH="0" baseline="0" noProof="0" dirty="0">
+                <a:ln>
+                  <a:noFill/>
+                </a:ln>
+                <a:solidFill>
+                  <a:prstClr val="white"/>
+                </a:solidFill>
+                <a:effectLst/>
+                <a:uLnTx/>
+                <a:uFillTx/>
+                <a:latin typeface="Calibri" panose="020F0502020204030204"/>
+                <a:ea typeface="+mn-ea"/>
+                <a:cs typeface="+mn-cs"/>
+              </a:rPr>
+              <a:t>8. I was just thinking the other day how to enhance the picture to show the continuous potential sphere streams from A passing B and causing action, and vice versa. I'd like to somehow capture this dynamic feedback cycle. </a:t>
+            </a:r>
+          </a:p>
+          <a:p>
+            <a:pPr marL="0" marR="0" lvl="0" indent="0" algn="l" defTabSz="914400" rtl="0" eaLnBrk="1" fontAlgn="auto" latinLnBrk="0" hangingPunct="1">
+              <a:lnSpc>
+                <a:spcPct val="100000"/>
+              </a:lnSpc>
+              <a:spcBef>
+                <a:spcPts val="0"/>
+              </a:spcBef>
+              <a:spcAft>
+                <a:spcPts val="0"/>
+              </a:spcAft>
+              <a:buClrTx/>
+              <a:buSzTx/>
+              <a:buFontTx/>
+              <a:buNone/>
+              <a:tabLst/>
+              <a:defRPr/>
+            </a:pPr>
+            <a:r>
+              <a:rPr kumimoji="0" lang="en-US" sz="1600" b="0" i="0" u="none" strike="noStrike" kern="1200" cap="none" spc="0" normalizeH="0" baseline="0" noProof="0" dirty="0">
+                <a:ln>
+                  <a:noFill/>
+                </a:ln>
+                <a:solidFill>
+                  <a:prstClr val="white"/>
+                </a:solidFill>
+                <a:effectLst/>
+                <a:uLnTx/>
+                <a:uFillTx/>
+                <a:latin typeface="Calibri" panose="020F0502020204030204"/>
+                <a:ea typeface="+mn-ea"/>
+                <a:cs typeface="+mn-cs"/>
+              </a:rPr>
+              <a:t>9. I think there is probably some incredible math just in this interaction. I don't know if that math has already been done. Perhaps.  I doubt anyone has considered the case when point potential velocity equals or exceeds field speed. That is an unexplored regime.  </a:t>
+            </a:r>
+          </a:p>
+          <a:p>
+            <a:pPr marL="0" marR="0" lvl="0" indent="0" algn="l" defTabSz="914400" rtl="0" eaLnBrk="1" fontAlgn="auto" latinLnBrk="0" hangingPunct="1">
+              <a:lnSpc>
+                <a:spcPct val="100000"/>
+              </a:lnSpc>
+              <a:spcBef>
+                <a:spcPts val="0"/>
+              </a:spcBef>
+              <a:spcAft>
+                <a:spcPts val="0"/>
+              </a:spcAft>
+              <a:buClrTx/>
+              <a:buSzTx/>
+              <a:buFontTx/>
+              <a:buNone/>
+              <a:tabLst/>
+              <a:defRPr/>
+            </a:pPr>
+            <a:endParaRPr kumimoji="0" lang="en-US" sz="1600" b="0" i="0" u="none" strike="noStrike" kern="1200" cap="none" spc="0" normalizeH="0" baseline="0" noProof="0" dirty="0">
+              <a:ln>
+                <a:noFill/>
+              </a:ln>
+              <a:solidFill>
+                <a:prstClr val="white"/>
+              </a:solidFill>
+              <a:effectLst/>
+              <a:uLnTx/>
+              <a:uFillTx/>
+              <a:latin typeface="Calibri" panose="020F0502020204030204"/>
+              <a:ea typeface="+mn-ea"/>
+              <a:cs typeface="+mn-cs"/>
+            </a:endParaRPr>
+          </a:p>
+          <a:p>
+            <a:pPr marL="0" marR="0" lvl="0" indent="0" algn="l" defTabSz="914400" rtl="0" eaLnBrk="1" fontAlgn="auto" latinLnBrk="0" hangingPunct="1">
+              <a:lnSpc>
+                <a:spcPct val="100000"/>
+              </a:lnSpc>
+              <a:spcBef>
+                <a:spcPts val="0"/>
+              </a:spcBef>
+              <a:spcAft>
+                <a:spcPts val="0"/>
+              </a:spcAft>
+              <a:buClrTx/>
+              <a:buSzTx/>
+              <a:buFontTx/>
+              <a:buNone/>
+              <a:tabLst/>
+              <a:defRPr/>
+            </a:pPr>
+            <a:r>
+              <a:rPr kumimoji="0" lang="en-US" sz="1600" b="0" i="0" u="none" strike="noStrike" kern="1200" cap="none" spc="0" normalizeH="0" baseline="0" noProof="0" dirty="0">
+                <a:ln>
+                  <a:noFill/>
+                </a:ln>
+                <a:solidFill>
+                  <a:prstClr val="white"/>
+                </a:solidFill>
+                <a:effectLst/>
+                <a:uLnTx/>
+                <a:uFillTx/>
+                <a:latin typeface="Calibri" panose="020F0502020204030204"/>
+                <a:ea typeface="+mn-ea"/>
+                <a:cs typeface="+mn-cs"/>
+              </a:rPr>
+              <a:t>My recommendation is to use your imagination to visualize the dynamical geometry and the potential sphere streams and the paths.  For me that leads to a lot of insight.   </a:t>
+            </a:r>
+          </a:p>
+        </p:txBody>
+      </p:sp>
+    </p:spTree>
+    <p:extLst>
+      <p:ext uri="{BB962C8B-B14F-4D97-AF65-F5344CB8AC3E}">
+        <p14:creationId xmlns:p14="http://schemas.microsoft.com/office/powerpoint/2010/main" val="4219678445"/>
+      </p:ext>
+    </p:extLst>
+  </p:cSld>
+  <p:clrMapOvr>
+    <a:masterClrMapping/>
+  </p:clrMapOvr>
+</p:sld>
+</file>
+
 <file path=ppt/theme/theme1.xml><?xml version="1.0" encoding="utf-8"?>
 <a:theme xmlns:a="http://schemas.openxmlformats.org/drawingml/2006/main" name="Office Theme">
   <a:themeElements>
@@ -37574,334 +35986,6 @@
 </file>
 
 <file path=ppt/theme/theme2.xml><?xml version="1.0" encoding="utf-8"?>
-<a:theme xmlns:a="http://schemas.openxmlformats.org/drawingml/2006/main" name="2_Office Theme">
-  <a:themeElements>
-    <a:clrScheme name="Office">
-      <a:dk1>
-        <a:sysClr val="windowText" lastClr="000000"/>
-      </a:dk1>
-      <a:lt1>
-        <a:sysClr val="window" lastClr="FFFFFF"/>
-      </a:lt1>
-      <a:dk2>
-        <a:srgbClr val="44546A"/>
-      </a:dk2>
-      <a:lt2>
-        <a:srgbClr val="E7E6E6"/>
-      </a:lt2>
-      <a:accent1>
-        <a:srgbClr val="4472C4"/>
-      </a:accent1>
-      <a:accent2>
-        <a:srgbClr val="ED7D31"/>
-      </a:accent2>
-      <a:accent3>
-        <a:srgbClr val="A5A5A5"/>
-      </a:accent3>
-      <a:accent4>
-        <a:srgbClr val="FFC000"/>
-      </a:accent4>
-      <a:accent5>
-        <a:srgbClr val="5B9BD5"/>
-      </a:accent5>
-      <a:accent6>
-        <a:srgbClr val="70AD47"/>
-      </a:accent6>
-      <a:hlink>
-        <a:srgbClr val="0563C1"/>
-      </a:hlink>
-      <a:folHlink>
-        <a:srgbClr val="954F72"/>
-      </a:folHlink>
-    </a:clrScheme>
-    <a:fontScheme name="Office">
-      <a:majorFont>
-        <a:latin typeface="Calibri Light" panose="020F0302020204030204"/>
-        <a:ea typeface=""/>
-        <a:cs typeface=""/>
-        <a:font script="Jpan" typeface="游ゴシック Light"/>
-        <a:font script="Hang" typeface="맑은 고딕"/>
-        <a:font script="Hans" typeface="等线 Light"/>
-        <a:font script="Hant" typeface="新細明體"/>
-        <a:font script="Arab" typeface="Times New Roman"/>
-        <a:font script="Hebr" typeface="Times New Roman"/>
-        <a:font script="Thai" typeface="Angsana New"/>
-        <a:font script="Ethi" typeface="Nyala"/>
-        <a:font script="Beng" typeface="Vrinda"/>
-        <a:font script="Gujr" typeface="Shruti"/>
-        <a:font script="Khmr" typeface="MoolBoran"/>
-        <a:font script="Knda" typeface="Tunga"/>
-        <a:font script="Guru" typeface="Raavi"/>
-        <a:font script="Cans" typeface="Euphemia"/>
-        <a:font script="Cher" typeface="Plantagenet Cherokee"/>
-        <a:font script="Yiii" typeface="Microsoft Yi Baiti"/>
-        <a:font script="Tibt" typeface="Microsoft Himalaya"/>
-        <a:font script="Thaa" typeface="MV Boli"/>
-        <a:font script="Deva" typeface="Mangal"/>
-        <a:font script="Telu" typeface="Gautami"/>
-        <a:font script="Taml" typeface="Latha"/>
-        <a:font script="Syrc" typeface="Estrangelo Edessa"/>
-        <a:font script="Orya" typeface="Kalinga"/>
-        <a:font script="Mlym" typeface="Kartika"/>
-        <a:font script="Laoo" typeface="DokChampa"/>
-        <a:font script="Sinh" typeface="Iskoola Pota"/>
-        <a:font script="Mong" typeface="Mongolian Baiti"/>
-        <a:font script="Viet" typeface="Times New Roman"/>
-        <a:font script="Uigh" typeface="Microsoft Uighur"/>
-        <a:font script="Geor" typeface="Sylfaen"/>
-        <a:font script="Armn" typeface="Arial"/>
-        <a:font script="Bugi" typeface="Leelawadee UI"/>
-        <a:font script="Bopo" typeface="Microsoft JhengHei"/>
-        <a:font script="Java" typeface="Javanese Text"/>
-        <a:font script="Lisu" typeface="Segoe UI"/>
-        <a:font script="Mymr" typeface="Myanmar Text"/>
-        <a:font script="Nkoo" typeface="Ebrima"/>
-        <a:font script="Olck" typeface="Nirmala UI"/>
-        <a:font script="Osma" typeface="Ebrima"/>
-        <a:font script="Phag" typeface="Phagspa"/>
-        <a:font script="Syrn" typeface="Estrangelo Edessa"/>
-        <a:font script="Syrj" typeface="Estrangelo Edessa"/>
-        <a:font script="Syre" typeface="Estrangelo Edessa"/>
-        <a:font script="Sora" typeface="Nirmala UI"/>
-        <a:font script="Tale" typeface="Microsoft Tai Le"/>
-        <a:font script="Talu" typeface="Microsoft New Tai Lue"/>
-        <a:font script="Tfng" typeface="Ebrima"/>
-      </a:majorFont>
-      <a:minorFont>
-        <a:latin typeface="Calibri" panose="020F0502020204030204"/>
-        <a:ea typeface=""/>
-        <a:cs typeface=""/>
-        <a:font script="Jpan" typeface="游ゴシック"/>
-        <a:font script="Hang" typeface="맑은 고딕"/>
-        <a:font script="Hans" typeface="等线"/>
-        <a:font script="Hant" typeface="新細明體"/>
-        <a:font script="Arab" typeface="Arial"/>
-        <a:font script="Hebr" typeface="Arial"/>
-        <a:font script="Thai" typeface="Cordia New"/>
-        <a:font script="Ethi" typeface="Nyala"/>
-        <a:font script="Beng" typeface="Vrinda"/>
-        <a:font script="Gujr" typeface="Shruti"/>
-        <a:font script="Khmr" typeface="DaunPenh"/>
-        <a:font script="Knda" typeface="Tunga"/>
-        <a:font script="Guru" typeface="Raavi"/>
-        <a:font script="Cans" typeface="Euphemia"/>
-        <a:font script="Cher" typeface="Plantagenet Cherokee"/>
-        <a:font script="Yiii" typeface="Microsoft Yi Baiti"/>
-        <a:font script="Tibt" typeface="Microsoft Himalaya"/>
-        <a:font script="Thaa" typeface="MV Boli"/>
-        <a:font script="Deva" typeface="Mangal"/>
-        <a:font script="Telu" typeface="Gautami"/>
-        <a:font script="Taml" typeface="Latha"/>
-        <a:font script="Syrc" typeface="Estrangelo Edessa"/>
-        <a:font script="Orya" typeface="Kalinga"/>
-        <a:font script="Mlym" typeface="Kartika"/>
-        <a:font script="Laoo" typeface="DokChampa"/>
-        <a:font script="Sinh" typeface="Iskoola Pota"/>
-        <a:font script="Mong" typeface="Mongolian Baiti"/>
-        <a:font script="Viet" typeface="Arial"/>
-        <a:font script="Uigh" typeface="Microsoft Uighur"/>
-        <a:font script="Geor" typeface="Sylfaen"/>
-        <a:font script="Armn" typeface="Arial"/>
-        <a:font script="Bugi" typeface="Leelawadee UI"/>
-        <a:font script="Bopo" typeface="Microsoft JhengHei"/>
-        <a:font script="Java" typeface="Javanese Text"/>
-        <a:font script="Lisu" typeface="Segoe UI"/>
-        <a:font script="Mymr" typeface="Myanmar Text"/>
-        <a:font script="Nkoo" typeface="Ebrima"/>
-        <a:font script="Olck" typeface="Nirmala UI"/>
-        <a:font script="Osma" typeface="Ebrima"/>
-        <a:font script="Phag" typeface="Phagspa"/>
-        <a:font script="Syrn" typeface="Estrangelo Edessa"/>
-        <a:font script="Syrj" typeface="Estrangelo Edessa"/>
-        <a:font script="Syre" typeface="Estrangelo Edessa"/>
-        <a:font script="Sora" typeface="Nirmala UI"/>
-        <a:font script="Tale" typeface="Microsoft Tai Le"/>
-        <a:font script="Talu" typeface="Microsoft New Tai Lue"/>
-        <a:font script="Tfng" typeface="Ebrima"/>
-      </a:minorFont>
-    </a:fontScheme>
-    <a:fmtScheme name="Office">
-      <a:fillStyleLst>
-        <a:solidFill>
-          <a:schemeClr val="phClr"/>
-        </a:solidFill>
-        <a:gradFill rotWithShape="1">
-          <a:gsLst>
-            <a:gs pos="0">
-              <a:schemeClr val="phClr">
-                <a:lumMod val="110000"/>
-                <a:satMod val="105000"/>
-                <a:tint val="67000"/>
-              </a:schemeClr>
-            </a:gs>
-            <a:gs pos="50000">
-              <a:schemeClr val="phClr">
-                <a:lumMod val="105000"/>
-                <a:satMod val="103000"/>
-                <a:tint val="73000"/>
-              </a:schemeClr>
-            </a:gs>
-            <a:gs pos="100000">
-              <a:schemeClr val="phClr">
-                <a:lumMod val="105000"/>
-                <a:satMod val="109000"/>
-                <a:tint val="81000"/>
-              </a:schemeClr>
-            </a:gs>
-          </a:gsLst>
-          <a:lin ang="5400000" scaled="0"/>
-        </a:gradFill>
-        <a:gradFill rotWithShape="1">
-          <a:gsLst>
-            <a:gs pos="0">
-              <a:schemeClr val="phClr">
-                <a:satMod val="103000"/>
-                <a:lumMod val="102000"/>
-                <a:tint val="94000"/>
-              </a:schemeClr>
-            </a:gs>
-            <a:gs pos="50000">
-              <a:schemeClr val="phClr">
-                <a:satMod val="110000"/>
-                <a:lumMod val="100000"/>
-                <a:shade val="100000"/>
-              </a:schemeClr>
-            </a:gs>
-            <a:gs pos="100000">
-              <a:schemeClr val="phClr">
-                <a:lumMod val="99000"/>
-                <a:satMod val="120000"/>
-                <a:shade val="78000"/>
-              </a:schemeClr>
-            </a:gs>
-          </a:gsLst>
-          <a:lin ang="5400000" scaled="0"/>
-        </a:gradFill>
-      </a:fillStyleLst>
-      <a:lnStyleLst>
-        <a:ln w="6350" cap="flat" cmpd="sng" algn="ctr">
-          <a:solidFill>
-            <a:schemeClr val="phClr"/>
-          </a:solidFill>
-          <a:prstDash val="solid"/>
-          <a:miter lim="800000"/>
-        </a:ln>
-        <a:ln w="12700" cap="flat" cmpd="sng" algn="ctr">
-          <a:solidFill>
-            <a:schemeClr val="phClr"/>
-          </a:solidFill>
-          <a:prstDash val="solid"/>
-          <a:miter lim="800000"/>
-        </a:ln>
-        <a:ln w="19050" cap="flat" cmpd="sng" algn="ctr">
-          <a:solidFill>
-            <a:schemeClr val="phClr"/>
-          </a:solidFill>
-          <a:prstDash val="solid"/>
-          <a:miter lim="800000"/>
-        </a:ln>
-      </a:lnStyleLst>
-      <a:effectStyleLst>
-        <a:effectStyle>
-          <a:effectLst/>
-        </a:effectStyle>
-        <a:effectStyle>
-          <a:effectLst/>
-        </a:effectStyle>
-        <a:effectStyle>
-          <a:effectLst>
-            <a:outerShdw blurRad="57150" dist="19050" dir="5400000" algn="ctr" rotWithShape="0">
-              <a:srgbClr val="000000">
-                <a:alpha val="63000"/>
-              </a:srgbClr>
-            </a:outerShdw>
-          </a:effectLst>
-        </a:effectStyle>
-      </a:effectStyleLst>
-      <a:bgFillStyleLst>
-        <a:solidFill>
-          <a:schemeClr val="phClr"/>
-        </a:solidFill>
-        <a:solidFill>
-          <a:schemeClr val="phClr">
-            <a:tint val="95000"/>
-            <a:satMod val="170000"/>
-          </a:schemeClr>
-        </a:solidFill>
-        <a:gradFill rotWithShape="1">
-          <a:gsLst>
-            <a:gs pos="0">
-              <a:schemeClr val="phClr">
-                <a:tint val="93000"/>
-                <a:satMod val="150000"/>
-                <a:shade val="98000"/>
-                <a:lumMod val="102000"/>
-              </a:schemeClr>
-            </a:gs>
-            <a:gs pos="50000">
-              <a:schemeClr val="phClr">
-                <a:tint val="98000"/>
-                <a:satMod val="130000"/>
-                <a:shade val="90000"/>
-                <a:lumMod val="103000"/>
-              </a:schemeClr>
-            </a:gs>
-            <a:gs pos="100000">
-              <a:schemeClr val="phClr">
-                <a:shade val="63000"/>
-                <a:satMod val="120000"/>
-              </a:schemeClr>
-            </a:gs>
-          </a:gsLst>
-          <a:lin ang="5400000" scaled="0"/>
-        </a:gradFill>
-      </a:bgFillStyleLst>
-    </a:fmtScheme>
-  </a:themeElements>
-  <a:objectDefaults>
-    <a:spDef>
-      <a:spPr/>
-      <a:bodyPr wrap="none">
-        <a:spAutoFit/>
-      </a:bodyPr>
-      <a:lstStyle>
-        <a:defPPr algn="l">
-          <a:defRPr sz="2400" dirty="0" smtClean="0">
-            <a:latin typeface="Helvetica Neue" panose="02000503000000020004" pitchFamily="2" charset="0"/>
-            <a:ea typeface="Helvetica Neue" panose="02000503000000020004" pitchFamily="2" charset="0"/>
-            <a:cs typeface="Helvetica Neue" panose="02000503000000020004" pitchFamily="2" charset="0"/>
-          </a:defRPr>
-        </a:defPPr>
-      </a:lstStyle>
-    </a:spDef>
-    <a:txDef>
-      <a:spPr>
-        <a:noFill/>
-      </a:spPr>
-      <a:bodyPr wrap="none" rtlCol="0">
-        <a:spAutoFit/>
-      </a:bodyPr>
-      <a:lstStyle>
-        <a:defPPr algn="l">
-          <a:defRPr dirty="0" smtClean="0">
-            <a:latin typeface="Helvetica Neue" panose="02000503000000020004" pitchFamily="2" charset="0"/>
-            <a:ea typeface="Helvetica Neue" panose="02000503000000020004" pitchFamily="2" charset="0"/>
-            <a:cs typeface="Helvetica Neue" panose="02000503000000020004" pitchFamily="2" charset="0"/>
-          </a:defRPr>
-        </a:defPPr>
-      </a:lstStyle>
-    </a:txDef>
-  </a:objectDefaults>
-  <a:extraClrSchemeLst/>
-  <a:extLst>
-    <a:ext uri="{05A4C25C-085E-4340-85A3-A5531E510DB2}">
-      <thm15:themeFamily xmlns:thm15="http://schemas.microsoft.com/office/thememl/2012/main" name="Office Theme" id="{62F939B6-93AF-4DB8-9C6B-D6C7DFDC589F}" vid="{4A3C46E8-61CC-4603-A589-7422A47A8E4A}"/>
-    </a:ext>
-  </a:extLst>
-</a:theme>
-</file>
-
-<file path=ppt/theme/theme3.xml><?xml version="1.0" encoding="utf-8"?>
 <a:theme xmlns:a="http://schemas.openxmlformats.org/drawingml/2006/main" name="Office Theme">
   <a:themeElements>
     <a:clrScheme name="Office">

</xml_diff>

<commit_message>
Align Noether braid terminology and generated outputs (#202)
* Update research-revolution transition language

* Refine corpus and priority documentation

* Adopt candidate and certified braid terminology

* Refine noether braid taxonomy proof map

* Set main scene shell to true purple

* Add NPQG time and space presentation assets

* Add point potential presentation asset

* Rename braid taxonomy to use angular-momentum frame terms

* Standardize retained-branch terminology in noether-braid docs

* Clarify braid proof packet roles and cleanup queue

* Align Noether braid chapter roles

* Rename resonance lock references to Noether Braid form

* Refresh generated graph and textbook package

---------

Co-authored-by: J Mark Morris <inquiries@neoclassical.ai>
</commit_message>
<xml_diff>
--- a/reference/archie/presentations/NPQG Fundamentals - Action.pptx
+++ b/reference/archie/presentations/NPQG Fundamentals - Action.pptx
@@ -3,28 +3,26 @@
 <p:presentation xmlns:a="http://schemas.openxmlformats.org/drawingml/2006/main" xmlns:r="http://schemas.openxmlformats.org/officeDocument/2006/relationships" xmlns:p="http://schemas.openxmlformats.org/presentationml/2006/main" saveSubsetFonts="1" autoCompressPictures="0">
   <p:sldMasterIdLst>
     <p:sldMasterId id="2147483648" r:id="rId1"/>
-    <p:sldMasterId id="2147483664" r:id="rId2"/>
   </p:sldMasterIdLst>
   <p:notesMasterIdLst>
-    <p:notesMasterId r:id="rId19"/>
+    <p:notesMasterId r:id="rId17"/>
   </p:notesMasterIdLst>
   <p:sldIdLst>
-    <p:sldId id="884" r:id="rId3"/>
-    <p:sldId id="808" r:id="rId4"/>
-    <p:sldId id="382" r:id="rId5"/>
-    <p:sldId id="842" r:id="rId6"/>
-    <p:sldId id="819" r:id="rId7"/>
-    <p:sldId id="844" r:id="rId8"/>
-    <p:sldId id="757" r:id="rId9"/>
-    <p:sldId id="820" r:id="rId10"/>
-    <p:sldId id="821" r:id="rId11"/>
-    <p:sldId id="809" r:id="rId12"/>
-    <p:sldId id="839" r:id="rId13"/>
-    <p:sldId id="840" r:id="rId14"/>
-    <p:sldId id="817" r:id="rId15"/>
-    <p:sldId id="816" r:id="rId16"/>
-    <p:sldId id="815" r:id="rId17"/>
-    <p:sldId id="843" r:id="rId18"/>
+    <p:sldId id="884" r:id="rId2"/>
+    <p:sldId id="808" r:id="rId3"/>
+    <p:sldId id="842" r:id="rId4"/>
+    <p:sldId id="819" r:id="rId5"/>
+    <p:sldId id="844" r:id="rId6"/>
+    <p:sldId id="757" r:id="rId7"/>
+    <p:sldId id="820" r:id="rId8"/>
+    <p:sldId id="821" r:id="rId9"/>
+    <p:sldId id="809" r:id="rId10"/>
+    <p:sldId id="839" r:id="rId11"/>
+    <p:sldId id="840" r:id="rId12"/>
+    <p:sldId id="817" r:id="rId13"/>
+    <p:sldId id="816" r:id="rId14"/>
+    <p:sldId id="815" r:id="rId15"/>
+    <p:sldId id="843" r:id="rId16"/>
   </p:sldIdLst>
   <p:sldSz cx="12192000" cy="6858000"/>
   <p:notesSz cx="6858000" cy="9144000"/>
@@ -3027,7 +3025,7 @@
           <a:p>
             <a:fld id="{BBBDA440-6FDE-5E41-BA40-A3C0E02BAB9F}" type="datetimeFigureOut">
               <a:rPr lang="en-US" smtClean="0"/>
-              <a:t>3/14/26</a:t>
+              <a:t>7/3/26</a:t>
             </a:fld>
             <a:endParaRPr lang="en-US"/>
           </a:p>
@@ -3982,7 +3980,7 @@
                 <a:tabLst/>
                 <a:defRPr/>
               </a:pPr>
-              <a:t>4</a:t>
+              <a:t>3</a:t>
             </a:fld>
             <a:endParaRPr kumimoji="0" lang="en-US" sz="1200" b="0" i="0" u="none" strike="noStrike" kern="1200" cap="none" spc="0" normalizeH="0" baseline="0" noProof="0">
               <a:ln>
@@ -4126,7 +4124,7 @@
                 <a:tabLst/>
                 <a:defRPr/>
               </a:pPr>
-              <a:t>10</a:t>
+              <a:t>9</a:t>
             </a:fld>
             <a:endParaRPr kumimoji="0" lang="en-US" sz="1200" b="0" i="0" u="none" strike="noStrike" kern="1200" cap="none" spc="0" normalizeH="0" baseline="0" noProof="0">
               <a:ln>
@@ -4330,7 +4328,7 @@
                 <a:tabLst/>
                 <a:defRPr/>
               </a:pPr>
-              <a:t>13</a:t>
+              <a:t>12</a:t>
             </a:fld>
             <a:endParaRPr kumimoji="0" lang="en-US" sz="1200" b="0" i="0" u="none" strike="noStrike" kern="1200" cap="none" spc="0" normalizeH="0" baseline="0" noProof="0">
               <a:ln>
@@ -4474,7 +4472,7 @@
                 <a:tabLst/>
                 <a:defRPr/>
               </a:pPr>
-              <a:t>14</a:t>
+              <a:t>13</a:t>
             </a:fld>
             <a:endParaRPr kumimoji="0" lang="en-US" sz="1200" b="0" i="0" u="none" strike="noStrike" kern="1200" cap="none" spc="0" normalizeH="0" baseline="0" noProof="0">
               <a:ln>
@@ -4618,7 +4616,7 @@
                 <a:tabLst/>
                 <a:defRPr/>
               </a:pPr>
-              <a:t>15</a:t>
+              <a:t>14</a:t>
             </a:fld>
             <a:endParaRPr kumimoji="0" lang="en-US" sz="1200" b="0" i="0" u="none" strike="noStrike" kern="1200" cap="none" spc="0" normalizeH="0" baseline="0" noProof="0">
               <a:ln>
@@ -4797,7 +4795,7 @@
           <a:p>
             <a:fld id="{CB70D3E6-D921-5B44-AC8D-B7FDAFC8A532}" type="datetimeFigureOut">
               <a:rPr lang="en-US" smtClean="0"/>
-              <a:t>3/14/26</a:t>
+              <a:t>7/3/26</a:t>
             </a:fld>
             <a:endParaRPr lang="en-US"/>
           </a:p>
@@ -4995,7 +4993,7 @@
           <a:p>
             <a:fld id="{CB70D3E6-D921-5B44-AC8D-B7FDAFC8A532}" type="datetimeFigureOut">
               <a:rPr lang="en-US" smtClean="0"/>
-              <a:t>3/14/26</a:t>
+              <a:t>7/3/26</a:t>
             </a:fld>
             <a:endParaRPr lang="en-US"/>
           </a:p>
@@ -5203,7 +5201,7 @@
           <a:p>
             <a:fld id="{CB70D3E6-D921-5B44-AC8D-B7FDAFC8A532}" type="datetimeFigureOut">
               <a:rPr lang="en-US" smtClean="0"/>
-              <a:t>3/14/26</a:t>
+              <a:t>7/3/26</a:t>
             </a:fld>
             <a:endParaRPr lang="en-US"/>
           </a:p>
@@ -5276,597 +5274,6 @@
 </p:sldLayout>
 </file>
 
-<file path=ppt/slideLayouts/slideLayout12.xml><?xml version="1.0" encoding="utf-8"?>
-<p:sldLayout xmlns:a="http://schemas.openxmlformats.org/drawingml/2006/main" xmlns:r="http://schemas.openxmlformats.org/officeDocument/2006/relationships" xmlns:p="http://schemas.openxmlformats.org/presentationml/2006/main" type="title" preserve="1">
-  <p:cSld name="Title Slide">
-    <p:spTree>
-      <p:nvGrpSpPr>
-        <p:cNvPr id="1" name=""/>
-        <p:cNvGrpSpPr/>
-        <p:nvPr/>
-      </p:nvGrpSpPr>
-      <p:grpSpPr>
-        <a:xfrm>
-          <a:off x="0" y="0"/>
-          <a:ext cx="0" cy="0"/>
-          <a:chOff x="0" y="0"/>
-          <a:chExt cx="0" cy="0"/>
-        </a:xfrm>
-      </p:grpSpPr>
-      <p:sp>
-        <p:nvSpPr>
-          <p:cNvPr id="2" name="Title 1">
-            <a:extLst>
-              <a:ext uri="{FF2B5EF4-FFF2-40B4-BE49-F238E27FC236}">
-                <a16:creationId xmlns:a16="http://schemas.microsoft.com/office/drawing/2014/main" id="{08FC2668-EBEB-AE41-BF76-89062B014B13}"/>
-              </a:ext>
-            </a:extLst>
-          </p:cNvPr>
-          <p:cNvSpPr>
-            <a:spLocks noGrp="1"/>
-          </p:cNvSpPr>
-          <p:nvPr>
-            <p:ph type="ctrTitle"/>
-          </p:nvPr>
-        </p:nvSpPr>
-        <p:spPr>
-          <a:xfrm>
-            <a:off x="1524000" y="1122363"/>
-            <a:ext cx="9144000" cy="2387600"/>
-          </a:xfrm>
-        </p:spPr>
-        <p:txBody>
-          <a:bodyPr anchor="b"/>
-          <a:lstStyle>
-            <a:lvl1pPr algn="ctr">
-              <a:defRPr sz="6000"/>
-            </a:lvl1pPr>
-          </a:lstStyle>
-          <a:p>
-            <a:r>
-              <a:rPr lang="en-US" dirty="0"/>
-              <a:t>Click to edit Master title style</a:t>
-            </a:r>
-          </a:p>
-        </p:txBody>
-      </p:sp>
-      <p:sp>
-        <p:nvSpPr>
-          <p:cNvPr id="3" name="Subtitle 2">
-            <a:extLst>
-              <a:ext uri="{FF2B5EF4-FFF2-40B4-BE49-F238E27FC236}">
-                <a16:creationId xmlns:a16="http://schemas.microsoft.com/office/drawing/2014/main" id="{C8C28A4C-0805-8E44-B54E-3B6F671F8D01}"/>
-              </a:ext>
-            </a:extLst>
-          </p:cNvPr>
-          <p:cNvSpPr>
-            <a:spLocks noGrp="1"/>
-          </p:cNvSpPr>
-          <p:nvPr>
-            <p:ph type="subTitle" idx="1"/>
-          </p:nvPr>
-        </p:nvSpPr>
-        <p:spPr>
-          <a:xfrm>
-            <a:off x="1524000" y="3602038"/>
-            <a:ext cx="9144000" cy="1655762"/>
-          </a:xfrm>
-        </p:spPr>
-        <p:txBody>
-          <a:bodyPr/>
-          <a:lstStyle>
-            <a:lvl1pPr marL="0" indent="0" algn="ctr">
-              <a:buNone/>
-              <a:defRPr sz="2400"/>
-            </a:lvl1pPr>
-            <a:lvl2pPr marL="457200" indent="0" algn="ctr">
-              <a:buNone/>
-              <a:defRPr sz="2000"/>
-            </a:lvl2pPr>
-            <a:lvl3pPr marL="914400" indent="0" algn="ctr">
-              <a:buNone/>
-              <a:defRPr sz="1800"/>
-            </a:lvl3pPr>
-            <a:lvl4pPr marL="1371600" indent="0" algn="ctr">
-              <a:buNone/>
-              <a:defRPr sz="1600"/>
-            </a:lvl4pPr>
-            <a:lvl5pPr marL="1828800" indent="0" algn="ctr">
-              <a:buNone/>
-              <a:defRPr sz="1600"/>
-            </a:lvl5pPr>
-            <a:lvl6pPr marL="2286000" indent="0" algn="ctr">
-              <a:buNone/>
-              <a:defRPr sz="1600"/>
-            </a:lvl6pPr>
-            <a:lvl7pPr marL="2743200" indent="0" algn="ctr">
-              <a:buNone/>
-              <a:defRPr sz="1600"/>
-            </a:lvl7pPr>
-            <a:lvl8pPr marL="3200400" indent="0" algn="ctr">
-              <a:buNone/>
-              <a:defRPr sz="1600"/>
-            </a:lvl8pPr>
-            <a:lvl9pPr marL="3657600" indent="0" algn="ctr">
-              <a:buNone/>
-              <a:defRPr sz="1600"/>
-            </a:lvl9pPr>
-          </a:lstStyle>
-          <a:p>
-            <a:r>
-              <a:rPr lang="en-US"/>
-              <a:t>Click to edit Master subtitle style</a:t>
-            </a:r>
-          </a:p>
-        </p:txBody>
-      </p:sp>
-      <p:sp>
-        <p:nvSpPr>
-          <p:cNvPr id="4" name="Date Placeholder 3">
-            <a:extLst>
-              <a:ext uri="{FF2B5EF4-FFF2-40B4-BE49-F238E27FC236}">
-                <a16:creationId xmlns:a16="http://schemas.microsoft.com/office/drawing/2014/main" id="{293B74C2-6265-7F41-BB8F-D8A0A0C89A63}"/>
-              </a:ext>
-            </a:extLst>
-          </p:cNvPr>
-          <p:cNvSpPr>
-            <a:spLocks noGrp="1"/>
-          </p:cNvSpPr>
-          <p:nvPr>
-            <p:ph type="dt" sz="half" idx="10"/>
-          </p:nvPr>
-        </p:nvSpPr>
-        <p:spPr/>
-        <p:txBody>
-          <a:bodyPr/>
-          <a:lstStyle/>
-          <a:p>
-            <a:fld id="{B1CFC895-F8E0-4049-8BEE-E5499394E46C}" type="datetime1">
-              <a:rPr lang="en-US" smtClean="0"/>
-              <a:t>3/14/26</a:t>
-            </a:fld>
-            <a:endParaRPr lang="en-US"/>
-          </a:p>
-        </p:txBody>
-      </p:sp>
-      <p:sp>
-        <p:nvSpPr>
-          <p:cNvPr id="5" name="Footer Placeholder 4">
-            <a:extLst>
-              <a:ext uri="{FF2B5EF4-FFF2-40B4-BE49-F238E27FC236}">
-                <a16:creationId xmlns:a16="http://schemas.microsoft.com/office/drawing/2014/main" id="{74C53590-4180-6C42-A6BF-707655C15A1D}"/>
-              </a:ext>
-            </a:extLst>
-          </p:cNvPr>
-          <p:cNvSpPr>
-            <a:spLocks noGrp="1"/>
-          </p:cNvSpPr>
-          <p:nvPr>
-            <p:ph type="ftr" sz="quarter" idx="11"/>
-          </p:nvPr>
-        </p:nvSpPr>
-        <p:spPr/>
-        <p:txBody>
-          <a:bodyPr/>
-          <a:lstStyle>
-            <a:lvl1pPr>
-              <a:defRPr/>
-            </a:lvl1pPr>
-          </a:lstStyle>
-          <a:p>
-            <a:r>
-              <a:rPr lang="en-US"/>
-              <a:t>J Mark Morris - Model of Nature - April 2019</a:t>
-            </a:r>
-          </a:p>
-        </p:txBody>
-      </p:sp>
-      <p:sp>
-        <p:nvSpPr>
-          <p:cNvPr id="6" name="Slide Number Placeholder 5">
-            <a:extLst>
-              <a:ext uri="{FF2B5EF4-FFF2-40B4-BE49-F238E27FC236}">
-                <a16:creationId xmlns:a16="http://schemas.microsoft.com/office/drawing/2014/main" id="{93A81401-8545-2D4E-A7FB-31AFC7A8DB71}"/>
-              </a:ext>
-            </a:extLst>
-          </p:cNvPr>
-          <p:cNvSpPr>
-            <a:spLocks noGrp="1"/>
-          </p:cNvSpPr>
-          <p:nvPr>
-            <p:ph type="sldNum" sz="quarter" idx="12"/>
-          </p:nvPr>
-        </p:nvSpPr>
-        <p:spPr/>
-        <p:txBody>
-          <a:bodyPr/>
-          <a:lstStyle/>
-          <a:p>
-            <a:fld id="{D73D4D4B-2FF7-BE46-958C-B004BD45EF6F}" type="slidenum">
-              <a:rPr lang="en-US" smtClean="0"/>
-              <a:t>‹#›</a:t>
-            </a:fld>
-            <a:endParaRPr lang="en-US"/>
-          </a:p>
-        </p:txBody>
-      </p:sp>
-    </p:spTree>
-    <p:extLst>
-      <p:ext uri="{BB962C8B-B14F-4D97-AF65-F5344CB8AC3E}">
-        <p14:creationId xmlns:p14="http://schemas.microsoft.com/office/powerpoint/2010/main" val="3372916978"/>
-      </p:ext>
-    </p:extLst>
-  </p:cSld>
-  <p:clrMapOvr>
-    <a:masterClrMapping/>
-  </p:clrMapOvr>
-</p:sldLayout>
-</file>
-
-<file path=ppt/slideLayouts/slideLayout13.xml><?xml version="1.0" encoding="utf-8"?>
-<p:sldLayout xmlns:a="http://schemas.openxmlformats.org/drawingml/2006/main" xmlns:r="http://schemas.openxmlformats.org/officeDocument/2006/relationships" xmlns:p="http://schemas.openxmlformats.org/presentationml/2006/main" type="obj" preserve="1">
-  <p:cSld name="Title and Content">
-    <p:spTree>
-      <p:nvGrpSpPr>
-        <p:cNvPr id="1" name=""/>
-        <p:cNvGrpSpPr/>
-        <p:nvPr/>
-      </p:nvGrpSpPr>
-      <p:grpSpPr>
-        <a:xfrm>
-          <a:off x="0" y="0"/>
-          <a:ext cx="0" cy="0"/>
-          <a:chOff x="0" y="0"/>
-          <a:chExt cx="0" cy="0"/>
-        </a:xfrm>
-      </p:grpSpPr>
-      <p:sp>
-        <p:nvSpPr>
-          <p:cNvPr id="2" name="Title 1">
-            <a:extLst>
-              <a:ext uri="{FF2B5EF4-FFF2-40B4-BE49-F238E27FC236}">
-                <a16:creationId xmlns:a16="http://schemas.microsoft.com/office/drawing/2014/main" id="{EDF560F9-C770-5C4C-9C93-102EC332DBA4}"/>
-              </a:ext>
-            </a:extLst>
-          </p:cNvPr>
-          <p:cNvSpPr>
-            <a:spLocks noGrp="1"/>
-          </p:cNvSpPr>
-          <p:nvPr>
-            <p:ph type="title"/>
-          </p:nvPr>
-        </p:nvSpPr>
-        <p:spPr>
-          <a:xfrm>
-            <a:off x="838200" y="365125"/>
-            <a:ext cx="10515600" cy="777875"/>
-          </a:xfrm>
-        </p:spPr>
-        <p:txBody>
-          <a:bodyPr/>
-          <a:lstStyle/>
-          <a:p>
-            <a:r>
-              <a:rPr lang="en-US" dirty="0"/>
-              <a:t>Click to edit Master title style</a:t>
-            </a:r>
-          </a:p>
-        </p:txBody>
-      </p:sp>
-      <p:sp>
-        <p:nvSpPr>
-          <p:cNvPr id="3" name="Content Placeholder 2">
-            <a:extLst>
-              <a:ext uri="{FF2B5EF4-FFF2-40B4-BE49-F238E27FC236}">
-                <a16:creationId xmlns:a16="http://schemas.microsoft.com/office/drawing/2014/main" id="{80D38EDA-56F1-1C40-B81E-28B921C4E99F}"/>
-              </a:ext>
-            </a:extLst>
-          </p:cNvPr>
-          <p:cNvSpPr>
-            <a:spLocks noGrp="1"/>
-          </p:cNvSpPr>
-          <p:nvPr>
-            <p:ph idx="1"/>
-          </p:nvPr>
-        </p:nvSpPr>
-        <p:spPr>
-          <a:xfrm>
-            <a:off x="838200" y="1295400"/>
-            <a:ext cx="10515600" cy="4881563"/>
-          </a:xfrm>
-        </p:spPr>
-        <p:txBody>
-          <a:bodyPr/>
-          <a:lstStyle/>
-          <a:p>
-            <a:pPr lvl="0"/>
-            <a:r>
-              <a:rPr lang="en-US" dirty="0"/>
-              <a:t>Edit Master text styles</a:t>
-            </a:r>
-          </a:p>
-          <a:p>
-            <a:pPr lvl="1"/>
-            <a:r>
-              <a:rPr lang="en-US" dirty="0"/>
-              <a:t>Second level</a:t>
-            </a:r>
-          </a:p>
-          <a:p>
-            <a:pPr lvl="2"/>
-            <a:r>
-              <a:rPr lang="en-US" dirty="0"/>
-              <a:t>Third level</a:t>
-            </a:r>
-          </a:p>
-          <a:p>
-            <a:pPr lvl="3"/>
-            <a:r>
-              <a:rPr lang="en-US" dirty="0"/>
-              <a:t>Fourth level</a:t>
-            </a:r>
-          </a:p>
-          <a:p>
-            <a:pPr lvl="4"/>
-            <a:r>
-              <a:rPr lang="en-US" dirty="0"/>
-              <a:t>Fifth level</a:t>
-            </a:r>
-          </a:p>
-        </p:txBody>
-      </p:sp>
-      <p:sp>
-        <p:nvSpPr>
-          <p:cNvPr id="4" name="Date Placeholder 3">
-            <a:extLst>
-              <a:ext uri="{FF2B5EF4-FFF2-40B4-BE49-F238E27FC236}">
-                <a16:creationId xmlns:a16="http://schemas.microsoft.com/office/drawing/2014/main" id="{0AD42772-5D80-F641-A1BB-6048573C4E88}"/>
-              </a:ext>
-            </a:extLst>
-          </p:cNvPr>
-          <p:cNvSpPr>
-            <a:spLocks noGrp="1"/>
-          </p:cNvSpPr>
-          <p:nvPr>
-            <p:ph type="dt" sz="half" idx="10"/>
-          </p:nvPr>
-        </p:nvSpPr>
-        <p:spPr/>
-        <p:txBody>
-          <a:bodyPr/>
-          <a:lstStyle/>
-          <a:p>
-            <a:fld id="{A91F55E2-A889-F24B-B1FE-1E878178F308}" type="datetime1">
-              <a:rPr lang="en-US" smtClean="0"/>
-              <a:t>3/14/26</a:t>
-            </a:fld>
-            <a:endParaRPr lang="en-US"/>
-          </a:p>
-        </p:txBody>
-      </p:sp>
-      <p:sp>
-        <p:nvSpPr>
-          <p:cNvPr id="5" name="Footer Placeholder 4">
-            <a:extLst>
-              <a:ext uri="{FF2B5EF4-FFF2-40B4-BE49-F238E27FC236}">
-                <a16:creationId xmlns:a16="http://schemas.microsoft.com/office/drawing/2014/main" id="{C68FC4AF-90CF-484C-B6C7-5CE1A016FB49}"/>
-              </a:ext>
-            </a:extLst>
-          </p:cNvPr>
-          <p:cNvSpPr>
-            <a:spLocks noGrp="1"/>
-          </p:cNvSpPr>
-          <p:nvPr>
-            <p:ph type="ftr" sz="quarter" idx="11"/>
-          </p:nvPr>
-        </p:nvSpPr>
-        <p:spPr/>
-        <p:txBody>
-          <a:bodyPr/>
-          <a:lstStyle/>
-          <a:p>
-            <a:r>
-              <a:rPr lang="en-US"/>
-              <a:t>J Mark Morris - Model of Nature - April 2019</a:t>
-            </a:r>
-          </a:p>
-        </p:txBody>
-      </p:sp>
-      <p:sp>
-        <p:nvSpPr>
-          <p:cNvPr id="6" name="Slide Number Placeholder 5">
-            <a:extLst>
-              <a:ext uri="{FF2B5EF4-FFF2-40B4-BE49-F238E27FC236}">
-                <a16:creationId xmlns:a16="http://schemas.microsoft.com/office/drawing/2014/main" id="{8169AF1E-33D8-3041-A601-1384C718A8B5}"/>
-              </a:ext>
-            </a:extLst>
-          </p:cNvPr>
-          <p:cNvSpPr>
-            <a:spLocks noGrp="1"/>
-          </p:cNvSpPr>
-          <p:nvPr>
-            <p:ph type="sldNum" sz="quarter" idx="12"/>
-          </p:nvPr>
-        </p:nvSpPr>
-        <p:spPr/>
-        <p:txBody>
-          <a:bodyPr/>
-          <a:lstStyle/>
-          <a:p>
-            <a:fld id="{D73D4D4B-2FF7-BE46-958C-B004BD45EF6F}" type="slidenum">
-              <a:rPr lang="en-US" smtClean="0"/>
-              <a:t>‹#›</a:t>
-            </a:fld>
-            <a:endParaRPr lang="en-US"/>
-          </a:p>
-        </p:txBody>
-      </p:sp>
-    </p:spTree>
-    <p:extLst>
-      <p:ext uri="{BB962C8B-B14F-4D97-AF65-F5344CB8AC3E}">
-        <p14:creationId xmlns:p14="http://schemas.microsoft.com/office/powerpoint/2010/main" val="497139919"/>
-      </p:ext>
-    </p:extLst>
-  </p:cSld>
-  <p:clrMapOvr>
-    <a:masterClrMapping/>
-  </p:clrMapOvr>
-</p:sldLayout>
-</file>
-
-<file path=ppt/slideLayouts/slideLayout14.xml><?xml version="1.0" encoding="utf-8"?>
-<p:sldLayout xmlns:a="http://schemas.openxmlformats.org/drawingml/2006/main" xmlns:r="http://schemas.openxmlformats.org/officeDocument/2006/relationships" xmlns:p="http://schemas.openxmlformats.org/presentationml/2006/main" type="titleOnly" preserve="1">
-  <p:cSld name="Title Only">
-    <p:spTree>
-      <p:nvGrpSpPr>
-        <p:cNvPr id="1" name=""/>
-        <p:cNvGrpSpPr/>
-        <p:nvPr/>
-      </p:nvGrpSpPr>
-      <p:grpSpPr>
-        <a:xfrm>
-          <a:off x="0" y="0"/>
-          <a:ext cx="0" cy="0"/>
-          <a:chOff x="0" y="0"/>
-          <a:chExt cx="0" cy="0"/>
-        </a:xfrm>
-      </p:grpSpPr>
-      <p:sp>
-        <p:nvSpPr>
-          <p:cNvPr id="2" name="Title 1">
-            <a:extLst>
-              <a:ext uri="{FF2B5EF4-FFF2-40B4-BE49-F238E27FC236}">
-                <a16:creationId xmlns:a16="http://schemas.microsoft.com/office/drawing/2014/main" id="{5821822D-6D7A-1342-98EF-890C6F2DA174}"/>
-              </a:ext>
-            </a:extLst>
-          </p:cNvPr>
-          <p:cNvSpPr>
-            <a:spLocks noGrp="1"/>
-          </p:cNvSpPr>
-          <p:nvPr>
-            <p:ph type="title"/>
-          </p:nvPr>
-        </p:nvSpPr>
-        <p:spPr>
-          <a:xfrm>
-            <a:off x="838200" y="365125"/>
-            <a:ext cx="10515600" cy="777875"/>
-          </a:xfrm>
-        </p:spPr>
-        <p:txBody>
-          <a:bodyPr/>
-          <a:lstStyle/>
-          <a:p>
-            <a:r>
-              <a:rPr lang="en-US"/>
-              <a:t>Click to edit Master title style</a:t>
-            </a:r>
-          </a:p>
-        </p:txBody>
-      </p:sp>
-      <p:sp>
-        <p:nvSpPr>
-          <p:cNvPr id="3" name="Date Placeholder 2">
-            <a:extLst>
-              <a:ext uri="{FF2B5EF4-FFF2-40B4-BE49-F238E27FC236}">
-                <a16:creationId xmlns:a16="http://schemas.microsoft.com/office/drawing/2014/main" id="{74CF19EA-9170-5B4B-814F-7425C8E22823}"/>
-              </a:ext>
-            </a:extLst>
-          </p:cNvPr>
-          <p:cNvSpPr>
-            <a:spLocks noGrp="1"/>
-          </p:cNvSpPr>
-          <p:nvPr>
-            <p:ph type="dt" sz="half" idx="10"/>
-          </p:nvPr>
-        </p:nvSpPr>
-        <p:spPr/>
-        <p:txBody>
-          <a:bodyPr/>
-          <a:lstStyle/>
-          <a:p>
-            <a:fld id="{C6E8461C-3391-334C-9885-001B32D724C4}" type="datetime1">
-              <a:rPr lang="en-US" smtClean="0"/>
-              <a:t>3/14/26</a:t>
-            </a:fld>
-            <a:endParaRPr lang="en-US"/>
-          </a:p>
-        </p:txBody>
-      </p:sp>
-      <p:sp>
-        <p:nvSpPr>
-          <p:cNvPr id="4" name="Footer Placeholder 3">
-            <a:extLst>
-              <a:ext uri="{FF2B5EF4-FFF2-40B4-BE49-F238E27FC236}">
-                <a16:creationId xmlns:a16="http://schemas.microsoft.com/office/drawing/2014/main" id="{5882B1FB-ECDF-AD43-9020-0267ED91C04E}"/>
-              </a:ext>
-            </a:extLst>
-          </p:cNvPr>
-          <p:cNvSpPr>
-            <a:spLocks noGrp="1"/>
-          </p:cNvSpPr>
-          <p:nvPr>
-            <p:ph type="ftr" sz="quarter" idx="11"/>
-          </p:nvPr>
-        </p:nvSpPr>
-        <p:spPr/>
-        <p:txBody>
-          <a:bodyPr/>
-          <a:lstStyle>
-            <a:lvl1pPr>
-              <a:defRPr/>
-            </a:lvl1pPr>
-          </a:lstStyle>
-          <a:p>
-            <a:r>
-              <a:rPr lang="en-US"/>
-              <a:t>J Mark Morris - Model of Nature - April 2019</a:t>
-            </a:r>
-          </a:p>
-        </p:txBody>
-      </p:sp>
-      <p:sp>
-        <p:nvSpPr>
-          <p:cNvPr id="5" name="Slide Number Placeholder 4">
-            <a:extLst>
-              <a:ext uri="{FF2B5EF4-FFF2-40B4-BE49-F238E27FC236}">
-                <a16:creationId xmlns:a16="http://schemas.microsoft.com/office/drawing/2014/main" id="{D949C470-5AF0-5246-81E7-95EAEE5639EF}"/>
-              </a:ext>
-            </a:extLst>
-          </p:cNvPr>
-          <p:cNvSpPr>
-            <a:spLocks noGrp="1"/>
-          </p:cNvSpPr>
-          <p:nvPr>
-            <p:ph type="sldNum" sz="quarter" idx="12"/>
-          </p:nvPr>
-        </p:nvSpPr>
-        <p:spPr/>
-        <p:txBody>
-          <a:bodyPr/>
-          <a:lstStyle/>
-          <a:p>
-            <a:fld id="{D73D4D4B-2FF7-BE46-958C-B004BD45EF6F}" type="slidenum">
-              <a:rPr lang="en-US" smtClean="0"/>
-              <a:t>‹#›</a:t>
-            </a:fld>
-            <a:endParaRPr lang="en-US"/>
-          </a:p>
-        </p:txBody>
-      </p:sp>
-    </p:spTree>
-    <p:extLst>
-      <p:ext uri="{BB962C8B-B14F-4D97-AF65-F5344CB8AC3E}">
-        <p14:creationId xmlns:p14="http://schemas.microsoft.com/office/powerpoint/2010/main" val="1963469369"/>
-      </p:ext>
-    </p:extLst>
-  </p:cSld>
-  <p:clrMapOvr>
-    <a:masterClrMapping/>
-  </p:clrMapOvr>
-</p:sldLayout>
-</file>
-
 <file path=ppt/slideLayouts/slideLayout2.xml><?xml version="1.0" encoding="utf-8"?>
 <p:sldLayout xmlns:a="http://schemas.openxmlformats.org/drawingml/2006/main" xmlns:r="http://schemas.openxmlformats.org/officeDocument/2006/relationships" xmlns:p="http://schemas.openxmlformats.org/presentationml/2006/main" type="obj" preserve="1">
   <p:cSld name="Title and Content">
@@ -5992,7 +5399,7 @@
           <a:p>
             <a:fld id="{CB70D3E6-D921-5B44-AC8D-B7FDAFC8A532}" type="datetimeFigureOut">
               <a:rPr lang="en-US" smtClean="0"/>
-              <a:t>3/14/26</a:t>
+              <a:t>7/3/26</a:t>
             </a:fld>
             <a:endParaRPr lang="en-US"/>
           </a:p>
@@ -6267,7 +5674,7 @@
           <a:p>
             <a:fld id="{CB70D3E6-D921-5B44-AC8D-B7FDAFC8A532}" type="datetimeFigureOut">
               <a:rPr lang="en-US" smtClean="0"/>
-              <a:t>3/14/26</a:t>
+              <a:t>7/3/26</a:t>
             </a:fld>
             <a:endParaRPr lang="en-US"/>
           </a:p>
@@ -6532,7 +5939,7 @@
           <a:p>
             <a:fld id="{CB70D3E6-D921-5B44-AC8D-B7FDAFC8A532}" type="datetimeFigureOut">
               <a:rPr lang="en-US" smtClean="0"/>
-              <a:t>3/14/26</a:t>
+              <a:t>7/3/26</a:t>
             </a:fld>
             <a:endParaRPr lang="en-US"/>
           </a:p>
@@ -6944,7 +6351,7 @@
           <a:p>
             <a:fld id="{CB70D3E6-D921-5B44-AC8D-B7FDAFC8A532}" type="datetimeFigureOut">
               <a:rPr lang="en-US" smtClean="0"/>
-              <a:t>3/14/26</a:t>
+              <a:t>7/3/26</a:t>
             </a:fld>
             <a:endParaRPr lang="en-US"/>
           </a:p>
@@ -7085,7 +6492,7 @@
           <a:p>
             <a:fld id="{CB70D3E6-D921-5B44-AC8D-B7FDAFC8A532}" type="datetimeFigureOut">
               <a:rPr lang="en-US" smtClean="0"/>
-              <a:t>3/14/26</a:t>
+              <a:t>7/3/26</a:t>
             </a:fld>
             <a:endParaRPr lang="en-US"/>
           </a:p>
@@ -7198,7 +6605,7 @@
           <a:p>
             <a:fld id="{CB70D3E6-D921-5B44-AC8D-B7FDAFC8A532}" type="datetimeFigureOut">
               <a:rPr lang="en-US" smtClean="0"/>
-              <a:t>3/14/26</a:t>
+              <a:t>7/3/26</a:t>
             </a:fld>
             <a:endParaRPr lang="en-US"/>
           </a:p>
@@ -7509,7 +6916,7 @@
           <a:p>
             <a:fld id="{CB70D3E6-D921-5B44-AC8D-B7FDAFC8A532}" type="datetimeFigureOut">
               <a:rPr lang="en-US" smtClean="0"/>
-              <a:t>3/14/26</a:t>
+              <a:t>7/3/26</a:t>
             </a:fld>
             <a:endParaRPr lang="en-US"/>
           </a:p>
@@ -7797,7 +7204,7 @@
           <a:p>
             <a:fld id="{CB70D3E6-D921-5B44-AC8D-B7FDAFC8A532}" type="datetimeFigureOut">
               <a:rPr lang="en-US" smtClean="0"/>
-              <a:t>3/14/26</a:t>
+              <a:t>7/3/26</a:t>
             </a:fld>
             <a:endParaRPr lang="en-US"/>
           </a:p>
@@ -8038,7 +7445,7 @@
           <a:p>
             <a:fld id="{CB70D3E6-D921-5B44-AC8D-B7FDAFC8A532}" type="datetimeFigureOut">
               <a:rPr lang="en-US" smtClean="0"/>
-              <a:t>3/14/26</a:t>
+              <a:t>7/3/26</a:t>
             </a:fld>
             <a:endParaRPr lang="en-US"/>
           </a:p>
@@ -8438,580 +7845,6 @@
 </p:sldMaster>
 </file>
 
-<file path=ppt/slideMasters/slideMaster2.xml><?xml version="1.0" encoding="utf-8"?>
-<p:sldMaster xmlns:a="http://schemas.openxmlformats.org/drawingml/2006/main" xmlns:r="http://schemas.openxmlformats.org/officeDocument/2006/relationships" xmlns:p="http://schemas.openxmlformats.org/presentationml/2006/main">
-  <p:cSld>
-    <p:bg>
-      <p:bgRef idx="1001">
-        <a:schemeClr val="bg1"/>
-      </p:bgRef>
-    </p:bg>
-    <p:spTree>
-      <p:nvGrpSpPr>
-        <p:cNvPr id="1" name=""/>
-        <p:cNvGrpSpPr/>
-        <p:nvPr/>
-      </p:nvGrpSpPr>
-      <p:grpSpPr>
-        <a:xfrm>
-          <a:off x="0" y="0"/>
-          <a:ext cx="0" cy="0"/>
-          <a:chOff x="0" y="0"/>
-          <a:chExt cx="0" cy="0"/>
-        </a:xfrm>
-      </p:grpSpPr>
-      <p:sp>
-        <p:nvSpPr>
-          <p:cNvPr id="2" name="Title Placeholder 1">
-            <a:extLst>
-              <a:ext uri="{FF2B5EF4-FFF2-40B4-BE49-F238E27FC236}">
-                <a16:creationId xmlns:a16="http://schemas.microsoft.com/office/drawing/2014/main" id="{4C79A1DB-155B-0846-9CED-8B75F56E0E58}"/>
-              </a:ext>
-            </a:extLst>
-          </p:cNvPr>
-          <p:cNvSpPr>
-            <a:spLocks noGrp="1"/>
-          </p:cNvSpPr>
-          <p:nvPr>
-            <p:ph type="title"/>
-          </p:nvPr>
-        </p:nvSpPr>
-        <p:spPr>
-          <a:xfrm>
-            <a:off x="838200" y="365125"/>
-            <a:ext cx="10515600" cy="1325563"/>
-          </a:xfrm>
-          <a:prstGeom prst="rect">
-            <a:avLst/>
-          </a:prstGeom>
-        </p:spPr>
-        <p:txBody>
-          <a:bodyPr vert="horz" lIns="91440" tIns="45720" rIns="91440" bIns="45720" rtlCol="0" anchor="ctr">
-            <a:normAutofit/>
-          </a:bodyPr>
-          <a:lstStyle/>
-          <a:p>
-            <a:r>
-              <a:rPr lang="en-US" dirty="0"/>
-              <a:t>Click to edit Master title style</a:t>
-            </a:r>
-          </a:p>
-        </p:txBody>
-      </p:sp>
-      <p:sp>
-        <p:nvSpPr>
-          <p:cNvPr id="3" name="Text Placeholder 2">
-            <a:extLst>
-              <a:ext uri="{FF2B5EF4-FFF2-40B4-BE49-F238E27FC236}">
-                <a16:creationId xmlns:a16="http://schemas.microsoft.com/office/drawing/2014/main" id="{FD69736F-08D5-7643-A656-ABAEB9457A7A}"/>
-              </a:ext>
-            </a:extLst>
-          </p:cNvPr>
-          <p:cNvSpPr>
-            <a:spLocks noGrp="1"/>
-          </p:cNvSpPr>
-          <p:nvPr>
-            <p:ph type="body" idx="1"/>
-          </p:nvPr>
-        </p:nvSpPr>
-        <p:spPr>
-          <a:xfrm>
-            <a:off x="838200" y="1825625"/>
-            <a:ext cx="10515600" cy="4351338"/>
-          </a:xfrm>
-          <a:prstGeom prst="rect">
-            <a:avLst/>
-          </a:prstGeom>
-        </p:spPr>
-        <p:txBody>
-          <a:bodyPr vert="horz" lIns="91440" tIns="45720" rIns="91440" bIns="45720" rtlCol="0">
-            <a:normAutofit/>
-          </a:bodyPr>
-          <a:lstStyle/>
-          <a:p>
-            <a:pPr lvl="0"/>
-            <a:r>
-              <a:rPr lang="en-US"/>
-              <a:t>Edit Master text styles</a:t>
-            </a:r>
-          </a:p>
-          <a:p>
-            <a:pPr lvl="1"/>
-            <a:r>
-              <a:rPr lang="en-US"/>
-              <a:t>Second level</a:t>
-            </a:r>
-          </a:p>
-          <a:p>
-            <a:pPr lvl="2"/>
-            <a:r>
-              <a:rPr lang="en-US"/>
-              <a:t>Third level</a:t>
-            </a:r>
-          </a:p>
-          <a:p>
-            <a:pPr lvl="3"/>
-            <a:r>
-              <a:rPr lang="en-US"/>
-              <a:t>Fourth level</a:t>
-            </a:r>
-          </a:p>
-          <a:p>
-            <a:pPr lvl="4"/>
-            <a:r>
-              <a:rPr lang="en-US"/>
-              <a:t>Fifth level</a:t>
-            </a:r>
-          </a:p>
-        </p:txBody>
-      </p:sp>
-      <p:sp>
-        <p:nvSpPr>
-          <p:cNvPr id="4" name="Date Placeholder 3">
-            <a:extLst>
-              <a:ext uri="{FF2B5EF4-FFF2-40B4-BE49-F238E27FC236}">
-                <a16:creationId xmlns:a16="http://schemas.microsoft.com/office/drawing/2014/main" id="{C0433D04-66F5-D74B-8EEA-459FDC00D1E4}"/>
-              </a:ext>
-            </a:extLst>
-          </p:cNvPr>
-          <p:cNvSpPr>
-            <a:spLocks noGrp="1"/>
-          </p:cNvSpPr>
-          <p:nvPr>
-            <p:ph type="dt" sz="half" idx="2"/>
-          </p:nvPr>
-        </p:nvSpPr>
-        <p:spPr>
-          <a:xfrm>
-            <a:off x="838200" y="6356350"/>
-            <a:ext cx="2743200" cy="365125"/>
-          </a:xfrm>
-          <a:prstGeom prst="rect">
-            <a:avLst/>
-          </a:prstGeom>
-        </p:spPr>
-        <p:txBody>
-          <a:bodyPr vert="horz" lIns="91440" tIns="45720" rIns="91440" bIns="45720" rtlCol="0" anchor="ctr"/>
-          <a:lstStyle>
-            <a:lvl1pPr algn="l">
-              <a:defRPr sz="1200">
-                <a:solidFill>
-                  <a:schemeClr val="tx1">
-                    <a:tint val="75000"/>
-                  </a:schemeClr>
-                </a:solidFill>
-                <a:latin typeface="Helvetica Neue" panose="02000503000000020004" pitchFamily="2" charset="0"/>
-                <a:ea typeface="Helvetica Neue" panose="02000503000000020004" pitchFamily="2" charset="0"/>
-                <a:cs typeface="Helvetica Neue" panose="02000503000000020004" pitchFamily="2" charset="0"/>
-              </a:defRPr>
-            </a:lvl1pPr>
-          </a:lstStyle>
-          <a:p>
-            <a:fld id="{2005EE61-3907-C44D-8624-D47E09E871DB}" type="datetime1">
-              <a:rPr lang="en-US" smtClean="0"/>
-              <a:t>3/14/26</a:t>
-            </a:fld>
-            <a:endParaRPr lang="en-US"/>
-          </a:p>
-        </p:txBody>
-      </p:sp>
-      <p:sp>
-        <p:nvSpPr>
-          <p:cNvPr id="5" name="Footer Placeholder 4">
-            <a:extLst>
-              <a:ext uri="{FF2B5EF4-FFF2-40B4-BE49-F238E27FC236}">
-                <a16:creationId xmlns:a16="http://schemas.microsoft.com/office/drawing/2014/main" id="{9FDE6E67-6F97-E149-8437-635D11E7ED43}"/>
-              </a:ext>
-            </a:extLst>
-          </p:cNvPr>
-          <p:cNvSpPr>
-            <a:spLocks noGrp="1"/>
-          </p:cNvSpPr>
-          <p:nvPr>
-            <p:ph type="ftr" sz="quarter" idx="3"/>
-          </p:nvPr>
-        </p:nvSpPr>
-        <p:spPr>
-          <a:xfrm>
-            <a:off x="4038600" y="6356350"/>
-            <a:ext cx="4114800" cy="365125"/>
-          </a:xfrm>
-          <a:prstGeom prst="rect">
-            <a:avLst/>
-          </a:prstGeom>
-        </p:spPr>
-        <p:txBody>
-          <a:bodyPr vert="horz" lIns="91440" tIns="45720" rIns="91440" bIns="45720" rtlCol="0" anchor="ctr"/>
-          <a:lstStyle>
-            <a:lvl1pPr algn="ctr">
-              <a:defRPr sz="1200">
-                <a:solidFill>
-                  <a:schemeClr val="tx1">
-                    <a:tint val="75000"/>
-                  </a:schemeClr>
-                </a:solidFill>
-                <a:latin typeface="Helvetica Neue" panose="02000503000000020004" pitchFamily="2" charset="0"/>
-                <a:ea typeface="Helvetica Neue" panose="02000503000000020004" pitchFamily="2" charset="0"/>
-                <a:cs typeface="Helvetica Neue" panose="02000503000000020004" pitchFamily="2" charset="0"/>
-              </a:defRPr>
-            </a:lvl1pPr>
-          </a:lstStyle>
-          <a:p>
-            <a:r>
-              <a:rPr lang="en-US"/>
-              <a:t>J Mark Morris - Model of Nature - April 2019</a:t>
-            </a:r>
-          </a:p>
-        </p:txBody>
-      </p:sp>
-      <p:sp>
-        <p:nvSpPr>
-          <p:cNvPr id="6" name="Slide Number Placeholder 5">
-            <a:extLst>
-              <a:ext uri="{FF2B5EF4-FFF2-40B4-BE49-F238E27FC236}">
-                <a16:creationId xmlns:a16="http://schemas.microsoft.com/office/drawing/2014/main" id="{D585CC1E-0AB1-F34A-83C6-0956BF9B4AF3}"/>
-              </a:ext>
-            </a:extLst>
-          </p:cNvPr>
-          <p:cNvSpPr>
-            <a:spLocks noGrp="1"/>
-          </p:cNvSpPr>
-          <p:nvPr>
-            <p:ph type="sldNum" sz="quarter" idx="4"/>
-          </p:nvPr>
-        </p:nvSpPr>
-        <p:spPr>
-          <a:xfrm>
-            <a:off x="8610600" y="6356350"/>
-            <a:ext cx="2743200" cy="365125"/>
-          </a:xfrm>
-          <a:prstGeom prst="rect">
-            <a:avLst/>
-          </a:prstGeom>
-        </p:spPr>
-        <p:txBody>
-          <a:bodyPr vert="horz" lIns="91440" tIns="45720" rIns="91440" bIns="45720" rtlCol="0" anchor="ctr"/>
-          <a:lstStyle>
-            <a:lvl1pPr algn="r">
-              <a:defRPr sz="1200">
-                <a:solidFill>
-                  <a:schemeClr val="tx1">
-                    <a:tint val="75000"/>
-                  </a:schemeClr>
-                </a:solidFill>
-                <a:latin typeface="Helvetica Neue" panose="02000503000000020004" pitchFamily="2" charset="0"/>
-                <a:ea typeface="Helvetica Neue" panose="02000503000000020004" pitchFamily="2" charset="0"/>
-                <a:cs typeface="Helvetica Neue" panose="02000503000000020004" pitchFamily="2" charset="0"/>
-              </a:defRPr>
-            </a:lvl1pPr>
-          </a:lstStyle>
-          <a:p>
-            <a:fld id="{D73D4D4B-2FF7-BE46-958C-B004BD45EF6F}" type="slidenum">
-              <a:rPr lang="en-US" smtClean="0"/>
-              <a:pPr/>
-              <a:t>‹#›</a:t>
-            </a:fld>
-            <a:endParaRPr lang="en-US"/>
-          </a:p>
-        </p:txBody>
-      </p:sp>
-    </p:spTree>
-    <p:extLst>
-      <p:ext uri="{BB962C8B-B14F-4D97-AF65-F5344CB8AC3E}">
-        <p14:creationId xmlns:p14="http://schemas.microsoft.com/office/powerpoint/2010/main" val="4188259015"/>
-      </p:ext>
-    </p:extLst>
-  </p:cSld>
-  <p:clrMap bg1="lt1" tx1="dk1" bg2="lt2" tx2="dk2" accent1="accent1" accent2="accent2" accent3="accent3" accent4="accent4" accent5="accent5" accent6="accent6" hlink="hlink" folHlink="folHlink"/>
-  <p:sldLayoutIdLst>
-    <p:sldLayoutId id="2147483665" r:id="rId1"/>
-    <p:sldLayoutId id="2147483666" r:id="rId2"/>
-    <p:sldLayoutId id="2147483667" r:id="rId3"/>
-  </p:sldLayoutIdLst>
-  <p:hf sldNum="0" hdr="0" dt="0"/>
-  <p:txStyles>
-    <p:titleStyle>
-      <a:lvl1pPr algn="l" defTabSz="914400" rtl="0" eaLnBrk="1" latinLnBrk="0" hangingPunct="1">
-        <a:lnSpc>
-          <a:spcPct val="90000"/>
-        </a:lnSpc>
-        <a:spcBef>
-          <a:spcPct val="0"/>
-        </a:spcBef>
-        <a:buNone/>
-        <a:defRPr sz="4400" kern="1200">
-          <a:solidFill>
-            <a:schemeClr val="tx1"/>
-          </a:solidFill>
-          <a:latin typeface="Helvetica Neue" panose="02000503000000020004" pitchFamily="2" charset="0"/>
-          <a:ea typeface="Helvetica Neue" panose="02000503000000020004" pitchFamily="2" charset="0"/>
-          <a:cs typeface="Helvetica Neue" panose="02000503000000020004" pitchFamily="2" charset="0"/>
-        </a:defRPr>
-      </a:lvl1pPr>
-    </p:titleStyle>
-    <p:bodyStyle>
-      <a:lvl1pPr marL="228600" indent="-228600" algn="l" defTabSz="914400" rtl="0" eaLnBrk="1" latinLnBrk="0" hangingPunct="1">
-        <a:lnSpc>
-          <a:spcPct val="90000"/>
-        </a:lnSpc>
-        <a:spcBef>
-          <a:spcPts val="1000"/>
-        </a:spcBef>
-        <a:buFont typeface="Arial" panose="020B0604020202020204" pitchFamily="34" charset="0"/>
-        <a:buChar char="•"/>
-        <a:defRPr sz="2800" kern="1200">
-          <a:solidFill>
-            <a:schemeClr val="tx1"/>
-          </a:solidFill>
-          <a:latin typeface="Helvetica Neue" panose="02000503000000020004" pitchFamily="2" charset="0"/>
-          <a:ea typeface="Helvetica Neue" panose="02000503000000020004" pitchFamily="2" charset="0"/>
-          <a:cs typeface="Helvetica Neue" panose="02000503000000020004" pitchFamily="2" charset="0"/>
-        </a:defRPr>
-      </a:lvl1pPr>
-      <a:lvl2pPr marL="685800" indent="-228600" algn="l" defTabSz="914400" rtl="0" eaLnBrk="1" latinLnBrk="0" hangingPunct="1">
-        <a:lnSpc>
-          <a:spcPct val="90000"/>
-        </a:lnSpc>
-        <a:spcBef>
-          <a:spcPts val="500"/>
-        </a:spcBef>
-        <a:buFont typeface="Arial" panose="020B0604020202020204" pitchFamily="34" charset="0"/>
-        <a:buChar char="•"/>
-        <a:defRPr sz="2400" kern="1200">
-          <a:solidFill>
-            <a:schemeClr val="tx1"/>
-          </a:solidFill>
-          <a:latin typeface="Helvetica Neue" panose="02000503000000020004" pitchFamily="2" charset="0"/>
-          <a:ea typeface="Helvetica Neue" panose="02000503000000020004" pitchFamily="2" charset="0"/>
-          <a:cs typeface="Helvetica Neue" panose="02000503000000020004" pitchFamily="2" charset="0"/>
-        </a:defRPr>
-      </a:lvl2pPr>
-      <a:lvl3pPr marL="1143000" indent="-228600" algn="l" defTabSz="914400" rtl="0" eaLnBrk="1" latinLnBrk="0" hangingPunct="1">
-        <a:lnSpc>
-          <a:spcPct val="90000"/>
-        </a:lnSpc>
-        <a:spcBef>
-          <a:spcPts val="500"/>
-        </a:spcBef>
-        <a:buFont typeface="Arial" panose="020B0604020202020204" pitchFamily="34" charset="0"/>
-        <a:buChar char="•"/>
-        <a:defRPr sz="2000" kern="1200">
-          <a:solidFill>
-            <a:schemeClr val="tx1"/>
-          </a:solidFill>
-          <a:latin typeface="Helvetica Neue" panose="02000503000000020004" pitchFamily="2" charset="0"/>
-          <a:ea typeface="Helvetica Neue" panose="02000503000000020004" pitchFamily="2" charset="0"/>
-          <a:cs typeface="Helvetica Neue" panose="02000503000000020004" pitchFamily="2" charset="0"/>
-        </a:defRPr>
-      </a:lvl3pPr>
-      <a:lvl4pPr marL="1600200" indent="-228600" algn="l" defTabSz="914400" rtl="0" eaLnBrk="1" latinLnBrk="0" hangingPunct="1">
-        <a:lnSpc>
-          <a:spcPct val="90000"/>
-        </a:lnSpc>
-        <a:spcBef>
-          <a:spcPts val="500"/>
-        </a:spcBef>
-        <a:buFont typeface="Arial" panose="020B0604020202020204" pitchFamily="34" charset="0"/>
-        <a:buChar char="•"/>
-        <a:defRPr sz="1800" kern="1200">
-          <a:solidFill>
-            <a:schemeClr val="tx1"/>
-          </a:solidFill>
-          <a:latin typeface="Helvetica Neue" panose="02000503000000020004" pitchFamily="2" charset="0"/>
-          <a:ea typeface="Helvetica Neue" panose="02000503000000020004" pitchFamily="2" charset="0"/>
-          <a:cs typeface="Helvetica Neue" panose="02000503000000020004" pitchFamily="2" charset="0"/>
-        </a:defRPr>
-      </a:lvl4pPr>
-      <a:lvl5pPr marL="2057400" indent="-228600" algn="l" defTabSz="914400" rtl="0" eaLnBrk="1" latinLnBrk="0" hangingPunct="1">
-        <a:lnSpc>
-          <a:spcPct val="90000"/>
-        </a:lnSpc>
-        <a:spcBef>
-          <a:spcPts val="500"/>
-        </a:spcBef>
-        <a:buFont typeface="Arial" panose="020B0604020202020204" pitchFamily="34" charset="0"/>
-        <a:buChar char="•"/>
-        <a:defRPr sz="1800" kern="1200">
-          <a:solidFill>
-            <a:schemeClr val="tx1"/>
-          </a:solidFill>
-          <a:latin typeface="Helvetica Neue" panose="02000503000000020004" pitchFamily="2" charset="0"/>
-          <a:ea typeface="Helvetica Neue" panose="02000503000000020004" pitchFamily="2" charset="0"/>
-          <a:cs typeface="Helvetica Neue" panose="02000503000000020004" pitchFamily="2" charset="0"/>
-        </a:defRPr>
-      </a:lvl5pPr>
-      <a:lvl6pPr marL="2514600" indent="-228600" algn="l" defTabSz="914400" rtl="0" eaLnBrk="1" latinLnBrk="0" hangingPunct="1">
-        <a:lnSpc>
-          <a:spcPct val="90000"/>
-        </a:lnSpc>
-        <a:spcBef>
-          <a:spcPts val="500"/>
-        </a:spcBef>
-        <a:buFont typeface="Arial" panose="020B0604020202020204" pitchFamily="34" charset="0"/>
-        <a:buChar char="•"/>
-        <a:defRPr sz="1800" kern="1200">
-          <a:solidFill>
-            <a:schemeClr val="tx1"/>
-          </a:solidFill>
-          <a:latin typeface="+mn-lt"/>
-          <a:ea typeface="+mn-ea"/>
-          <a:cs typeface="+mn-cs"/>
-        </a:defRPr>
-      </a:lvl6pPr>
-      <a:lvl7pPr marL="2971800" indent="-228600" algn="l" defTabSz="914400" rtl="0" eaLnBrk="1" latinLnBrk="0" hangingPunct="1">
-        <a:lnSpc>
-          <a:spcPct val="90000"/>
-        </a:lnSpc>
-        <a:spcBef>
-          <a:spcPts val="500"/>
-        </a:spcBef>
-        <a:buFont typeface="Arial" panose="020B0604020202020204" pitchFamily="34" charset="0"/>
-        <a:buChar char="•"/>
-        <a:defRPr sz="1800" kern="1200">
-          <a:solidFill>
-            <a:schemeClr val="tx1"/>
-          </a:solidFill>
-          <a:latin typeface="+mn-lt"/>
-          <a:ea typeface="+mn-ea"/>
-          <a:cs typeface="+mn-cs"/>
-        </a:defRPr>
-      </a:lvl7pPr>
-      <a:lvl8pPr marL="3429000" indent="-228600" algn="l" defTabSz="914400" rtl="0" eaLnBrk="1" latinLnBrk="0" hangingPunct="1">
-        <a:lnSpc>
-          <a:spcPct val="90000"/>
-        </a:lnSpc>
-        <a:spcBef>
-          <a:spcPts val="500"/>
-        </a:spcBef>
-        <a:buFont typeface="Arial" panose="020B0604020202020204" pitchFamily="34" charset="0"/>
-        <a:buChar char="•"/>
-        <a:defRPr sz="1800" kern="1200">
-          <a:solidFill>
-            <a:schemeClr val="tx1"/>
-          </a:solidFill>
-          <a:latin typeface="+mn-lt"/>
-          <a:ea typeface="+mn-ea"/>
-          <a:cs typeface="+mn-cs"/>
-        </a:defRPr>
-      </a:lvl8pPr>
-      <a:lvl9pPr marL="3886200" indent="-228600" algn="l" defTabSz="914400" rtl="0" eaLnBrk="1" latinLnBrk="0" hangingPunct="1">
-        <a:lnSpc>
-          <a:spcPct val="90000"/>
-        </a:lnSpc>
-        <a:spcBef>
-          <a:spcPts val="500"/>
-        </a:spcBef>
-        <a:buFont typeface="Arial" panose="020B0604020202020204" pitchFamily="34" charset="0"/>
-        <a:buChar char="•"/>
-        <a:defRPr sz="1800" kern="1200">
-          <a:solidFill>
-            <a:schemeClr val="tx1"/>
-          </a:solidFill>
-          <a:latin typeface="+mn-lt"/>
-          <a:ea typeface="+mn-ea"/>
-          <a:cs typeface="+mn-cs"/>
-        </a:defRPr>
-      </a:lvl9pPr>
-    </p:bodyStyle>
-    <p:otherStyle>
-      <a:defPPr>
-        <a:defRPr lang="en-US"/>
-      </a:defPPr>
-      <a:lvl1pPr marL="0" algn="l" defTabSz="914400" rtl="0" eaLnBrk="1" latinLnBrk="0" hangingPunct="1">
-        <a:defRPr sz="1800" kern="1200">
-          <a:solidFill>
-            <a:schemeClr val="tx1"/>
-          </a:solidFill>
-          <a:latin typeface="+mn-lt"/>
-          <a:ea typeface="+mn-ea"/>
-          <a:cs typeface="+mn-cs"/>
-        </a:defRPr>
-      </a:lvl1pPr>
-      <a:lvl2pPr marL="457200" algn="l" defTabSz="914400" rtl="0" eaLnBrk="1" latinLnBrk="0" hangingPunct="1">
-        <a:defRPr sz="1800" kern="1200">
-          <a:solidFill>
-            <a:schemeClr val="tx1"/>
-          </a:solidFill>
-          <a:latin typeface="+mn-lt"/>
-          <a:ea typeface="+mn-ea"/>
-          <a:cs typeface="+mn-cs"/>
-        </a:defRPr>
-      </a:lvl2pPr>
-      <a:lvl3pPr marL="914400" algn="l" defTabSz="914400" rtl="0" eaLnBrk="1" latinLnBrk="0" hangingPunct="1">
-        <a:defRPr sz="1800" kern="1200">
-          <a:solidFill>
-            <a:schemeClr val="tx1"/>
-          </a:solidFill>
-          <a:latin typeface="+mn-lt"/>
-          <a:ea typeface="+mn-ea"/>
-          <a:cs typeface="+mn-cs"/>
-        </a:defRPr>
-      </a:lvl3pPr>
-      <a:lvl4pPr marL="1371600" algn="l" defTabSz="914400" rtl="0" eaLnBrk="1" latinLnBrk="0" hangingPunct="1">
-        <a:defRPr sz="1800" kern="1200">
-          <a:solidFill>
-            <a:schemeClr val="tx1"/>
-          </a:solidFill>
-          <a:latin typeface="+mn-lt"/>
-          <a:ea typeface="+mn-ea"/>
-          <a:cs typeface="+mn-cs"/>
-        </a:defRPr>
-      </a:lvl4pPr>
-      <a:lvl5pPr marL="1828800" algn="l" defTabSz="914400" rtl="0" eaLnBrk="1" latinLnBrk="0" hangingPunct="1">
-        <a:defRPr sz="1800" kern="1200">
-          <a:solidFill>
-            <a:schemeClr val="tx1"/>
-          </a:solidFill>
-          <a:latin typeface="+mn-lt"/>
-          <a:ea typeface="+mn-ea"/>
-          <a:cs typeface="+mn-cs"/>
-        </a:defRPr>
-      </a:lvl5pPr>
-      <a:lvl6pPr marL="2286000" algn="l" defTabSz="914400" rtl="0" eaLnBrk="1" latinLnBrk="0" hangingPunct="1">
-        <a:defRPr sz="1800" kern="1200">
-          <a:solidFill>
-            <a:schemeClr val="tx1"/>
-          </a:solidFill>
-          <a:latin typeface="+mn-lt"/>
-          <a:ea typeface="+mn-ea"/>
-          <a:cs typeface="+mn-cs"/>
-        </a:defRPr>
-      </a:lvl6pPr>
-      <a:lvl7pPr marL="2743200" algn="l" defTabSz="914400" rtl="0" eaLnBrk="1" latinLnBrk="0" hangingPunct="1">
-        <a:defRPr sz="1800" kern="1200">
-          <a:solidFill>
-            <a:schemeClr val="tx1"/>
-          </a:solidFill>
-          <a:latin typeface="+mn-lt"/>
-          <a:ea typeface="+mn-ea"/>
-          <a:cs typeface="+mn-cs"/>
-        </a:defRPr>
-      </a:lvl7pPr>
-      <a:lvl8pPr marL="3200400" algn="l" defTabSz="914400" rtl="0" eaLnBrk="1" latinLnBrk="0" hangingPunct="1">
-        <a:defRPr sz="1800" kern="1200">
-          <a:solidFill>
-            <a:schemeClr val="tx1"/>
-          </a:solidFill>
-          <a:latin typeface="+mn-lt"/>
-          <a:ea typeface="+mn-ea"/>
-          <a:cs typeface="+mn-cs"/>
-        </a:defRPr>
-      </a:lvl8pPr>
-      <a:lvl9pPr marL="3657600" algn="l" defTabSz="914400" rtl="0" eaLnBrk="1" latinLnBrk="0" hangingPunct="1">
-        <a:defRPr sz="1800" kern="1200">
-          <a:solidFill>
-            <a:schemeClr val="tx1"/>
-          </a:solidFill>
-          <a:latin typeface="+mn-lt"/>
-          <a:ea typeface="+mn-ea"/>
-          <a:cs typeface="+mn-cs"/>
-        </a:defRPr>
-      </a:lvl9pPr>
-    </p:otherStyle>
-  </p:txStyles>
-</p:sldMaster>
-</file>
-
 <file path=ppt/slides/slide1.xml><?xml version="1.0" encoding="utf-8"?>
 <p:sld xmlns:a="http://schemas.openxmlformats.org/drawingml/2006/main" xmlns:r="http://schemas.openxmlformats.org/officeDocument/2006/relationships" xmlns:p="http://schemas.openxmlformats.org/presentationml/2006/main">
   <p:cSld>
@@ -9136,638 +7969,6 @@
 </file>
 
 <file path=ppt/slides/slide10.xml><?xml version="1.0" encoding="utf-8"?>
-<p:sld xmlns:a="http://schemas.openxmlformats.org/drawingml/2006/main" xmlns:r="http://schemas.openxmlformats.org/officeDocument/2006/relationships" xmlns:p="http://schemas.openxmlformats.org/presentationml/2006/main">
-  <p:cSld>
-    <p:bg>
-      <p:bgPr>
-        <a:solidFill>
-          <a:srgbClr val="7030A0"/>
-        </a:solidFill>
-        <a:effectLst/>
-      </p:bgPr>
-    </p:bg>
-    <p:spTree>
-      <p:nvGrpSpPr>
-        <p:cNvPr id="1" name=""/>
-        <p:cNvGrpSpPr/>
-        <p:nvPr/>
-      </p:nvGrpSpPr>
-      <p:grpSpPr>
-        <a:xfrm>
-          <a:off x="0" y="0"/>
-          <a:ext cx="0" cy="0"/>
-          <a:chOff x="0" y="0"/>
-          <a:chExt cx="0" cy="0"/>
-        </a:xfrm>
-      </p:grpSpPr>
-      <p:sp>
-        <p:nvSpPr>
-          <p:cNvPr id="2" name="TextBox 1">
-            <a:extLst>
-              <a:ext uri="{FF2B5EF4-FFF2-40B4-BE49-F238E27FC236}">
-                <a16:creationId xmlns:a16="http://schemas.microsoft.com/office/drawing/2014/main" id="{018A63B5-40EC-8B9D-0CE4-CED6A7D3C146}"/>
-              </a:ext>
-            </a:extLst>
-          </p:cNvPr>
-          <p:cNvSpPr txBox="1"/>
-          <p:nvPr/>
-        </p:nvSpPr>
-        <p:spPr>
-          <a:xfrm>
-            <a:off x="-70338" y="0"/>
-            <a:ext cx="12262338" cy="6740307"/>
-          </a:xfrm>
-          <a:prstGeom prst="rect">
-            <a:avLst/>
-          </a:prstGeom>
-          <a:noFill/>
-        </p:spPr>
-        <p:txBody>
-          <a:bodyPr wrap="square" rtlCol="0">
-            <a:spAutoFit/>
-          </a:bodyPr>
-          <a:lstStyle/>
-          <a:p>
-            <a:pPr marL="0" marR="0" lvl="0" indent="0" algn="l" defTabSz="914400" rtl="0" eaLnBrk="1" fontAlgn="auto" latinLnBrk="0" hangingPunct="1">
-              <a:lnSpc>
-                <a:spcPct val="100000"/>
-              </a:lnSpc>
-              <a:spcBef>
-                <a:spcPts val="0"/>
-              </a:spcBef>
-              <a:spcAft>
-                <a:spcPts val="0"/>
-              </a:spcAft>
-              <a:buClrTx/>
-              <a:buSzTx/>
-              <a:buFontTx/>
-              <a:buNone/>
-              <a:tabLst/>
-              <a:defRPr/>
-            </a:pPr>
-            <a:r>
-              <a:rPr kumimoji="0" lang="en-US" sz="1600" b="0" i="0" u="none" strike="noStrike" kern="1200" cap="none" spc="0" normalizeH="0" baseline="0" noProof="0" dirty="0">
-                <a:ln>
-                  <a:noFill/>
-                </a:ln>
-                <a:solidFill>
-                  <a:prstClr val="white"/>
-                </a:solidFill>
-                <a:effectLst/>
-                <a:uLnTx/>
-                <a:uFillTx/>
-                <a:latin typeface="Calibri" panose="020F0502020204030204"/>
-                <a:ea typeface="+mn-ea"/>
-                <a:cs typeface="+mn-cs"/>
-              </a:rPr>
-              <a:t>It's like the classic history potential figure. However, if we really contemplated what is happening in this dynamical geometry between any two point potentials is this:</a:t>
-            </a:r>
-          </a:p>
-          <a:p>
-            <a:pPr marL="0" marR="0" lvl="0" indent="0" algn="l" defTabSz="914400" rtl="0" eaLnBrk="1" fontAlgn="auto" latinLnBrk="0" hangingPunct="1">
-              <a:lnSpc>
-                <a:spcPct val="100000"/>
-              </a:lnSpc>
-              <a:spcBef>
-                <a:spcPts val="0"/>
-              </a:spcBef>
-              <a:spcAft>
-                <a:spcPts val="0"/>
-              </a:spcAft>
-              <a:buClrTx/>
-              <a:buSzTx/>
-              <a:buFontTx/>
-              <a:buNone/>
-              <a:tabLst/>
-              <a:defRPr/>
-            </a:pPr>
-            <a:r>
-              <a:rPr kumimoji="0" lang="en-US" sz="1600" b="0" i="0" u="none" strike="noStrike" kern="1200" cap="none" spc="0" normalizeH="0" baseline="0" noProof="0" dirty="0">
-                <a:ln>
-                  <a:noFill/>
-                </a:ln>
-                <a:solidFill>
-                  <a:prstClr val="white"/>
-                </a:solidFill>
-                <a:effectLst/>
-                <a:uLnTx/>
-                <a:uFillTx/>
-                <a:latin typeface="Calibri" panose="020F0502020204030204"/>
-                <a:ea typeface="+mn-ea"/>
-                <a:cs typeface="+mn-cs"/>
-              </a:rPr>
-              <a:t>1. Point potentials follow continuous paths through R4 (t, </a:t>
-            </a:r>
-            <a:r>
-              <a:rPr kumimoji="0" lang="en-US" sz="1600" b="0" i="0" u="none" strike="noStrike" kern="1200" cap="none" spc="0" normalizeH="0" baseline="0" noProof="0" dirty="0" err="1">
-                <a:ln>
-                  <a:noFill/>
-                </a:ln>
-                <a:solidFill>
-                  <a:prstClr val="white"/>
-                </a:solidFill>
-                <a:effectLst/>
-                <a:uLnTx/>
-                <a:uFillTx/>
-                <a:latin typeface="Calibri" panose="020F0502020204030204"/>
-                <a:ea typeface="+mn-ea"/>
-                <a:cs typeface="+mn-cs"/>
-              </a:rPr>
-              <a:t>x,y,z</a:t>
-            </a:r>
-            <a:r>
-              <a:rPr kumimoji="0" lang="en-US" sz="1600" b="0" i="0" u="none" strike="noStrike" kern="1200" cap="none" spc="0" normalizeH="0" baseline="0" noProof="0" dirty="0">
-                <a:ln>
-                  <a:noFill/>
-                </a:ln>
-                <a:solidFill>
-                  <a:prstClr val="white"/>
-                </a:solidFill>
-                <a:effectLst/>
-                <a:uLnTx/>
-                <a:uFillTx/>
-                <a:latin typeface="Calibri" panose="020F0502020204030204"/>
-                <a:ea typeface="+mn-ea"/>
-                <a:cs typeface="+mn-cs"/>
-              </a:rPr>
-              <a:t>, x', y', z'). That is to say at any absolute time each point potential has a position in space and a velocity.</a:t>
-            </a:r>
-          </a:p>
-          <a:p>
-            <a:pPr marL="0" marR="0" lvl="0" indent="0" algn="l" defTabSz="914400" rtl="0" eaLnBrk="1" fontAlgn="auto" latinLnBrk="0" hangingPunct="1">
-              <a:lnSpc>
-                <a:spcPct val="100000"/>
-              </a:lnSpc>
-              <a:spcBef>
-                <a:spcPts val="0"/>
-              </a:spcBef>
-              <a:spcAft>
-                <a:spcPts val="0"/>
-              </a:spcAft>
-              <a:buClrTx/>
-              <a:buSzTx/>
-              <a:buFontTx/>
-              <a:buNone/>
-              <a:tabLst/>
-              <a:defRPr/>
-            </a:pPr>
-            <a:r>
-              <a:rPr kumimoji="0" lang="en-US" sz="1600" b="0" i="0" u="none" strike="noStrike" kern="1200" cap="none" spc="0" normalizeH="0" baseline="0" noProof="0" dirty="0">
-                <a:ln>
-                  <a:noFill/>
-                </a:ln>
-                <a:solidFill>
-                  <a:prstClr val="white"/>
-                </a:solidFill>
-                <a:effectLst/>
-                <a:uLnTx/>
-                <a:uFillTx/>
-                <a:latin typeface="Calibri" panose="020F0502020204030204"/>
-                <a:ea typeface="+mn-ea"/>
-                <a:cs typeface="+mn-cs"/>
-              </a:rPr>
-              <a:t>2. Now consider two point potentials each following their path under the influence of the arriving potential field. Let's limit ourselves to point potential velocities less than field speed, because it is a simpler case. </a:t>
-            </a:r>
-          </a:p>
-          <a:p>
-            <a:pPr marL="0" marR="0" lvl="0" indent="0" algn="l" defTabSz="914400" rtl="0" eaLnBrk="1" fontAlgn="auto" latinLnBrk="0" hangingPunct="1">
-              <a:lnSpc>
-                <a:spcPct val="100000"/>
-              </a:lnSpc>
-              <a:spcBef>
-                <a:spcPts val="0"/>
-              </a:spcBef>
-              <a:spcAft>
-                <a:spcPts val="0"/>
-              </a:spcAft>
-              <a:buClrTx/>
-              <a:buSzTx/>
-              <a:buFontTx/>
-              <a:buNone/>
-              <a:tabLst/>
-              <a:defRPr/>
-            </a:pPr>
-            <a:r>
-              <a:rPr kumimoji="0" lang="en-US" sz="1600" b="0" i="0" u="none" strike="noStrike" kern="1200" cap="none" spc="0" normalizeH="0" baseline="0" noProof="0" dirty="0">
-                <a:ln>
-                  <a:noFill/>
-                </a:ln>
-                <a:solidFill>
-                  <a:prstClr val="white"/>
-                </a:solidFill>
-                <a:effectLst/>
-                <a:uLnTx/>
-                <a:uFillTx/>
-                <a:latin typeface="Calibri" panose="020F0502020204030204"/>
-                <a:ea typeface="+mn-ea"/>
-                <a:cs typeface="+mn-cs"/>
-              </a:rPr>
-              <a:t>3. Each point potential is continuously emitting a spherical potential that starts at it's current location with radius 0 and expands such that radius is field speed multiplied by elapsed time since emission. We are using all Euclidean coordinates here in time and space, so everything is absolute. </a:t>
-            </a:r>
-          </a:p>
-          <a:p>
-            <a:pPr marL="0" marR="0" lvl="0" indent="0" algn="l" defTabSz="914400" rtl="0" eaLnBrk="1" fontAlgn="auto" latinLnBrk="0" hangingPunct="1">
-              <a:lnSpc>
-                <a:spcPct val="100000"/>
-              </a:lnSpc>
-              <a:spcBef>
-                <a:spcPts val="0"/>
-              </a:spcBef>
-              <a:spcAft>
-                <a:spcPts val="0"/>
-              </a:spcAft>
-              <a:buClrTx/>
-              <a:buSzTx/>
-              <a:buFontTx/>
-              <a:buNone/>
-              <a:tabLst/>
-              <a:defRPr/>
-            </a:pPr>
-            <a:r>
-              <a:rPr kumimoji="0" lang="en-US" sz="1600" b="0" i="0" u="none" strike="noStrike" kern="1200" cap="none" spc="0" normalizeH="0" baseline="0" noProof="0" dirty="0">
-                <a:ln>
-                  <a:noFill/>
-                </a:ln>
-                <a:solidFill>
-                  <a:prstClr val="white"/>
-                </a:solidFill>
-                <a:effectLst/>
-                <a:uLnTx/>
-                <a:uFillTx/>
-                <a:latin typeface="Calibri" panose="020F0502020204030204"/>
-                <a:ea typeface="+mn-ea"/>
-                <a:cs typeface="+mn-cs"/>
-              </a:rPr>
-              <a:t>4. So there is a pretty cool thing that once a spherical potential is emitted, the origin of that sphere never changes.  Only the radius increases. Meanwhile the point potential has moved on continuously emitting new potential spheres.  So the potential wake is kind of like a boat in a lake, except we are in 3D space not flatland. </a:t>
-            </a:r>
-          </a:p>
-          <a:p>
-            <a:pPr marL="0" marR="0" lvl="0" indent="0" algn="l" defTabSz="914400" rtl="0" eaLnBrk="1" fontAlgn="auto" latinLnBrk="0" hangingPunct="1">
-              <a:lnSpc>
-                <a:spcPct val="100000"/>
-              </a:lnSpc>
-              <a:spcBef>
-                <a:spcPts val="0"/>
-              </a:spcBef>
-              <a:spcAft>
-                <a:spcPts val="0"/>
-              </a:spcAft>
-              <a:buClrTx/>
-              <a:buSzTx/>
-              <a:buFontTx/>
-              <a:buNone/>
-              <a:tabLst/>
-              <a:defRPr/>
-            </a:pPr>
-            <a:r>
-              <a:rPr kumimoji="0" lang="en-US" sz="1600" b="0" i="0" u="none" strike="noStrike" kern="1200" cap="none" spc="0" normalizeH="0" baseline="0" noProof="0" dirty="0">
-                <a:ln>
-                  <a:noFill/>
-                </a:ln>
-                <a:solidFill>
-                  <a:prstClr val="white"/>
-                </a:solidFill>
-                <a:effectLst/>
-                <a:uLnTx/>
-                <a:uFillTx/>
-                <a:latin typeface="Calibri" panose="020F0502020204030204"/>
-                <a:ea typeface="+mn-ea"/>
-                <a:cs typeface="+mn-cs"/>
-              </a:rPr>
-              <a:t>5. Now it gets kind of cool to start thinking about the relationship between the point potentials. Let's examine the sphere A emits at T0. It takes some time to reach B. When the sphere intersects B, we still know the origin of the sphere and can do math. But also we have to consider the velocity of A when that potential sphere was emitted, because it affects the gradient of potential that B experiences. We also have to consider B's velocity. There is a general formula in here which needs to be developed. It might look like </a:t>
-            </a:r>
-            <a:r>
-              <a:rPr kumimoji="0" lang="en-US" sz="1600" b="0" i="0" u="none" strike="noStrike" kern="1200" cap="none" spc="0" normalizeH="0" baseline="0" noProof="0" dirty="0" err="1">
-                <a:ln>
-                  <a:noFill/>
-                </a:ln>
-                <a:solidFill>
-                  <a:prstClr val="white"/>
-                </a:solidFill>
-                <a:effectLst/>
-                <a:uLnTx/>
-                <a:uFillTx/>
-                <a:latin typeface="Calibri" panose="020F0502020204030204"/>
-                <a:ea typeface="+mn-ea"/>
-                <a:cs typeface="+mn-cs"/>
-              </a:rPr>
-              <a:t>Lienard</a:t>
-            </a:r>
-            <a:r>
-              <a:rPr kumimoji="0" lang="en-US" sz="1600" b="0" i="0" u="none" strike="noStrike" kern="1200" cap="none" spc="0" normalizeH="0" baseline="0" noProof="0" dirty="0">
-                <a:ln>
-                  <a:noFill/>
-                </a:ln>
-                <a:solidFill>
-                  <a:prstClr val="white"/>
-                </a:solidFill>
-                <a:effectLst/>
-                <a:uLnTx/>
-                <a:uFillTx/>
-                <a:latin typeface="Calibri" panose="020F0502020204030204"/>
-                <a:ea typeface="+mn-ea"/>
-                <a:cs typeface="+mn-cs"/>
-              </a:rPr>
-              <a:t>/</a:t>
-            </a:r>
-            <a:r>
-              <a:rPr kumimoji="0" lang="en-US" sz="1600" b="0" i="0" u="none" strike="noStrike" kern="1200" cap="none" spc="0" normalizeH="0" baseline="0" noProof="0" dirty="0" err="1">
-                <a:ln>
-                  <a:noFill/>
-                </a:ln>
-                <a:solidFill>
-                  <a:prstClr val="white"/>
-                </a:solidFill>
-                <a:effectLst/>
-                <a:uLnTx/>
-                <a:uFillTx/>
-                <a:latin typeface="Calibri" panose="020F0502020204030204"/>
-                <a:ea typeface="+mn-ea"/>
-                <a:cs typeface="+mn-cs"/>
-              </a:rPr>
-              <a:t>Wiechert</a:t>
-            </a:r>
-            <a:r>
-              <a:rPr kumimoji="0" lang="en-US" sz="1600" b="0" i="0" u="none" strike="noStrike" kern="1200" cap="none" spc="0" normalizeH="0" baseline="0" noProof="0" dirty="0">
-                <a:ln>
-                  <a:noFill/>
-                </a:ln>
-                <a:solidFill>
-                  <a:prstClr val="white"/>
-                </a:solidFill>
-                <a:effectLst/>
-                <a:uLnTx/>
-                <a:uFillTx/>
-                <a:latin typeface="Calibri" panose="020F0502020204030204"/>
-                <a:ea typeface="+mn-ea"/>
-                <a:cs typeface="+mn-cs"/>
-              </a:rPr>
-              <a:t>/</a:t>
-            </a:r>
-            <a:r>
-              <a:rPr kumimoji="0" lang="en-US" sz="1600" b="0" i="0" u="none" strike="noStrike" kern="1200" cap="none" spc="0" normalizeH="0" baseline="0" noProof="0" dirty="0" err="1">
-                <a:ln>
-                  <a:noFill/>
-                </a:ln>
-                <a:solidFill>
-                  <a:prstClr val="white"/>
-                </a:solidFill>
-                <a:effectLst/>
-                <a:uLnTx/>
-                <a:uFillTx/>
-                <a:latin typeface="Calibri" panose="020F0502020204030204"/>
-                <a:ea typeface="+mn-ea"/>
-                <a:cs typeface="+mn-cs"/>
-              </a:rPr>
-              <a:t>Jeffimenko</a:t>
-            </a:r>
-            <a:r>
-              <a:rPr kumimoji="0" lang="en-US" sz="1600" b="0" i="0" u="none" strike="noStrike" kern="1200" cap="none" spc="0" normalizeH="0" baseline="0" noProof="0" dirty="0">
-                <a:ln>
-                  <a:noFill/>
-                </a:ln>
-                <a:solidFill>
-                  <a:prstClr val="white"/>
-                </a:solidFill>
-                <a:effectLst/>
-                <a:uLnTx/>
-                <a:uFillTx/>
-                <a:latin typeface="Calibri" panose="020F0502020204030204"/>
-                <a:ea typeface="+mn-ea"/>
-                <a:cs typeface="+mn-cs"/>
-              </a:rPr>
-              <a:t> math. Not sure yet. </a:t>
-            </a:r>
-          </a:p>
-          <a:p>
-            <a:pPr marL="0" marR="0" lvl="0" indent="0" algn="l" defTabSz="914400" rtl="0" eaLnBrk="1" fontAlgn="auto" latinLnBrk="0" hangingPunct="1">
-              <a:lnSpc>
-                <a:spcPct val="100000"/>
-              </a:lnSpc>
-              <a:spcBef>
-                <a:spcPts val="0"/>
-              </a:spcBef>
-              <a:spcAft>
-                <a:spcPts val="0"/>
-              </a:spcAft>
-              <a:buClrTx/>
-              <a:buSzTx/>
-              <a:buFontTx/>
-              <a:buNone/>
-              <a:tabLst/>
-              <a:defRPr/>
-            </a:pPr>
-            <a:r>
-              <a:rPr kumimoji="0" lang="en-US" sz="1600" b="0" i="0" u="none" strike="noStrike" kern="1200" cap="none" spc="0" normalizeH="0" baseline="0" noProof="0" dirty="0">
-                <a:ln>
-                  <a:noFill/>
-                </a:ln>
-                <a:solidFill>
-                  <a:prstClr val="white"/>
-                </a:solidFill>
-                <a:effectLst/>
-                <a:uLnTx/>
-                <a:uFillTx/>
-                <a:latin typeface="Calibri" panose="020F0502020204030204"/>
-                <a:ea typeface="+mn-ea"/>
-                <a:cs typeface="+mn-cs"/>
-              </a:rPr>
-              <a:t>6. Let's use the term potential sphere stream to describe each point potential emitting a stream of expanding spherical potentials. The stream also encodes the velocity of the emitting point potential, by nature of the moving origin. </a:t>
-            </a:r>
-          </a:p>
-          <a:p>
-            <a:pPr marL="0" marR="0" lvl="0" indent="0" algn="l" defTabSz="914400" rtl="0" eaLnBrk="1" fontAlgn="auto" latinLnBrk="0" hangingPunct="1">
-              <a:lnSpc>
-                <a:spcPct val="100000"/>
-              </a:lnSpc>
-              <a:spcBef>
-                <a:spcPts val="0"/>
-              </a:spcBef>
-              <a:spcAft>
-                <a:spcPts val="0"/>
-              </a:spcAft>
-              <a:buClrTx/>
-              <a:buSzTx/>
-              <a:buFontTx/>
-              <a:buNone/>
-              <a:tabLst/>
-              <a:defRPr/>
-            </a:pPr>
-            <a:r>
-              <a:rPr kumimoji="0" lang="en-US" sz="1600" b="0" i="0" u="none" strike="noStrike" kern="1200" cap="none" spc="0" normalizeH="0" baseline="0" noProof="0" dirty="0">
-                <a:ln>
-                  <a:noFill/>
-                </a:ln>
-                <a:solidFill>
-                  <a:prstClr val="white"/>
-                </a:solidFill>
-                <a:effectLst/>
-                <a:uLnTx/>
-                <a:uFillTx/>
-                <a:latin typeface="Calibri" panose="020F0502020204030204"/>
-                <a:ea typeface="+mn-ea"/>
-                <a:cs typeface="+mn-cs"/>
-              </a:rPr>
-              <a:t>7. When the potential sphere emitted at T0 arrives, in the potential sphere stream from A, then action will occur and the path of B will be impacted. But B is also emitting a potential sphere stream that impacts A after the travel time delay. So there is a feedback cycle with a variable delay that is dependent on both A and B's path.</a:t>
-            </a:r>
-          </a:p>
-          <a:p>
-            <a:pPr marL="0" marR="0" lvl="0" indent="0" algn="l" defTabSz="914400" rtl="0" eaLnBrk="1" fontAlgn="auto" latinLnBrk="0" hangingPunct="1">
-              <a:lnSpc>
-                <a:spcPct val="100000"/>
-              </a:lnSpc>
-              <a:spcBef>
-                <a:spcPts val="0"/>
-              </a:spcBef>
-              <a:spcAft>
-                <a:spcPts val="0"/>
-              </a:spcAft>
-              <a:buClrTx/>
-              <a:buSzTx/>
-              <a:buFontTx/>
-              <a:buNone/>
-              <a:tabLst/>
-              <a:defRPr/>
-            </a:pPr>
-            <a:r>
-              <a:rPr kumimoji="0" lang="en-US" sz="1600" b="0" i="0" u="none" strike="noStrike" kern="1200" cap="none" spc="0" normalizeH="0" baseline="0" noProof="0" dirty="0">
-                <a:ln>
-                  <a:noFill/>
-                </a:ln>
-                <a:solidFill>
-                  <a:prstClr val="white"/>
-                </a:solidFill>
-                <a:effectLst/>
-                <a:uLnTx/>
-                <a:uFillTx/>
-                <a:latin typeface="Calibri" panose="020F0502020204030204"/>
-                <a:ea typeface="+mn-ea"/>
-                <a:cs typeface="+mn-cs"/>
-              </a:rPr>
-              <a:t>8. I was just thinking the other day how to enhance the picture to show the continuous potential sphere streams from A passing B and causing action, and vice versa. I'd like to somehow capture this dynamic feedback cycle. </a:t>
-            </a:r>
-          </a:p>
-          <a:p>
-            <a:pPr marL="0" marR="0" lvl="0" indent="0" algn="l" defTabSz="914400" rtl="0" eaLnBrk="1" fontAlgn="auto" latinLnBrk="0" hangingPunct="1">
-              <a:lnSpc>
-                <a:spcPct val="100000"/>
-              </a:lnSpc>
-              <a:spcBef>
-                <a:spcPts val="0"/>
-              </a:spcBef>
-              <a:spcAft>
-                <a:spcPts val="0"/>
-              </a:spcAft>
-              <a:buClrTx/>
-              <a:buSzTx/>
-              <a:buFontTx/>
-              <a:buNone/>
-              <a:tabLst/>
-              <a:defRPr/>
-            </a:pPr>
-            <a:r>
-              <a:rPr kumimoji="0" lang="en-US" sz="1600" b="0" i="0" u="none" strike="noStrike" kern="1200" cap="none" spc="0" normalizeH="0" baseline="0" noProof="0" dirty="0">
-                <a:ln>
-                  <a:noFill/>
-                </a:ln>
-                <a:solidFill>
-                  <a:prstClr val="white"/>
-                </a:solidFill>
-                <a:effectLst/>
-                <a:uLnTx/>
-                <a:uFillTx/>
-                <a:latin typeface="Calibri" panose="020F0502020204030204"/>
-                <a:ea typeface="+mn-ea"/>
-                <a:cs typeface="+mn-cs"/>
-              </a:rPr>
-              <a:t>9. I think there is probably some incredible math just in this interaction. I don't know if that math has already been done. Perhaps.  I doubt anyone has considered the case when point potential velocity equals or exceeds field speed. That is an unexplored regime.  </a:t>
-            </a:r>
-          </a:p>
-          <a:p>
-            <a:pPr marL="0" marR="0" lvl="0" indent="0" algn="l" defTabSz="914400" rtl="0" eaLnBrk="1" fontAlgn="auto" latinLnBrk="0" hangingPunct="1">
-              <a:lnSpc>
-                <a:spcPct val="100000"/>
-              </a:lnSpc>
-              <a:spcBef>
-                <a:spcPts val="0"/>
-              </a:spcBef>
-              <a:spcAft>
-                <a:spcPts val="0"/>
-              </a:spcAft>
-              <a:buClrTx/>
-              <a:buSzTx/>
-              <a:buFontTx/>
-              <a:buNone/>
-              <a:tabLst/>
-              <a:defRPr/>
-            </a:pPr>
-            <a:endParaRPr kumimoji="0" lang="en-US" sz="1600" b="0" i="0" u="none" strike="noStrike" kern="1200" cap="none" spc="0" normalizeH="0" baseline="0" noProof="0" dirty="0">
-              <a:ln>
-                <a:noFill/>
-              </a:ln>
-              <a:solidFill>
-                <a:prstClr val="white"/>
-              </a:solidFill>
-              <a:effectLst/>
-              <a:uLnTx/>
-              <a:uFillTx/>
-              <a:latin typeface="Calibri" panose="020F0502020204030204"/>
-              <a:ea typeface="+mn-ea"/>
-              <a:cs typeface="+mn-cs"/>
-            </a:endParaRPr>
-          </a:p>
-          <a:p>
-            <a:pPr marL="0" marR="0" lvl="0" indent="0" algn="l" defTabSz="914400" rtl="0" eaLnBrk="1" fontAlgn="auto" latinLnBrk="0" hangingPunct="1">
-              <a:lnSpc>
-                <a:spcPct val="100000"/>
-              </a:lnSpc>
-              <a:spcBef>
-                <a:spcPts val="0"/>
-              </a:spcBef>
-              <a:spcAft>
-                <a:spcPts val="0"/>
-              </a:spcAft>
-              <a:buClrTx/>
-              <a:buSzTx/>
-              <a:buFontTx/>
-              <a:buNone/>
-              <a:tabLst/>
-              <a:defRPr/>
-            </a:pPr>
-            <a:r>
-              <a:rPr kumimoji="0" lang="en-US" sz="1600" b="0" i="0" u="none" strike="noStrike" kern="1200" cap="none" spc="0" normalizeH="0" baseline="0" noProof="0" dirty="0">
-                <a:ln>
-                  <a:noFill/>
-                </a:ln>
-                <a:solidFill>
-                  <a:prstClr val="white"/>
-                </a:solidFill>
-                <a:effectLst/>
-                <a:uLnTx/>
-                <a:uFillTx/>
-                <a:latin typeface="Calibri" panose="020F0502020204030204"/>
-                <a:ea typeface="+mn-ea"/>
-                <a:cs typeface="+mn-cs"/>
-              </a:rPr>
-              <a:t>My recommendation is to use your imagination to visualize the dynamical geometry and the potential sphere streams and the paths.  For me that leads to a lot of insight.   </a:t>
-            </a:r>
-          </a:p>
-        </p:txBody>
-      </p:sp>
-    </p:spTree>
-    <p:extLst>
-      <p:ext uri="{BB962C8B-B14F-4D97-AF65-F5344CB8AC3E}">
-        <p14:creationId xmlns:p14="http://schemas.microsoft.com/office/powerpoint/2010/main" val="4219678445"/>
-      </p:ext>
-    </p:extLst>
-  </p:cSld>
-  <p:clrMapOvr>
-    <a:masterClrMapping/>
-  </p:clrMapOvr>
-</p:sld>
-</file>
-
-<file path=ppt/slides/slide11.xml><?xml version="1.0" encoding="utf-8"?>
 <p:sld xmlns:a="http://schemas.openxmlformats.org/drawingml/2006/main" xmlns:r="http://schemas.openxmlformats.org/officeDocument/2006/relationships" xmlns:p="http://schemas.openxmlformats.org/presentationml/2006/main">
   <p:cSld>
     <p:bg>
@@ -11870,7 +10071,7 @@
 </p:sld>
 </file>
 
-<file path=ppt/slides/slide12.xml><?xml version="1.0" encoding="utf-8"?>
+<file path=ppt/slides/slide11.xml><?xml version="1.0" encoding="utf-8"?>
 <p:sld xmlns:a="http://schemas.openxmlformats.org/drawingml/2006/main" xmlns:r="http://schemas.openxmlformats.org/officeDocument/2006/relationships" xmlns:p="http://schemas.openxmlformats.org/presentationml/2006/main">
   <p:cSld>
     <p:bg>
@@ -13612,7 +11813,7 @@
 </p:sld>
 </file>
 
-<file path=ppt/slides/slide13.xml><?xml version="1.0" encoding="utf-8"?>
+<file path=ppt/slides/slide12.xml><?xml version="1.0" encoding="utf-8"?>
 <p:sld xmlns:a="http://schemas.openxmlformats.org/drawingml/2006/main" xmlns:r="http://schemas.openxmlformats.org/officeDocument/2006/relationships" xmlns:p="http://schemas.openxmlformats.org/presentationml/2006/main">
   <p:cSld>
     <p:bg>
@@ -20106,7 +18307,7 @@
 </p:sld>
 </file>
 
-<file path=ppt/slides/slide14.xml><?xml version="1.0" encoding="utf-8"?>
+<file path=ppt/slides/slide13.xml><?xml version="1.0" encoding="utf-8"?>
 <p:sld xmlns:a="http://schemas.openxmlformats.org/drawingml/2006/main" xmlns:r="http://schemas.openxmlformats.org/officeDocument/2006/relationships" xmlns:p="http://schemas.openxmlformats.org/presentationml/2006/main">
   <p:cSld>
     <p:bg>
@@ -20731,7 +18932,7 @@
 </p:sld>
 </file>
 
-<file path=ppt/slides/slide15.xml><?xml version="1.0" encoding="utf-8"?>
+<file path=ppt/slides/slide14.xml><?xml version="1.0" encoding="utf-8"?>
 <p:sld xmlns:a="http://schemas.openxmlformats.org/drawingml/2006/main" xmlns:r="http://schemas.openxmlformats.org/officeDocument/2006/relationships" xmlns:p="http://schemas.openxmlformats.org/presentationml/2006/main">
   <p:cSld>
     <p:bg>
@@ -21986,7 +20187,7 @@
 </p:sld>
 </file>
 
-<file path=ppt/slides/slide16.xml><?xml version="1.0" encoding="utf-8"?>
+<file path=ppt/slides/slide15.xml><?xml version="1.0" encoding="utf-8"?>
 <p:sld xmlns:a="http://schemas.openxmlformats.org/drawingml/2006/main" xmlns:r="http://schemas.openxmlformats.org/officeDocument/2006/relationships" xmlns:p="http://schemas.openxmlformats.org/presentationml/2006/main">
   <p:cSld>
     <p:bg>
@@ -24753,427 +22954,6 @@
 </file>
 
 <file path=ppt/slides/slide3.xml><?xml version="1.0" encoding="utf-8"?>
-<p:sld xmlns:a="http://schemas.openxmlformats.org/drawingml/2006/main" xmlns:r="http://schemas.openxmlformats.org/officeDocument/2006/relationships" xmlns:p="http://schemas.openxmlformats.org/presentationml/2006/main">
-  <p:cSld>
-    <p:bg>
-      <p:bgPr>
-        <a:solidFill>
-          <a:schemeClr val="tx1"/>
-        </a:solidFill>
-        <a:effectLst/>
-      </p:bgPr>
-    </p:bg>
-    <p:spTree>
-      <p:nvGrpSpPr>
-        <p:cNvPr id="1" name=""/>
-        <p:cNvGrpSpPr/>
-        <p:nvPr/>
-      </p:nvGrpSpPr>
-      <p:grpSpPr>
-        <a:xfrm>
-          <a:off x="0" y="0"/>
-          <a:ext cx="0" cy="0"/>
-          <a:chOff x="0" y="0"/>
-          <a:chExt cx="0" cy="0"/>
-        </a:xfrm>
-      </p:grpSpPr>
-      <p:sp>
-        <p:nvSpPr>
-          <p:cNvPr id="9" name="Rectangle 8">
-            <a:extLst>
-              <a:ext uri="{FF2B5EF4-FFF2-40B4-BE49-F238E27FC236}">
-                <a16:creationId xmlns:a16="http://schemas.microsoft.com/office/drawing/2014/main" id="{2A8AA5BC-4F7A-4226-8F99-6D824B226A97}"/>
-              </a:ext>
-              <a:ext uri="{C183D7F6-B498-43B3-948B-1728B52AA6E4}">
-                <adec:decorative xmlns:adec="http://schemas.microsoft.com/office/drawing/2017/decorative" val="1"/>
-              </a:ext>
-            </a:extLst>
-          </p:cNvPr>
-          <p:cNvSpPr>
-            <a:spLocks noGrp="1" noRot="1" noChangeAspect="1" noMove="1" noResize="1" noEditPoints="1" noAdjustHandles="1" noChangeArrowheads="1" noChangeShapeType="1" noTextEdit="1"/>
-          </p:cNvSpPr>
-          <p:nvPr>
-            <p:extLst>
-              <p:ext uri="{386F3935-93C4-4BCD-93E2-E3B085C9AB24}">
-                <p16:designElem xmlns:p16="http://schemas.microsoft.com/office/powerpoint/2015/main" val="1"/>
-              </p:ext>
-            </p:extLst>
-          </p:nvPr>
-        </p:nvSpPr>
-        <p:spPr>
-          <a:xfrm>
-            <a:off x="0" y="-3324"/>
-            <a:ext cx="12192000" cy="6861324"/>
-          </a:xfrm>
-          <a:prstGeom prst="rect">
-            <a:avLst/>
-          </a:prstGeom>
-          <a:solidFill>
-            <a:schemeClr val="tx1"/>
-          </a:solidFill>
-          <a:ln>
-            <a:noFill/>
-          </a:ln>
-        </p:spPr>
-        <p:style>
-          <a:lnRef idx="2">
-            <a:schemeClr val="accent1">
-              <a:shade val="50000"/>
-            </a:schemeClr>
-          </a:lnRef>
-          <a:fillRef idx="1">
-            <a:schemeClr val="accent1"/>
-          </a:fillRef>
-          <a:effectRef idx="0">
-            <a:schemeClr val="accent1"/>
-          </a:effectRef>
-          <a:fontRef idx="minor">
-            <a:schemeClr val="lt1"/>
-          </a:fontRef>
-        </p:style>
-        <p:txBody>
-          <a:bodyPr rtlCol="0" anchor="ctr"/>
-          <a:lstStyle/>
-          <a:p>
-            <a:pPr marL="0" marR="0" lvl="0" indent="0" algn="ctr" defTabSz="914400" rtl="0" eaLnBrk="1" fontAlgn="auto" latinLnBrk="0" hangingPunct="1">
-              <a:lnSpc>
-                <a:spcPct val="100000"/>
-              </a:lnSpc>
-              <a:spcBef>
-                <a:spcPts val="0"/>
-              </a:spcBef>
-              <a:spcAft>
-                <a:spcPts val="0"/>
-              </a:spcAft>
-              <a:buClrTx/>
-              <a:buSzTx/>
-              <a:buFontTx/>
-              <a:buNone/>
-              <a:tabLst/>
-              <a:defRPr/>
-            </a:pPr>
-            <a:endParaRPr kumimoji="0" lang="en-US" sz="1800" b="0" i="0" u="none" strike="noStrike" kern="1200" cap="none" spc="0" normalizeH="0" baseline="0" noProof="0">
-              <a:ln>
-                <a:noFill/>
-              </a:ln>
-              <a:solidFill>
-                <a:prstClr val="white"/>
-              </a:solidFill>
-              <a:effectLst/>
-              <a:uLnTx/>
-              <a:uFillTx/>
-              <a:latin typeface="Calibri" panose="020F0502020204030204"/>
-              <a:ea typeface="+mn-ea"/>
-              <a:cs typeface="+mn-cs"/>
-            </a:endParaRPr>
-          </a:p>
-        </p:txBody>
-      </p:sp>
-      <p:sp>
-        <p:nvSpPr>
-          <p:cNvPr id="11" name="Rectangle 10">
-            <a:extLst>
-              <a:ext uri="{FF2B5EF4-FFF2-40B4-BE49-F238E27FC236}">
-                <a16:creationId xmlns:a16="http://schemas.microsoft.com/office/drawing/2014/main" id="{3E5445C6-DD42-4979-86FF-03730E8C6DB0}"/>
-              </a:ext>
-              <a:ext uri="{C183D7F6-B498-43B3-948B-1728B52AA6E4}">
-                <adec:decorative xmlns:adec="http://schemas.microsoft.com/office/drawing/2017/decorative" val="1"/>
-              </a:ext>
-            </a:extLst>
-          </p:cNvPr>
-          <p:cNvSpPr>
-            <a:spLocks noGrp="1" noRot="1" noChangeAspect="1" noMove="1" noResize="1" noEditPoints="1" noAdjustHandles="1" noChangeArrowheads="1" noChangeShapeType="1" noTextEdit="1"/>
-          </p:cNvSpPr>
-          <p:nvPr>
-            <p:extLst>
-              <p:ext uri="{386F3935-93C4-4BCD-93E2-E3B085C9AB24}">
-                <p16:designElem xmlns:p16="http://schemas.microsoft.com/office/powerpoint/2015/main" val="1"/>
-              </p:ext>
-            </p:extLst>
-          </p:nvPr>
-        </p:nvSpPr>
-        <p:spPr bwMode="ltGray">
-          <a:xfrm>
-            <a:off x="321734" y="321733"/>
-            <a:ext cx="11573488" cy="6214534"/>
-          </a:xfrm>
-          <a:prstGeom prst="rect">
-            <a:avLst/>
-          </a:prstGeom>
-          <a:solidFill>
-            <a:schemeClr val="bg1">
-              <a:lumMod val="75000"/>
-              <a:lumOff val="25000"/>
-            </a:schemeClr>
-          </a:solidFill>
-          <a:ln w="127000" cap="sq" cmpd="thinThick">
-            <a:solidFill>
-              <a:schemeClr val="bg1">
-                <a:lumMod val="75000"/>
-                <a:lumOff val="25000"/>
-              </a:schemeClr>
-            </a:solidFill>
-          </a:ln>
-        </p:spPr>
-        <p:style>
-          <a:lnRef idx="2">
-            <a:schemeClr val="accent1">
-              <a:shade val="50000"/>
-            </a:schemeClr>
-          </a:lnRef>
-          <a:fillRef idx="1">
-            <a:schemeClr val="accent1"/>
-          </a:fillRef>
-          <a:effectRef idx="0">
-            <a:schemeClr val="accent1"/>
-          </a:effectRef>
-          <a:fontRef idx="minor">
-            <a:schemeClr val="lt1"/>
-          </a:fontRef>
-        </p:style>
-        <p:txBody>
-          <a:bodyPr rtlCol="0" anchor="ctr"/>
-          <a:lstStyle/>
-          <a:p>
-            <a:pPr marL="0" marR="0" lvl="0" indent="0" algn="ctr" defTabSz="914400" rtl="0" eaLnBrk="1" fontAlgn="auto" latinLnBrk="0" hangingPunct="1">
-              <a:lnSpc>
-                <a:spcPct val="100000"/>
-              </a:lnSpc>
-              <a:spcBef>
-                <a:spcPts val="0"/>
-              </a:spcBef>
-              <a:spcAft>
-                <a:spcPts val="0"/>
-              </a:spcAft>
-              <a:buClrTx/>
-              <a:buSzTx/>
-              <a:buFontTx/>
-              <a:buNone/>
-              <a:tabLst/>
-              <a:defRPr/>
-            </a:pPr>
-            <a:endParaRPr kumimoji="0" lang="en-US" sz="1800" b="0" i="0" u="none" strike="noStrike" kern="1200" cap="none" spc="0" normalizeH="0" baseline="0" noProof="0">
-              <a:ln>
-                <a:noFill/>
-              </a:ln>
-              <a:solidFill>
-                <a:prstClr val="white"/>
-              </a:solidFill>
-              <a:effectLst/>
-              <a:uLnTx/>
-              <a:uFillTx/>
-              <a:latin typeface="Calibri" panose="020F0502020204030204"/>
-              <a:ea typeface="+mn-ea"/>
-              <a:cs typeface="+mn-cs"/>
-            </a:endParaRPr>
-          </a:p>
-        </p:txBody>
-      </p:sp>
-      <p:sp>
-        <p:nvSpPr>
-          <p:cNvPr id="2" name="Title 1">
-            <a:extLst>
-              <a:ext uri="{FF2B5EF4-FFF2-40B4-BE49-F238E27FC236}">
-                <a16:creationId xmlns:a16="http://schemas.microsoft.com/office/drawing/2014/main" id="{7710B119-EC53-BA46-BAA3-CB758CDEDAF5}"/>
-              </a:ext>
-            </a:extLst>
-          </p:cNvPr>
-          <p:cNvSpPr>
-            <a:spLocks noGrp="1"/>
-          </p:cNvSpPr>
-          <p:nvPr>
-            <p:ph type="ctrTitle"/>
-          </p:nvPr>
-        </p:nvSpPr>
-        <p:spPr>
-          <a:xfrm>
-            <a:off x="1524000" y="1122362"/>
-            <a:ext cx="9144000" cy="2840037"/>
-          </a:xfrm>
-        </p:spPr>
-        <p:txBody>
-          <a:bodyPr>
-            <a:normAutofit/>
-          </a:bodyPr>
-          <a:lstStyle/>
-          <a:p>
-            <a:r>
-              <a:rPr lang="en-US" sz="5800" dirty="0"/>
-              <a:t>Thank You</a:t>
-            </a:r>
-          </a:p>
-        </p:txBody>
-      </p:sp>
-      <p:sp>
-        <p:nvSpPr>
-          <p:cNvPr id="3" name="Subtitle 2">
-            <a:extLst>
-              <a:ext uri="{FF2B5EF4-FFF2-40B4-BE49-F238E27FC236}">
-                <a16:creationId xmlns:a16="http://schemas.microsoft.com/office/drawing/2014/main" id="{44E6BC0E-0DB7-C346-A0CC-E3CB36C29A54}"/>
-              </a:ext>
-            </a:extLst>
-          </p:cNvPr>
-          <p:cNvSpPr>
-            <a:spLocks noGrp="1"/>
-          </p:cNvSpPr>
-          <p:nvPr>
-            <p:ph type="subTitle" idx="1"/>
-          </p:nvPr>
-        </p:nvSpPr>
-        <p:spPr>
-          <a:xfrm>
-            <a:off x="1524000" y="4256436"/>
-            <a:ext cx="9144000" cy="1600818"/>
-          </a:xfrm>
-        </p:spPr>
-        <p:txBody>
-          <a:bodyPr>
-            <a:normAutofit/>
-          </a:bodyPr>
-          <a:lstStyle/>
-          <a:p>
-            <a:r>
-              <a:rPr lang="en-US" dirty="0"/>
-              <a:t>Questions?</a:t>
-            </a:r>
-          </a:p>
-        </p:txBody>
-      </p:sp>
-      <p:cxnSp>
-        <p:nvCxnSpPr>
-          <p:cNvPr id="13" name="Straight Connector 12">
-            <a:extLst>
-              <a:ext uri="{FF2B5EF4-FFF2-40B4-BE49-F238E27FC236}">
-                <a16:creationId xmlns:a16="http://schemas.microsoft.com/office/drawing/2014/main" id="{45000665-DFC7-417E-8FD7-516A0F15C975}"/>
-              </a:ext>
-              <a:ext uri="{C183D7F6-B498-43B3-948B-1728B52AA6E4}">
-                <adec:decorative xmlns:adec="http://schemas.microsoft.com/office/drawing/2017/decorative" val="1"/>
-              </a:ext>
-            </a:extLst>
-          </p:cNvPr>
-          <p:cNvCxnSpPr>
-            <a:cxnSpLocks noGrp="1" noRot="1" noChangeAspect="1" noMove="1" noResize="1" noEditPoints="1" noAdjustHandles="1" noChangeArrowheads="1" noChangeShapeType="1"/>
-          </p:cNvCxnSpPr>
-          <p:nvPr>
-            <p:extLst>
-              <p:ext uri="{386F3935-93C4-4BCD-93E2-E3B085C9AB24}">
-                <p16:designElem xmlns:p16="http://schemas.microsoft.com/office/powerpoint/2015/main" val="1"/>
-              </p:ext>
-            </p:extLst>
-          </p:nvPr>
-        </p:nvCxnSpPr>
-        <p:spPr>
-          <a:xfrm>
-            <a:off x="4724400" y="4109417"/>
-            <a:ext cx="2743200" cy="0"/>
-          </a:xfrm>
-          <a:prstGeom prst="line">
-            <a:avLst/>
-          </a:prstGeom>
-          <a:ln w="12700">
-            <a:solidFill>
-              <a:schemeClr val="tx1">
-                <a:lumMod val="85000"/>
-              </a:schemeClr>
-            </a:solidFill>
-          </a:ln>
-        </p:spPr>
-        <p:style>
-          <a:lnRef idx="1">
-            <a:schemeClr val="accent1"/>
-          </a:lnRef>
-          <a:fillRef idx="0">
-            <a:schemeClr val="accent1"/>
-          </a:fillRef>
-          <a:effectRef idx="0">
-            <a:schemeClr val="accent1"/>
-          </a:effectRef>
-          <a:fontRef idx="minor">
-            <a:schemeClr val="tx1"/>
-          </a:fontRef>
-        </p:style>
-      </p:cxnSp>
-      <p:sp>
-        <p:nvSpPr>
-          <p:cNvPr id="4" name="Footer Placeholder 3">
-            <a:extLst>
-              <a:ext uri="{FF2B5EF4-FFF2-40B4-BE49-F238E27FC236}">
-                <a16:creationId xmlns:a16="http://schemas.microsoft.com/office/drawing/2014/main" id="{9E726E67-7B90-B642-8D26-6DDF890C4785}"/>
-              </a:ext>
-            </a:extLst>
-          </p:cNvPr>
-          <p:cNvSpPr>
-            <a:spLocks noGrp="1"/>
-          </p:cNvSpPr>
-          <p:nvPr>
-            <p:ph type="ftr" sz="quarter" idx="11"/>
-          </p:nvPr>
-        </p:nvSpPr>
-        <p:spPr>
-          <a:xfrm>
-            <a:off x="4038600" y="6159710"/>
-            <a:ext cx="4114800" cy="365125"/>
-          </a:xfrm>
-        </p:spPr>
-        <p:txBody>
-          <a:bodyPr>
-            <a:normAutofit/>
-          </a:bodyPr>
-          <a:lstStyle/>
-          <a:p>
-            <a:pPr marL="0" marR="0" lvl="0" indent="0" algn="ctr" defTabSz="914400" rtl="0" eaLnBrk="1" fontAlgn="auto" latinLnBrk="0" hangingPunct="1">
-              <a:lnSpc>
-                <a:spcPct val="100000"/>
-              </a:lnSpc>
-              <a:spcBef>
-                <a:spcPts val="0"/>
-              </a:spcBef>
-              <a:spcAft>
-                <a:spcPts val="600"/>
-              </a:spcAft>
-              <a:buClrTx/>
-              <a:buSzTx/>
-              <a:buFontTx/>
-              <a:buNone/>
-              <a:tabLst/>
-              <a:defRPr/>
-            </a:pPr>
-            <a:r>
-              <a:rPr kumimoji="0" lang="en-US" sz="1200" b="0" i="0" u="none" strike="noStrike" kern="1200" cap="none" spc="0" normalizeH="0" baseline="0" noProof="0" dirty="0">
-                <a:ln>
-                  <a:noFill/>
-                </a:ln>
-                <a:solidFill>
-                  <a:prstClr val="white">
-                    <a:tint val="75000"/>
-                  </a:prstClr>
-                </a:solidFill>
-                <a:effectLst/>
-                <a:uLnTx/>
-                <a:uFillTx/>
-                <a:latin typeface="Helvetica Neue" panose="02000503000000020004" pitchFamily="2" charset="0"/>
-                <a:ea typeface="Helvetica Neue" panose="02000503000000020004" pitchFamily="2" charset="0"/>
-                <a:cs typeface="Helvetica Neue" panose="02000503000000020004" pitchFamily="2" charset="0"/>
-              </a:rPr>
-              <a:t>J Mark Morris - Model of Nature</a:t>
-            </a:r>
-          </a:p>
-        </p:txBody>
-      </p:sp>
-    </p:spTree>
-    <p:extLst>
-      <p:ext uri="{BB962C8B-B14F-4D97-AF65-F5344CB8AC3E}">
-        <p14:creationId xmlns:p14="http://schemas.microsoft.com/office/powerpoint/2010/main" val="3747833275"/>
-      </p:ext>
-    </p:extLst>
-  </p:cSld>
-  <p:clrMapOvr>
-    <a:overrideClrMapping bg1="dk1" tx1="lt1" bg2="dk2" tx2="lt2" accent1="accent1" accent2="accent2" accent3="accent3" accent4="accent4" accent5="accent5" accent6="accent6" hlink="hlink" folHlink="folHlink"/>
-  </p:clrMapOvr>
-</p:sld>
-</file>
-
-<file path=ppt/slides/slide4.xml><?xml version="1.0" encoding="utf-8"?>
 <p:sld xmlns:a="http://schemas.openxmlformats.org/drawingml/2006/main" xmlns:r="http://schemas.openxmlformats.org/officeDocument/2006/relationships" xmlns:p="http://schemas.openxmlformats.org/presentationml/2006/main">
   <p:cSld>
     <p:bg>
@@ -28201,7 +25981,7 @@
 </p:sld>
 </file>
 
-<file path=ppt/slides/slide5.xml><?xml version="1.0" encoding="utf-8"?>
+<file path=ppt/slides/slide4.xml><?xml version="1.0" encoding="utf-8"?>
 <p:sld xmlns:a="http://schemas.openxmlformats.org/drawingml/2006/main" xmlns:r="http://schemas.openxmlformats.org/officeDocument/2006/relationships" xmlns:p="http://schemas.openxmlformats.org/presentationml/2006/main">
   <p:cSld>
     <p:bg>
@@ -30801,7 +28581,7 @@
 </p:sld>
 </file>
 
-<file path=ppt/slides/slide6.xml><?xml version="1.0" encoding="utf-8"?>
+<file path=ppt/slides/slide5.xml><?xml version="1.0" encoding="utf-8"?>
 <p:sld xmlns:a="http://schemas.openxmlformats.org/drawingml/2006/main" xmlns:r="http://schemas.openxmlformats.org/officeDocument/2006/relationships" xmlns:p="http://schemas.openxmlformats.org/presentationml/2006/main">
   <p:cSld>
     <p:bg>
@@ -31661,7 +29441,7 @@
 </p:sld>
 </file>
 
-<file path=ppt/slides/slide7.xml><?xml version="1.0" encoding="utf-8"?>
+<file path=ppt/slides/slide6.xml><?xml version="1.0" encoding="utf-8"?>
 <p:sld xmlns:a="http://schemas.openxmlformats.org/drawingml/2006/main" xmlns:r="http://schemas.openxmlformats.org/officeDocument/2006/relationships" xmlns:p="http://schemas.openxmlformats.org/presentationml/2006/main">
   <p:cSld>
     <p:bg>
@@ -33529,7 +31309,7 @@
 </p:sld>
 </file>
 
-<file path=ppt/slides/slide8.xml><?xml version="1.0" encoding="utf-8"?>
+<file path=ppt/slides/slide7.xml><?xml version="1.0" encoding="utf-8"?>
 <p:sld xmlns:a="http://schemas.openxmlformats.org/drawingml/2006/main" xmlns:r="http://schemas.openxmlformats.org/officeDocument/2006/relationships" xmlns:p="http://schemas.openxmlformats.org/presentationml/2006/main">
   <p:cSld>
     <p:bg>
@@ -35313,7 +33093,7 @@
 </p:sld>
 </file>
 
-<file path=ppt/slides/slide9.xml><?xml version="1.0" encoding="utf-8"?>
+<file path=ppt/slides/slide8.xml><?xml version="1.0" encoding="utf-8"?>
 <p:sld xmlns:a="http://schemas.openxmlformats.org/drawingml/2006/main" xmlns:r="http://schemas.openxmlformats.org/officeDocument/2006/relationships" xmlns:p="http://schemas.openxmlformats.org/presentationml/2006/main">
   <p:cSld>
     <p:bg>
@@ -37278,6 +35058,638 @@
 </p:sld>
 </file>
 
+<file path=ppt/slides/slide9.xml><?xml version="1.0" encoding="utf-8"?>
+<p:sld xmlns:a="http://schemas.openxmlformats.org/drawingml/2006/main" xmlns:r="http://schemas.openxmlformats.org/officeDocument/2006/relationships" xmlns:p="http://schemas.openxmlformats.org/presentationml/2006/main">
+  <p:cSld>
+    <p:bg>
+      <p:bgPr>
+        <a:solidFill>
+          <a:srgbClr val="7030A0"/>
+        </a:solidFill>
+        <a:effectLst/>
+      </p:bgPr>
+    </p:bg>
+    <p:spTree>
+      <p:nvGrpSpPr>
+        <p:cNvPr id="1" name=""/>
+        <p:cNvGrpSpPr/>
+        <p:nvPr/>
+      </p:nvGrpSpPr>
+      <p:grpSpPr>
+        <a:xfrm>
+          <a:off x="0" y="0"/>
+          <a:ext cx="0" cy="0"/>
+          <a:chOff x="0" y="0"/>
+          <a:chExt cx="0" cy="0"/>
+        </a:xfrm>
+      </p:grpSpPr>
+      <p:sp>
+        <p:nvSpPr>
+          <p:cNvPr id="2" name="TextBox 1">
+            <a:extLst>
+              <a:ext uri="{FF2B5EF4-FFF2-40B4-BE49-F238E27FC236}">
+                <a16:creationId xmlns:a16="http://schemas.microsoft.com/office/drawing/2014/main" id="{018A63B5-40EC-8B9D-0CE4-CED6A7D3C146}"/>
+              </a:ext>
+            </a:extLst>
+          </p:cNvPr>
+          <p:cNvSpPr txBox="1"/>
+          <p:nvPr/>
+        </p:nvSpPr>
+        <p:spPr>
+          <a:xfrm>
+            <a:off x="-70338" y="0"/>
+            <a:ext cx="12262338" cy="6740307"/>
+          </a:xfrm>
+          <a:prstGeom prst="rect">
+            <a:avLst/>
+          </a:prstGeom>
+          <a:noFill/>
+        </p:spPr>
+        <p:txBody>
+          <a:bodyPr wrap="square" rtlCol="0">
+            <a:spAutoFit/>
+          </a:bodyPr>
+          <a:lstStyle/>
+          <a:p>
+            <a:pPr marL="0" marR="0" lvl="0" indent="0" algn="l" defTabSz="914400" rtl="0" eaLnBrk="1" fontAlgn="auto" latinLnBrk="0" hangingPunct="1">
+              <a:lnSpc>
+                <a:spcPct val="100000"/>
+              </a:lnSpc>
+              <a:spcBef>
+                <a:spcPts val="0"/>
+              </a:spcBef>
+              <a:spcAft>
+                <a:spcPts val="0"/>
+              </a:spcAft>
+              <a:buClrTx/>
+              <a:buSzTx/>
+              <a:buFontTx/>
+              <a:buNone/>
+              <a:tabLst/>
+              <a:defRPr/>
+            </a:pPr>
+            <a:r>
+              <a:rPr kumimoji="0" lang="en-US" sz="1600" b="0" i="0" u="none" strike="noStrike" kern="1200" cap="none" spc="0" normalizeH="0" baseline="0" noProof="0" dirty="0">
+                <a:ln>
+                  <a:noFill/>
+                </a:ln>
+                <a:solidFill>
+                  <a:prstClr val="white"/>
+                </a:solidFill>
+                <a:effectLst/>
+                <a:uLnTx/>
+                <a:uFillTx/>
+                <a:latin typeface="Calibri" panose="020F0502020204030204"/>
+                <a:ea typeface="+mn-ea"/>
+                <a:cs typeface="+mn-cs"/>
+              </a:rPr>
+              <a:t>It's like the classic history potential figure. However, if we really contemplated what is happening in this dynamical geometry between any two point potentials is this:</a:t>
+            </a:r>
+          </a:p>
+          <a:p>
+            <a:pPr marL="0" marR="0" lvl="0" indent="0" algn="l" defTabSz="914400" rtl="0" eaLnBrk="1" fontAlgn="auto" latinLnBrk="0" hangingPunct="1">
+              <a:lnSpc>
+                <a:spcPct val="100000"/>
+              </a:lnSpc>
+              <a:spcBef>
+                <a:spcPts val="0"/>
+              </a:spcBef>
+              <a:spcAft>
+                <a:spcPts val="0"/>
+              </a:spcAft>
+              <a:buClrTx/>
+              <a:buSzTx/>
+              <a:buFontTx/>
+              <a:buNone/>
+              <a:tabLst/>
+              <a:defRPr/>
+            </a:pPr>
+            <a:r>
+              <a:rPr kumimoji="0" lang="en-US" sz="1600" b="0" i="0" u="none" strike="noStrike" kern="1200" cap="none" spc="0" normalizeH="0" baseline="0" noProof="0" dirty="0">
+                <a:ln>
+                  <a:noFill/>
+                </a:ln>
+                <a:solidFill>
+                  <a:prstClr val="white"/>
+                </a:solidFill>
+                <a:effectLst/>
+                <a:uLnTx/>
+                <a:uFillTx/>
+                <a:latin typeface="Calibri" panose="020F0502020204030204"/>
+                <a:ea typeface="+mn-ea"/>
+                <a:cs typeface="+mn-cs"/>
+              </a:rPr>
+              <a:t>1. Point potentials follow continuous paths through R4 (t, </a:t>
+            </a:r>
+            <a:r>
+              <a:rPr kumimoji="0" lang="en-US" sz="1600" b="0" i="0" u="none" strike="noStrike" kern="1200" cap="none" spc="0" normalizeH="0" baseline="0" noProof="0" dirty="0" err="1">
+                <a:ln>
+                  <a:noFill/>
+                </a:ln>
+                <a:solidFill>
+                  <a:prstClr val="white"/>
+                </a:solidFill>
+                <a:effectLst/>
+                <a:uLnTx/>
+                <a:uFillTx/>
+                <a:latin typeface="Calibri" panose="020F0502020204030204"/>
+                <a:ea typeface="+mn-ea"/>
+                <a:cs typeface="+mn-cs"/>
+              </a:rPr>
+              <a:t>x,y,z</a:t>
+            </a:r>
+            <a:r>
+              <a:rPr kumimoji="0" lang="en-US" sz="1600" b="0" i="0" u="none" strike="noStrike" kern="1200" cap="none" spc="0" normalizeH="0" baseline="0" noProof="0" dirty="0">
+                <a:ln>
+                  <a:noFill/>
+                </a:ln>
+                <a:solidFill>
+                  <a:prstClr val="white"/>
+                </a:solidFill>
+                <a:effectLst/>
+                <a:uLnTx/>
+                <a:uFillTx/>
+                <a:latin typeface="Calibri" panose="020F0502020204030204"/>
+                <a:ea typeface="+mn-ea"/>
+                <a:cs typeface="+mn-cs"/>
+              </a:rPr>
+              <a:t>, x', y', z'). That is to say at any absolute time each point potential has a position in space and a velocity.</a:t>
+            </a:r>
+          </a:p>
+          <a:p>
+            <a:pPr marL="0" marR="0" lvl="0" indent="0" algn="l" defTabSz="914400" rtl="0" eaLnBrk="1" fontAlgn="auto" latinLnBrk="0" hangingPunct="1">
+              <a:lnSpc>
+                <a:spcPct val="100000"/>
+              </a:lnSpc>
+              <a:spcBef>
+                <a:spcPts val="0"/>
+              </a:spcBef>
+              <a:spcAft>
+                <a:spcPts val="0"/>
+              </a:spcAft>
+              <a:buClrTx/>
+              <a:buSzTx/>
+              <a:buFontTx/>
+              <a:buNone/>
+              <a:tabLst/>
+              <a:defRPr/>
+            </a:pPr>
+            <a:r>
+              <a:rPr kumimoji="0" lang="en-US" sz="1600" b="0" i="0" u="none" strike="noStrike" kern="1200" cap="none" spc="0" normalizeH="0" baseline="0" noProof="0" dirty="0">
+                <a:ln>
+                  <a:noFill/>
+                </a:ln>
+                <a:solidFill>
+                  <a:prstClr val="white"/>
+                </a:solidFill>
+                <a:effectLst/>
+                <a:uLnTx/>
+                <a:uFillTx/>
+                <a:latin typeface="Calibri" panose="020F0502020204030204"/>
+                <a:ea typeface="+mn-ea"/>
+                <a:cs typeface="+mn-cs"/>
+              </a:rPr>
+              <a:t>2. Now consider two point potentials each following their path under the influence of the arriving potential field. Let's limit ourselves to point potential velocities less than field speed, because it is a simpler case. </a:t>
+            </a:r>
+          </a:p>
+          <a:p>
+            <a:pPr marL="0" marR="0" lvl="0" indent="0" algn="l" defTabSz="914400" rtl="0" eaLnBrk="1" fontAlgn="auto" latinLnBrk="0" hangingPunct="1">
+              <a:lnSpc>
+                <a:spcPct val="100000"/>
+              </a:lnSpc>
+              <a:spcBef>
+                <a:spcPts val="0"/>
+              </a:spcBef>
+              <a:spcAft>
+                <a:spcPts val="0"/>
+              </a:spcAft>
+              <a:buClrTx/>
+              <a:buSzTx/>
+              <a:buFontTx/>
+              <a:buNone/>
+              <a:tabLst/>
+              <a:defRPr/>
+            </a:pPr>
+            <a:r>
+              <a:rPr kumimoji="0" lang="en-US" sz="1600" b="0" i="0" u="none" strike="noStrike" kern="1200" cap="none" spc="0" normalizeH="0" baseline="0" noProof="0" dirty="0">
+                <a:ln>
+                  <a:noFill/>
+                </a:ln>
+                <a:solidFill>
+                  <a:prstClr val="white"/>
+                </a:solidFill>
+                <a:effectLst/>
+                <a:uLnTx/>
+                <a:uFillTx/>
+                <a:latin typeface="Calibri" panose="020F0502020204030204"/>
+                <a:ea typeface="+mn-ea"/>
+                <a:cs typeface="+mn-cs"/>
+              </a:rPr>
+              <a:t>3. Each point potential is continuously emitting a spherical potential that starts at it's current location with radius 0 and expands such that radius is field speed multiplied by elapsed time since emission. We are using all Euclidean coordinates here in time and space, so everything is absolute. </a:t>
+            </a:r>
+          </a:p>
+          <a:p>
+            <a:pPr marL="0" marR="0" lvl="0" indent="0" algn="l" defTabSz="914400" rtl="0" eaLnBrk="1" fontAlgn="auto" latinLnBrk="0" hangingPunct="1">
+              <a:lnSpc>
+                <a:spcPct val="100000"/>
+              </a:lnSpc>
+              <a:spcBef>
+                <a:spcPts val="0"/>
+              </a:spcBef>
+              <a:spcAft>
+                <a:spcPts val="0"/>
+              </a:spcAft>
+              <a:buClrTx/>
+              <a:buSzTx/>
+              <a:buFontTx/>
+              <a:buNone/>
+              <a:tabLst/>
+              <a:defRPr/>
+            </a:pPr>
+            <a:r>
+              <a:rPr kumimoji="0" lang="en-US" sz="1600" b="0" i="0" u="none" strike="noStrike" kern="1200" cap="none" spc="0" normalizeH="0" baseline="0" noProof="0" dirty="0">
+                <a:ln>
+                  <a:noFill/>
+                </a:ln>
+                <a:solidFill>
+                  <a:prstClr val="white"/>
+                </a:solidFill>
+                <a:effectLst/>
+                <a:uLnTx/>
+                <a:uFillTx/>
+                <a:latin typeface="Calibri" panose="020F0502020204030204"/>
+                <a:ea typeface="+mn-ea"/>
+                <a:cs typeface="+mn-cs"/>
+              </a:rPr>
+              <a:t>4. So there is a pretty cool thing that once a spherical potential is emitted, the origin of that sphere never changes.  Only the radius increases. Meanwhile the point potential has moved on continuously emitting new potential spheres.  So the potential wake is kind of like a boat in a lake, except we are in 3D space not flatland. </a:t>
+            </a:r>
+          </a:p>
+          <a:p>
+            <a:pPr marL="0" marR="0" lvl="0" indent="0" algn="l" defTabSz="914400" rtl="0" eaLnBrk="1" fontAlgn="auto" latinLnBrk="0" hangingPunct="1">
+              <a:lnSpc>
+                <a:spcPct val="100000"/>
+              </a:lnSpc>
+              <a:spcBef>
+                <a:spcPts val="0"/>
+              </a:spcBef>
+              <a:spcAft>
+                <a:spcPts val="0"/>
+              </a:spcAft>
+              <a:buClrTx/>
+              <a:buSzTx/>
+              <a:buFontTx/>
+              <a:buNone/>
+              <a:tabLst/>
+              <a:defRPr/>
+            </a:pPr>
+            <a:r>
+              <a:rPr kumimoji="0" lang="en-US" sz="1600" b="0" i="0" u="none" strike="noStrike" kern="1200" cap="none" spc="0" normalizeH="0" baseline="0" noProof="0" dirty="0">
+                <a:ln>
+                  <a:noFill/>
+                </a:ln>
+                <a:solidFill>
+                  <a:prstClr val="white"/>
+                </a:solidFill>
+                <a:effectLst/>
+                <a:uLnTx/>
+                <a:uFillTx/>
+                <a:latin typeface="Calibri" panose="020F0502020204030204"/>
+                <a:ea typeface="+mn-ea"/>
+                <a:cs typeface="+mn-cs"/>
+              </a:rPr>
+              <a:t>5. Now it gets kind of cool to start thinking about the relationship between the point potentials. Let's examine the sphere A emits at T0. It takes some time to reach B. When the sphere intersects B, we still know the origin of the sphere and can do math. But also we have to consider the velocity of A when that potential sphere was emitted, because it affects the gradient of potential that B experiences. We also have to consider B's velocity. There is a general formula in here which needs to be developed. It might look like </a:t>
+            </a:r>
+            <a:r>
+              <a:rPr kumimoji="0" lang="en-US" sz="1600" b="0" i="0" u="none" strike="noStrike" kern="1200" cap="none" spc="0" normalizeH="0" baseline="0" noProof="0" dirty="0" err="1">
+                <a:ln>
+                  <a:noFill/>
+                </a:ln>
+                <a:solidFill>
+                  <a:prstClr val="white"/>
+                </a:solidFill>
+                <a:effectLst/>
+                <a:uLnTx/>
+                <a:uFillTx/>
+                <a:latin typeface="Calibri" panose="020F0502020204030204"/>
+                <a:ea typeface="+mn-ea"/>
+                <a:cs typeface="+mn-cs"/>
+              </a:rPr>
+              <a:t>Lienard</a:t>
+            </a:r>
+            <a:r>
+              <a:rPr kumimoji="0" lang="en-US" sz="1600" b="0" i="0" u="none" strike="noStrike" kern="1200" cap="none" spc="0" normalizeH="0" baseline="0" noProof="0" dirty="0">
+                <a:ln>
+                  <a:noFill/>
+                </a:ln>
+                <a:solidFill>
+                  <a:prstClr val="white"/>
+                </a:solidFill>
+                <a:effectLst/>
+                <a:uLnTx/>
+                <a:uFillTx/>
+                <a:latin typeface="Calibri" panose="020F0502020204030204"/>
+                <a:ea typeface="+mn-ea"/>
+                <a:cs typeface="+mn-cs"/>
+              </a:rPr>
+              <a:t>/</a:t>
+            </a:r>
+            <a:r>
+              <a:rPr kumimoji="0" lang="en-US" sz="1600" b="0" i="0" u="none" strike="noStrike" kern="1200" cap="none" spc="0" normalizeH="0" baseline="0" noProof="0" dirty="0" err="1">
+                <a:ln>
+                  <a:noFill/>
+                </a:ln>
+                <a:solidFill>
+                  <a:prstClr val="white"/>
+                </a:solidFill>
+                <a:effectLst/>
+                <a:uLnTx/>
+                <a:uFillTx/>
+                <a:latin typeface="Calibri" panose="020F0502020204030204"/>
+                <a:ea typeface="+mn-ea"/>
+                <a:cs typeface="+mn-cs"/>
+              </a:rPr>
+              <a:t>Wiechert</a:t>
+            </a:r>
+            <a:r>
+              <a:rPr kumimoji="0" lang="en-US" sz="1600" b="0" i="0" u="none" strike="noStrike" kern="1200" cap="none" spc="0" normalizeH="0" baseline="0" noProof="0" dirty="0">
+                <a:ln>
+                  <a:noFill/>
+                </a:ln>
+                <a:solidFill>
+                  <a:prstClr val="white"/>
+                </a:solidFill>
+                <a:effectLst/>
+                <a:uLnTx/>
+                <a:uFillTx/>
+                <a:latin typeface="Calibri" panose="020F0502020204030204"/>
+                <a:ea typeface="+mn-ea"/>
+                <a:cs typeface="+mn-cs"/>
+              </a:rPr>
+              <a:t>/</a:t>
+            </a:r>
+            <a:r>
+              <a:rPr kumimoji="0" lang="en-US" sz="1600" b="0" i="0" u="none" strike="noStrike" kern="1200" cap="none" spc="0" normalizeH="0" baseline="0" noProof="0" dirty="0" err="1">
+                <a:ln>
+                  <a:noFill/>
+                </a:ln>
+                <a:solidFill>
+                  <a:prstClr val="white"/>
+                </a:solidFill>
+                <a:effectLst/>
+                <a:uLnTx/>
+                <a:uFillTx/>
+                <a:latin typeface="Calibri" panose="020F0502020204030204"/>
+                <a:ea typeface="+mn-ea"/>
+                <a:cs typeface="+mn-cs"/>
+              </a:rPr>
+              <a:t>Jeffimenko</a:t>
+            </a:r>
+            <a:r>
+              <a:rPr kumimoji="0" lang="en-US" sz="1600" b="0" i="0" u="none" strike="noStrike" kern="1200" cap="none" spc="0" normalizeH="0" baseline="0" noProof="0" dirty="0">
+                <a:ln>
+                  <a:noFill/>
+                </a:ln>
+                <a:solidFill>
+                  <a:prstClr val="white"/>
+                </a:solidFill>
+                <a:effectLst/>
+                <a:uLnTx/>
+                <a:uFillTx/>
+                <a:latin typeface="Calibri" panose="020F0502020204030204"/>
+                <a:ea typeface="+mn-ea"/>
+                <a:cs typeface="+mn-cs"/>
+              </a:rPr>
+              <a:t> math. Not sure yet. </a:t>
+            </a:r>
+          </a:p>
+          <a:p>
+            <a:pPr marL="0" marR="0" lvl="0" indent="0" algn="l" defTabSz="914400" rtl="0" eaLnBrk="1" fontAlgn="auto" latinLnBrk="0" hangingPunct="1">
+              <a:lnSpc>
+                <a:spcPct val="100000"/>
+              </a:lnSpc>
+              <a:spcBef>
+                <a:spcPts val="0"/>
+              </a:spcBef>
+              <a:spcAft>
+                <a:spcPts val="0"/>
+              </a:spcAft>
+              <a:buClrTx/>
+              <a:buSzTx/>
+              <a:buFontTx/>
+              <a:buNone/>
+              <a:tabLst/>
+              <a:defRPr/>
+            </a:pPr>
+            <a:r>
+              <a:rPr kumimoji="0" lang="en-US" sz="1600" b="0" i="0" u="none" strike="noStrike" kern="1200" cap="none" spc="0" normalizeH="0" baseline="0" noProof="0" dirty="0">
+                <a:ln>
+                  <a:noFill/>
+                </a:ln>
+                <a:solidFill>
+                  <a:prstClr val="white"/>
+                </a:solidFill>
+                <a:effectLst/>
+                <a:uLnTx/>
+                <a:uFillTx/>
+                <a:latin typeface="Calibri" panose="020F0502020204030204"/>
+                <a:ea typeface="+mn-ea"/>
+                <a:cs typeface="+mn-cs"/>
+              </a:rPr>
+              <a:t>6. Let's use the term potential sphere stream to describe each point potential emitting a stream of expanding spherical potentials. The stream also encodes the velocity of the emitting point potential, by nature of the moving origin. </a:t>
+            </a:r>
+          </a:p>
+          <a:p>
+            <a:pPr marL="0" marR="0" lvl="0" indent="0" algn="l" defTabSz="914400" rtl="0" eaLnBrk="1" fontAlgn="auto" latinLnBrk="0" hangingPunct="1">
+              <a:lnSpc>
+                <a:spcPct val="100000"/>
+              </a:lnSpc>
+              <a:spcBef>
+                <a:spcPts val="0"/>
+              </a:spcBef>
+              <a:spcAft>
+                <a:spcPts val="0"/>
+              </a:spcAft>
+              <a:buClrTx/>
+              <a:buSzTx/>
+              <a:buFontTx/>
+              <a:buNone/>
+              <a:tabLst/>
+              <a:defRPr/>
+            </a:pPr>
+            <a:r>
+              <a:rPr kumimoji="0" lang="en-US" sz="1600" b="0" i="0" u="none" strike="noStrike" kern="1200" cap="none" spc="0" normalizeH="0" baseline="0" noProof="0" dirty="0">
+                <a:ln>
+                  <a:noFill/>
+                </a:ln>
+                <a:solidFill>
+                  <a:prstClr val="white"/>
+                </a:solidFill>
+                <a:effectLst/>
+                <a:uLnTx/>
+                <a:uFillTx/>
+                <a:latin typeface="Calibri" panose="020F0502020204030204"/>
+                <a:ea typeface="+mn-ea"/>
+                <a:cs typeface="+mn-cs"/>
+              </a:rPr>
+              <a:t>7. When the potential sphere emitted at T0 arrives, in the potential sphere stream from A, then action will occur and the path of B will be impacted. But B is also emitting a potential sphere stream that impacts A after the travel time delay. So there is a feedback cycle with a variable delay that is dependent on both A and B's path.</a:t>
+            </a:r>
+          </a:p>
+          <a:p>
+            <a:pPr marL="0" marR="0" lvl="0" indent="0" algn="l" defTabSz="914400" rtl="0" eaLnBrk="1" fontAlgn="auto" latinLnBrk="0" hangingPunct="1">
+              <a:lnSpc>
+                <a:spcPct val="100000"/>
+              </a:lnSpc>
+              <a:spcBef>
+                <a:spcPts val="0"/>
+              </a:spcBef>
+              <a:spcAft>
+                <a:spcPts val="0"/>
+              </a:spcAft>
+              <a:buClrTx/>
+              <a:buSzTx/>
+              <a:buFontTx/>
+              <a:buNone/>
+              <a:tabLst/>
+              <a:defRPr/>
+            </a:pPr>
+            <a:r>
+              <a:rPr kumimoji="0" lang="en-US" sz="1600" b="0" i="0" u="none" strike="noStrike" kern="1200" cap="none" spc="0" normalizeH="0" baseline="0" noProof="0" dirty="0">
+                <a:ln>
+                  <a:noFill/>
+                </a:ln>
+                <a:solidFill>
+                  <a:prstClr val="white"/>
+                </a:solidFill>
+                <a:effectLst/>
+                <a:uLnTx/>
+                <a:uFillTx/>
+                <a:latin typeface="Calibri" panose="020F0502020204030204"/>
+                <a:ea typeface="+mn-ea"/>
+                <a:cs typeface="+mn-cs"/>
+              </a:rPr>
+              <a:t>8. I was just thinking the other day how to enhance the picture to show the continuous potential sphere streams from A passing B and causing action, and vice versa. I'd like to somehow capture this dynamic feedback cycle. </a:t>
+            </a:r>
+          </a:p>
+          <a:p>
+            <a:pPr marL="0" marR="0" lvl="0" indent="0" algn="l" defTabSz="914400" rtl="0" eaLnBrk="1" fontAlgn="auto" latinLnBrk="0" hangingPunct="1">
+              <a:lnSpc>
+                <a:spcPct val="100000"/>
+              </a:lnSpc>
+              <a:spcBef>
+                <a:spcPts val="0"/>
+              </a:spcBef>
+              <a:spcAft>
+                <a:spcPts val="0"/>
+              </a:spcAft>
+              <a:buClrTx/>
+              <a:buSzTx/>
+              <a:buFontTx/>
+              <a:buNone/>
+              <a:tabLst/>
+              <a:defRPr/>
+            </a:pPr>
+            <a:r>
+              <a:rPr kumimoji="0" lang="en-US" sz="1600" b="0" i="0" u="none" strike="noStrike" kern="1200" cap="none" spc="0" normalizeH="0" baseline="0" noProof="0" dirty="0">
+                <a:ln>
+                  <a:noFill/>
+                </a:ln>
+                <a:solidFill>
+                  <a:prstClr val="white"/>
+                </a:solidFill>
+                <a:effectLst/>
+                <a:uLnTx/>
+                <a:uFillTx/>
+                <a:latin typeface="Calibri" panose="020F0502020204030204"/>
+                <a:ea typeface="+mn-ea"/>
+                <a:cs typeface="+mn-cs"/>
+              </a:rPr>
+              <a:t>9. I think there is probably some incredible math just in this interaction. I don't know if that math has already been done. Perhaps.  I doubt anyone has considered the case when point potential velocity equals or exceeds field speed. That is an unexplored regime.  </a:t>
+            </a:r>
+          </a:p>
+          <a:p>
+            <a:pPr marL="0" marR="0" lvl="0" indent="0" algn="l" defTabSz="914400" rtl="0" eaLnBrk="1" fontAlgn="auto" latinLnBrk="0" hangingPunct="1">
+              <a:lnSpc>
+                <a:spcPct val="100000"/>
+              </a:lnSpc>
+              <a:spcBef>
+                <a:spcPts val="0"/>
+              </a:spcBef>
+              <a:spcAft>
+                <a:spcPts val="0"/>
+              </a:spcAft>
+              <a:buClrTx/>
+              <a:buSzTx/>
+              <a:buFontTx/>
+              <a:buNone/>
+              <a:tabLst/>
+              <a:defRPr/>
+            </a:pPr>
+            <a:endParaRPr kumimoji="0" lang="en-US" sz="1600" b="0" i="0" u="none" strike="noStrike" kern="1200" cap="none" spc="0" normalizeH="0" baseline="0" noProof="0" dirty="0">
+              <a:ln>
+                <a:noFill/>
+              </a:ln>
+              <a:solidFill>
+                <a:prstClr val="white"/>
+              </a:solidFill>
+              <a:effectLst/>
+              <a:uLnTx/>
+              <a:uFillTx/>
+              <a:latin typeface="Calibri" panose="020F0502020204030204"/>
+              <a:ea typeface="+mn-ea"/>
+              <a:cs typeface="+mn-cs"/>
+            </a:endParaRPr>
+          </a:p>
+          <a:p>
+            <a:pPr marL="0" marR="0" lvl="0" indent="0" algn="l" defTabSz="914400" rtl="0" eaLnBrk="1" fontAlgn="auto" latinLnBrk="0" hangingPunct="1">
+              <a:lnSpc>
+                <a:spcPct val="100000"/>
+              </a:lnSpc>
+              <a:spcBef>
+                <a:spcPts val="0"/>
+              </a:spcBef>
+              <a:spcAft>
+                <a:spcPts val="0"/>
+              </a:spcAft>
+              <a:buClrTx/>
+              <a:buSzTx/>
+              <a:buFontTx/>
+              <a:buNone/>
+              <a:tabLst/>
+              <a:defRPr/>
+            </a:pPr>
+            <a:r>
+              <a:rPr kumimoji="0" lang="en-US" sz="1600" b="0" i="0" u="none" strike="noStrike" kern="1200" cap="none" spc="0" normalizeH="0" baseline="0" noProof="0" dirty="0">
+                <a:ln>
+                  <a:noFill/>
+                </a:ln>
+                <a:solidFill>
+                  <a:prstClr val="white"/>
+                </a:solidFill>
+                <a:effectLst/>
+                <a:uLnTx/>
+                <a:uFillTx/>
+                <a:latin typeface="Calibri" panose="020F0502020204030204"/>
+                <a:ea typeface="+mn-ea"/>
+                <a:cs typeface="+mn-cs"/>
+              </a:rPr>
+              <a:t>My recommendation is to use your imagination to visualize the dynamical geometry and the potential sphere streams and the paths.  For me that leads to a lot of insight.   </a:t>
+            </a:r>
+          </a:p>
+        </p:txBody>
+      </p:sp>
+    </p:spTree>
+    <p:extLst>
+      <p:ext uri="{BB962C8B-B14F-4D97-AF65-F5344CB8AC3E}">
+        <p14:creationId xmlns:p14="http://schemas.microsoft.com/office/powerpoint/2010/main" val="4219678445"/>
+      </p:ext>
+    </p:extLst>
+  </p:cSld>
+  <p:clrMapOvr>
+    <a:masterClrMapping/>
+  </p:clrMapOvr>
+</p:sld>
+</file>
+
 <file path=ppt/theme/theme1.xml><?xml version="1.0" encoding="utf-8"?>
 <a:theme xmlns:a="http://schemas.openxmlformats.org/drawingml/2006/main" name="Office Theme">
   <a:themeElements>
@@ -37574,334 +35986,6 @@
 </file>
 
 <file path=ppt/theme/theme2.xml><?xml version="1.0" encoding="utf-8"?>
-<a:theme xmlns:a="http://schemas.openxmlformats.org/drawingml/2006/main" name="2_Office Theme">
-  <a:themeElements>
-    <a:clrScheme name="Office">
-      <a:dk1>
-        <a:sysClr val="windowText" lastClr="000000"/>
-      </a:dk1>
-      <a:lt1>
-        <a:sysClr val="window" lastClr="FFFFFF"/>
-      </a:lt1>
-      <a:dk2>
-        <a:srgbClr val="44546A"/>
-      </a:dk2>
-      <a:lt2>
-        <a:srgbClr val="E7E6E6"/>
-      </a:lt2>
-      <a:accent1>
-        <a:srgbClr val="4472C4"/>
-      </a:accent1>
-      <a:accent2>
-        <a:srgbClr val="ED7D31"/>
-      </a:accent2>
-      <a:accent3>
-        <a:srgbClr val="A5A5A5"/>
-      </a:accent3>
-      <a:accent4>
-        <a:srgbClr val="FFC000"/>
-      </a:accent4>
-      <a:accent5>
-        <a:srgbClr val="5B9BD5"/>
-      </a:accent5>
-      <a:accent6>
-        <a:srgbClr val="70AD47"/>
-      </a:accent6>
-      <a:hlink>
-        <a:srgbClr val="0563C1"/>
-      </a:hlink>
-      <a:folHlink>
-        <a:srgbClr val="954F72"/>
-      </a:folHlink>
-    </a:clrScheme>
-    <a:fontScheme name="Office">
-      <a:majorFont>
-        <a:latin typeface="Calibri Light" panose="020F0302020204030204"/>
-        <a:ea typeface=""/>
-        <a:cs typeface=""/>
-        <a:font script="Jpan" typeface="游ゴシック Light"/>
-        <a:font script="Hang" typeface="맑은 고딕"/>
-        <a:font script="Hans" typeface="等线 Light"/>
-        <a:font script="Hant" typeface="新細明體"/>
-        <a:font script="Arab" typeface="Times New Roman"/>
-        <a:font script="Hebr" typeface="Times New Roman"/>
-        <a:font script="Thai" typeface="Angsana New"/>
-        <a:font script="Ethi" typeface="Nyala"/>
-        <a:font script="Beng" typeface="Vrinda"/>
-        <a:font script="Gujr" typeface="Shruti"/>
-        <a:font script="Khmr" typeface="MoolBoran"/>
-        <a:font script="Knda" typeface="Tunga"/>
-        <a:font script="Guru" typeface="Raavi"/>
-        <a:font script="Cans" typeface="Euphemia"/>
-        <a:font script="Cher" typeface="Plantagenet Cherokee"/>
-        <a:font script="Yiii" typeface="Microsoft Yi Baiti"/>
-        <a:font script="Tibt" typeface="Microsoft Himalaya"/>
-        <a:font script="Thaa" typeface="MV Boli"/>
-        <a:font script="Deva" typeface="Mangal"/>
-        <a:font script="Telu" typeface="Gautami"/>
-        <a:font script="Taml" typeface="Latha"/>
-        <a:font script="Syrc" typeface="Estrangelo Edessa"/>
-        <a:font script="Orya" typeface="Kalinga"/>
-        <a:font script="Mlym" typeface="Kartika"/>
-        <a:font script="Laoo" typeface="DokChampa"/>
-        <a:font script="Sinh" typeface="Iskoola Pota"/>
-        <a:font script="Mong" typeface="Mongolian Baiti"/>
-        <a:font script="Viet" typeface="Times New Roman"/>
-        <a:font script="Uigh" typeface="Microsoft Uighur"/>
-        <a:font script="Geor" typeface="Sylfaen"/>
-        <a:font script="Armn" typeface="Arial"/>
-        <a:font script="Bugi" typeface="Leelawadee UI"/>
-        <a:font script="Bopo" typeface="Microsoft JhengHei"/>
-        <a:font script="Java" typeface="Javanese Text"/>
-        <a:font script="Lisu" typeface="Segoe UI"/>
-        <a:font script="Mymr" typeface="Myanmar Text"/>
-        <a:font script="Nkoo" typeface="Ebrima"/>
-        <a:font script="Olck" typeface="Nirmala UI"/>
-        <a:font script="Osma" typeface="Ebrima"/>
-        <a:font script="Phag" typeface="Phagspa"/>
-        <a:font script="Syrn" typeface="Estrangelo Edessa"/>
-        <a:font script="Syrj" typeface="Estrangelo Edessa"/>
-        <a:font script="Syre" typeface="Estrangelo Edessa"/>
-        <a:font script="Sora" typeface="Nirmala UI"/>
-        <a:font script="Tale" typeface="Microsoft Tai Le"/>
-        <a:font script="Talu" typeface="Microsoft New Tai Lue"/>
-        <a:font script="Tfng" typeface="Ebrima"/>
-      </a:majorFont>
-      <a:minorFont>
-        <a:latin typeface="Calibri" panose="020F0502020204030204"/>
-        <a:ea typeface=""/>
-        <a:cs typeface=""/>
-        <a:font script="Jpan" typeface="游ゴシック"/>
-        <a:font script="Hang" typeface="맑은 고딕"/>
-        <a:font script="Hans" typeface="等线"/>
-        <a:font script="Hant" typeface="新細明體"/>
-        <a:font script="Arab" typeface="Arial"/>
-        <a:font script="Hebr" typeface="Arial"/>
-        <a:font script="Thai" typeface="Cordia New"/>
-        <a:font script="Ethi" typeface="Nyala"/>
-        <a:font script="Beng" typeface="Vrinda"/>
-        <a:font script="Gujr" typeface="Shruti"/>
-        <a:font script="Khmr" typeface="DaunPenh"/>
-        <a:font script="Knda" typeface="Tunga"/>
-        <a:font script="Guru" typeface="Raavi"/>
-        <a:font script="Cans" typeface="Euphemia"/>
-        <a:font script="Cher" typeface="Plantagenet Cherokee"/>
-        <a:font script="Yiii" typeface="Microsoft Yi Baiti"/>
-        <a:font script="Tibt" typeface="Microsoft Himalaya"/>
-        <a:font script="Thaa" typeface="MV Boli"/>
-        <a:font script="Deva" typeface="Mangal"/>
-        <a:font script="Telu" typeface="Gautami"/>
-        <a:font script="Taml" typeface="Latha"/>
-        <a:font script="Syrc" typeface="Estrangelo Edessa"/>
-        <a:font script="Orya" typeface="Kalinga"/>
-        <a:font script="Mlym" typeface="Kartika"/>
-        <a:font script="Laoo" typeface="DokChampa"/>
-        <a:font script="Sinh" typeface="Iskoola Pota"/>
-        <a:font script="Mong" typeface="Mongolian Baiti"/>
-        <a:font script="Viet" typeface="Arial"/>
-        <a:font script="Uigh" typeface="Microsoft Uighur"/>
-        <a:font script="Geor" typeface="Sylfaen"/>
-        <a:font script="Armn" typeface="Arial"/>
-        <a:font script="Bugi" typeface="Leelawadee UI"/>
-        <a:font script="Bopo" typeface="Microsoft JhengHei"/>
-        <a:font script="Java" typeface="Javanese Text"/>
-        <a:font script="Lisu" typeface="Segoe UI"/>
-        <a:font script="Mymr" typeface="Myanmar Text"/>
-        <a:font script="Nkoo" typeface="Ebrima"/>
-        <a:font script="Olck" typeface="Nirmala UI"/>
-        <a:font script="Osma" typeface="Ebrima"/>
-        <a:font script="Phag" typeface="Phagspa"/>
-        <a:font script="Syrn" typeface="Estrangelo Edessa"/>
-        <a:font script="Syrj" typeface="Estrangelo Edessa"/>
-        <a:font script="Syre" typeface="Estrangelo Edessa"/>
-        <a:font script="Sora" typeface="Nirmala UI"/>
-        <a:font script="Tale" typeface="Microsoft Tai Le"/>
-        <a:font script="Talu" typeface="Microsoft New Tai Lue"/>
-        <a:font script="Tfng" typeface="Ebrima"/>
-      </a:minorFont>
-    </a:fontScheme>
-    <a:fmtScheme name="Office">
-      <a:fillStyleLst>
-        <a:solidFill>
-          <a:schemeClr val="phClr"/>
-        </a:solidFill>
-        <a:gradFill rotWithShape="1">
-          <a:gsLst>
-            <a:gs pos="0">
-              <a:schemeClr val="phClr">
-                <a:lumMod val="110000"/>
-                <a:satMod val="105000"/>
-                <a:tint val="67000"/>
-              </a:schemeClr>
-            </a:gs>
-            <a:gs pos="50000">
-              <a:schemeClr val="phClr">
-                <a:lumMod val="105000"/>
-                <a:satMod val="103000"/>
-                <a:tint val="73000"/>
-              </a:schemeClr>
-            </a:gs>
-            <a:gs pos="100000">
-              <a:schemeClr val="phClr">
-                <a:lumMod val="105000"/>
-                <a:satMod val="109000"/>
-                <a:tint val="81000"/>
-              </a:schemeClr>
-            </a:gs>
-          </a:gsLst>
-          <a:lin ang="5400000" scaled="0"/>
-        </a:gradFill>
-        <a:gradFill rotWithShape="1">
-          <a:gsLst>
-            <a:gs pos="0">
-              <a:schemeClr val="phClr">
-                <a:satMod val="103000"/>
-                <a:lumMod val="102000"/>
-                <a:tint val="94000"/>
-              </a:schemeClr>
-            </a:gs>
-            <a:gs pos="50000">
-              <a:schemeClr val="phClr">
-                <a:satMod val="110000"/>
-                <a:lumMod val="100000"/>
-                <a:shade val="100000"/>
-              </a:schemeClr>
-            </a:gs>
-            <a:gs pos="100000">
-              <a:schemeClr val="phClr">
-                <a:lumMod val="99000"/>
-                <a:satMod val="120000"/>
-                <a:shade val="78000"/>
-              </a:schemeClr>
-            </a:gs>
-          </a:gsLst>
-          <a:lin ang="5400000" scaled="0"/>
-        </a:gradFill>
-      </a:fillStyleLst>
-      <a:lnStyleLst>
-        <a:ln w="6350" cap="flat" cmpd="sng" algn="ctr">
-          <a:solidFill>
-            <a:schemeClr val="phClr"/>
-          </a:solidFill>
-          <a:prstDash val="solid"/>
-          <a:miter lim="800000"/>
-        </a:ln>
-        <a:ln w="12700" cap="flat" cmpd="sng" algn="ctr">
-          <a:solidFill>
-            <a:schemeClr val="phClr"/>
-          </a:solidFill>
-          <a:prstDash val="solid"/>
-          <a:miter lim="800000"/>
-        </a:ln>
-        <a:ln w="19050" cap="flat" cmpd="sng" algn="ctr">
-          <a:solidFill>
-            <a:schemeClr val="phClr"/>
-          </a:solidFill>
-          <a:prstDash val="solid"/>
-          <a:miter lim="800000"/>
-        </a:ln>
-      </a:lnStyleLst>
-      <a:effectStyleLst>
-        <a:effectStyle>
-          <a:effectLst/>
-        </a:effectStyle>
-        <a:effectStyle>
-          <a:effectLst/>
-        </a:effectStyle>
-        <a:effectStyle>
-          <a:effectLst>
-            <a:outerShdw blurRad="57150" dist="19050" dir="5400000" algn="ctr" rotWithShape="0">
-              <a:srgbClr val="000000">
-                <a:alpha val="63000"/>
-              </a:srgbClr>
-            </a:outerShdw>
-          </a:effectLst>
-        </a:effectStyle>
-      </a:effectStyleLst>
-      <a:bgFillStyleLst>
-        <a:solidFill>
-          <a:schemeClr val="phClr"/>
-        </a:solidFill>
-        <a:solidFill>
-          <a:schemeClr val="phClr">
-            <a:tint val="95000"/>
-            <a:satMod val="170000"/>
-          </a:schemeClr>
-        </a:solidFill>
-        <a:gradFill rotWithShape="1">
-          <a:gsLst>
-            <a:gs pos="0">
-              <a:schemeClr val="phClr">
-                <a:tint val="93000"/>
-                <a:satMod val="150000"/>
-                <a:shade val="98000"/>
-                <a:lumMod val="102000"/>
-              </a:schemeClr>
-            </a:gs>
-            <a:gs pos="50000">
-              <a:schemeClr val="phClr">
-                <a:tint val="98000"/>
-                <a:satMod val="130000"/>
-                <a:shade val="90000"/>
-                <a:lumMod val="103000"/>
-              </a:schemeClr>
-            </a:gs>
-            <a:gs pos="100000">
-              <a:schemeClr val="phClr">
-                <a:shade val="63000"/>
-                <a:satMod val="120000"/>
-              </a:schemeClr>
-            </a:gs>
-          </a:gsLst>
-          <a:lin ang="5400000" scaled="0"/>
-        </a:gradFill>
-      </a:bgFillStyleLst>
-    </a:fmtScheme>
-  </a:themeElements>
-  <a:objectDefaults>
-    <a:spDef>
-      <a:spPr/>
-      <a:bodyPr wrap="none">
-        <a:spAutoFit/>
-      </a:bodyPr>
-      <a:lstStyle>
-        <a:defPPr algn="l">
-          <a:defRPr sz="2400" dirty="0" smtClean="0">
-            <a:latin typeface="Helvetica Neue" panose="02000503000000020004" pitchFamily="2" charset="0"/>
-            <a:ea typeface="Helvetica Neue" panose="02000503000000020004" pitchFamily="2" charset="0"/>
-            <a:cs typeface="Helvetica Neue" panose="02000503000000020004" pitchFamily="2" charset="0"/>
-          </a:defRPr>
-        </a:defPPr>
-      </a:lstStyle>
-    </a:spDef>
-    <a:txDef>
-      <a:spPr>
-        <a:noFill/>
-      </a:spPr>
-      <a:bodyPr wrap="none" rtlCol="0">
-        <a:spAutoFit/>
-      </a:bodyPr>
-      <a:lstStyle>
-        <a:defPPr algn="l">
-          <a:defRPr dirty="0" smtClean="0">
-            <a:latin typeface="Helvetica Neue" panose="02000503000000020004" pitchFamily="2" charset="0"/>
-            <a:ea typeface="Helvetica Neue" panose="02000503000000020004" pitchFamily="2" charset="0"/>
-            <a:cs typeface="Helvetica Neue" panose="02000503000000020004" pitchFamily="2" charset="0"/>
-          </a:defRPr>
-        </a:defPPr>
-      </a:lstStyle>
-    </a:txDef>
-  </a:objectDefaults>
-  <a:extraClrSchemeLst/>
-  <a:extLst>
-    <a:ext uri="{05A4C25C-085E-4340-85A3-A5531E510DB2}">
-      <thm15:themeFamily xmlns:thm15="http://schemas.microsoft.com/office/thememl/2012/main" name="Office Theme" id="{62F939B6-93AF-4DB8-9C6B-D6C7DFDC589F}" vid="{4A3C46E8-61CC-4603-A589-7422A47A8E4A}"/>
-    </a:ext>
-  </a:extLst>
-</a:theme>
-</file>
-
-<file path=ppt/theme/theme3.xml><?xml version="1.0" encoding="utf-8"?>
 <a:theme xmlns:a="http://schemas.openxmlformats.org/drawingml/2006/main" name="Office Theme">
   <a:themeElements>
     <a:clrScheme name="Office">

</xml_diff>